<commit_message>
Each simulated household stands for 8 real ones; diet-plan flag and count on the board; deck with the diet slide
Co-Authored-By: Claude Fable 5.1 <noreply@anthropic.com>
</commit_message>
<xml_diff>
--- a/docs/Gridzilla-pitch.pptx
+++ b/docs/Gridzilla-pitch.pptx
@@ -17,9 +17,10 @@
     <p:sldId id="265" r:id="rId11"/>
     <p:sldId id="266" r:id="rId12"/>
     <p:sldId id="267" r:id="rId13"/>
+    <p:sldId id="268" r:id="rId14"/>
   </p:sldIdLst>
   <p:notesMasterIdLst>
-    <p:notesMasterId r:id="rId14"/>
+    <p:notesMasterId r:id="rId15"/>
   </p:notesMasterIdLst>
   <p:sldSz cx="12192000" cy="6858000"/>
   <p:notesSz cx="6858000" cy="12192000"/>
@@ -118,44 +119,45 @@
   <p:extLst>
     <p:ext uri="{521415D9-36F7-43E2-AB2F-B90AF26B5E84}">
       <p14:sectionLst xmlns:p14="http://schemas.microsoft.com/office/powerpoint/2010/main">
-        <p14:section name="Opening" id="{f7c55e97-c2f8-d12f-29af-a65bdad8d848}">
+        <p14:section name="Opening" id="{03a1f20a-a530-3246-372e-916cd8c427f5}">
           <p14:sldIdLst>
             <p14:sldId id="256"/>
           </p14:sldIdLst>
         </p14:section>
-        <p14:section name="Why" id="{ec73b804-9d14-482e-ad72-e641fbf31c7e}">
+        <p14:section name="Why" id="{2b3c7dee-e08f-87c8-bce0-c7cb8df5915e}">
           <p14:sldIdLst>
             <p14:sldId id="257"/>
           </p14:sldIdLst>
         </p14:section>
-        <p14:section name="What" id="{1e6f71cd-2ff7-67d4-292c-cc4db06bdb95}">
+        <p14:section name="What" id="{ec1f621f-9133-c13c-1c53-2b7a1c4645b6}">
           <p14:sldIdLst>
             <p14:sldId id="258"/>
             <p14:sldId id="259"/>
             <p14:sldId id="260"/>
           </p14:sldIdLst>
         </p14:section>
-        <p14:section name="How" id="{9f043683-91cd-8fd0-a540-36c011b0933d}">
+        <p14:section name="How" id="{2bae2ec4-3cfc-5a13-b405-fff4932a250a}">
           <p14:sldIdLst>
             <p14:sldId id="261"/>
             <p14:sldId id="262"/>
-          </p14:sldIdLst>
-        </p14:section>
-        <p14:section name="Demo" id="{43038152-1179-0246-1c2a-6ad2e380c476}">
-          <p14:sldIdLst>
             <p14:sldId id="263"/>
           </p14:sldIdLst>
         </p14:section>
-        <p14:section name="Built" id="{24c47211-dc93-17e1-0c98-9502e293cc8c}">
+        <p14:section name="Demo" id="{756e8f4f-978f-c31d-50a6-39fc41a0b06b}">
           <p14:sldIdLst>
             <p14:sldId id="264"/>
+          </p14:sldIdLst>
+        </p14:section>
+        <p14:section name="Built" id="{2a25aba1-4839-b487-8f04-81df96ea01d0}">
+          <p14:sldIdLst>
             <p14:sldId id="265"/>
             <p14:sldId id="266"/>
+            <p14:sldId id="267"/>
           </p14:sldIdLst>
         </p14:section>
-        <p14:section name="Close" id="{efe6393c-b81c-77e2-38b8-1885a49d1678}">
+        <p14:section name="Close" id="{eac0673b-4837-7543-1863-9d306b8faa6c}">
           <p14:sldIdLst>
-            <p14:sldId id="267"/>
+            <p14:sldId id="268"/>
           </p14:sldIdLst>
         </p14:section>
       </p14:sectionLst>
@@ -650,7 +652,7 @@
           <a:p>
             <a:r>
               <a:rPr lang="en-US" dirty="0"/>
-              <a:t>12:30-13:30. Six controls, then the two gaps yourself. A juror who finds a gap you named is on your side.</a:t>
+              <a:t>11:30-12:30. The point of this slide is credibility: nothing is a mock-up. Name the two real devices and the public broker.</a:t>
             </a:r>
             <a:endParaRPr lang="en-US" dirty="0"/>
           </a:p>
@@ -738,7 +740,7 @@
           <a:p>
             <a:r>
               <a:rPr lang="en-US" dirty="0"/>
-              <a:t>13:30-14:30. Left: vendor independence is proven by the simulators, which run no Victron code. Right: the economics in two sentences, pay on the meter and the dynamic connection.</a:t>
+              <a:t>12:30-13:30. Six controls, then the two gaps yourself. A juror who finds a gap you named is on your side.</a:t>
             </a:r>
             <a:endParaRPr lang="en-US" dirty="0"/>
           </a:p>
@@ -826,7 +828,7 @@
           <a:p>
             <a:r>
               <a:rPr lang="en-US" dirty="0"/>
-              <a:t>14:30-15:00. The ask is a transformer to pilot on. Stop talking, take questions.</a:t>
+              <a:t>13:30-14:30. Left: vendor independence is proven by the simulators, which run no Victron code. Right: the economics in two sentences, pay on the meter and the dynamic connection.</a:t>
             </a:r>
             <a:endParaRPr lang="en-US" dirty="0"/>
           </a:p>
@@ -850,6 +852,94 @@
             <a:fld id="{F7021451-1387-4CA6-816F-3879F97B5CBC}" type="slidenum">
               <a:rPr lang="en-US"/>
               <a:t>12</a:t>
+            </a:fld>
+            <a:endParaRPr lang="en-US"/>
+          </a:p>
+        </p:txBody>
+      </p:sp>
+    </p:spTree>
+    <p:extLst>
+      <p:ext uri="{BB962C8B-B14F-4D97-AF65-F5344CB8AC3E}">
+        <p14:creationId xmlns:p14="http://schemas.microsoft.com/office/powerpoint/2010/main" val="1024086991"/>
+      </p:ext>
+    </p:extLst>
+  </p:cSld>
+  <p:clrMapOvr>
+    <a:masterClrMapping/>
+  </p:clrMapOvr>
+</p:notes>
+</file>
+
+<file path=ppt/notesSlides/notesSlide13.xml><?xml version="1.0" encoding="utf-8"?>
+<p:notes xmlns:a="http://schemas.openxmlformats.org/drawingml/2006/main" xmlns:r="http://schemas.openxmlformats.org/officeDocument/2006/relationships" xmlns:p="http://schemas.openxmlformats.org/presentationml/2006/main">
+  <p:cSld>
+    <p:spTree>
+      <p:nvGrpSpPr>
+        <p:cNvPr id="1" name=""/>
+        <p:cNvGrpSpPr/>
+        <p:nvPr/>
+      </p:nvGrpSpPr>
+      <p:grpSpPr>
+        <a:xfrm>
+          <a:off x="0" y="0"/>
+          <a:ext cx="0" cy="0"/>
+          <a:chOff x="0" y="0"/>
+          <a:chExt cx="0" cy="0"/>
+        </a:xfrm>
+      </p:grpSpPr>
+      <p:sp>
+        <p:nvSpPr>
+          <p:cNvPr id="2" name="Slide Image Placeholder 1"/>
+          <p:cNvSpPr>
+            <a:spLocks noGrp="1" noRot="1" noChangeAspect="1"/>
+          </p:cNvSpPr>
+          <p:nvPr>
+            <p:ph type="sldImg"/>
+          </p:nvPr>
+        </p:nvSpPr>
+        <p:spPr/>
+      </p:sp>
+      <p:sp>
+        <p:nvSpPr>
+          <p:cNvPr id="3" name="Notes Placeholder 2"/>
+          <p:cNvSpPr>
+            <a:spLocks noGrp="1"/>
+          </p:cNvSpPr>
+          <p:nvPr>
+            <p:ph type="body" idx="1"/>
+          </p:nvPr>
+        </p:nvSpPr>
+        <p:spPr/>
+        <p:txBody>
+          <a:bodyPr/>
+          <a:lstStyle/>
+          <a:p>
+            <a:r>
+              <a:rPr lang="en-US" dirty="0"/>
+              <a:t>14:30-15:00. The ask is a transformer to pilot on. Stop talking, take questions.</a:t>
+            </a:r>
+            <a:endParaRPr lang="en-US" dirty="0"/>
+          </a:p>
+        </p:txBody>
+      </p:sp>
+      <p:sp>
+        <p:nvSpPr>
+          <p:cNvPr id="4" name="Slide Number Placeholder 3"/>
+          <p:cNvSpPr>
+            <a:spLocks noGrp="1"/>
+          </p:cNvSpPr>
+          <p:nvPr>
+            <p:ph type="sldNum" sz="quarter" idx="10"/>
+          </p:nvPr>
+        </p:nvSpPr>
+        <p:spPr/>
+        <p:txBody>
+          <a:bodyPr/>
+          <a:lstStyle/>
+          <a:p>
+            <a:fld id="{F7021451-1387-4CA6-816F-3879F97B5CBC}" type="slidenum">
+              <a:rPr lang="en-US"/>
+              <a:t>13</a:t>
             </a:fld>
             <a:endParaRPr lang="en-US"/>
           </a:p>
@@ -1354,7 +1444,7 @@
           <a:p>
             <a:r>
               <a:rPr lang="en-US" dirty="0"/>
-              <a:t>6:30-7:30. Grey is what the same houses would have drawn, blue is what they drew, red is the transformer. The gap is the product. Real numbers from the running system, 4 houses per simulated household.</a:t>
+              <a:t>6:30-7:00. Grey is what the same houses would have drawn, blue is what they drew, red is the transformer. The gap is the product. Real numbers from the running system, 4 houses per simulated household.</a:t>
             </a:r>
             <a:endParaRPr lang="en-US" dirty="0"/>
           </a:p>
@@ -1442,7 +1532,7 @@
           <a:p>
             <a:r>
               <a:rPr lang="en-US" dirty="0"/>
-              <a:t>7:30-11:30. Alt-tab: deck, Gridzilla board, VRM. Pin Blatnica before the SUPPORT step so the curve stays on our transformer. VRM is the independent witness: Victron's own portal showing the setpoint change. If the venue network dies, show the recorded video.</a:t>
+              <a:t>7:00-8:00. Monster talk: Gridzilla eats peaks, but it is on a diet: it eats exactly the slice above L and not a watt more. A car plugged in at 18:00 trickles through dinner and gulps at 02:00. A battery swallows the peak and burps it back into the house. At noon it drinks the PV surplus. Nobody notices; the transformer sleeps at 70 instead of 110 percent. Then the algorithm in one breath: forecast what nobody controls, count the flexible energy, water-fill, send the ceilings. DeepSeek sits on top for what the plan cannot see: a cold snap, an outage, backflow.</a:t>
             </a:r>
             <a:endParaRPr lang="en-US" dirty="0"/>
           </a:p>
@@ -1530,7 +1620,7 @@
           <a:p>
             <a:r>
               <a:rPr lang="en-US" dirty="0"/>
-              <a:t>11:30-12:30. The point of this slide is credibility: nothing is a mock-up. Name the two real devices and the public broker.</a:t>
+              <a:t>8:00-11:30. Alt-tab: deck, Gridzilla board, VRM. Pin Blatnica before the SUPPORT step so the curve stays on our transformer. VRM is the independent witness: Victron's own portal showing the setpoint change. If the venue network dies, show the recorded video.</a:t>
             </a:r>
             <a:endParaRPr lang="en-US" dirty="0"/>
           </a:p>
@@ -2452,7 +2542,7 @@
                   <a:schemeClr val="tx1"/>
                 </a:solidFill>
               </a:rPr>
-              <a:t>Security of the control plane: the DSO can ask, it can never command</a:t>
+              <a:t>Everything on that screen runs on real infrastructure today</a:t>
             </a:r>
             <a:endParaRPr lang="en-US" sz="3200" dirty="0"/>
           </a:p>
@@ -2460,18 +2550,18 @@
       </p:sp>
       <p:sp>
         <p:nvSpPr>
-          <p:cNvPr id="3" name="sec Authenticity"/>
+          <p:cNvPr id="3" name="stat households on the board, 8,070 houses represented"/>
           <p:cNvSpPr/>
           <p:nvPr/>
         </p:nvSpPr>
         <p:spPr>
           <a:xfrm>
             <a:off x="548640" y="1463040"/>
-            <a:ext cx="5440680" cy="1005840"/>
+            <a:ext cx="2697480" cy="1417320"/>
           </a:xfrm>
           <a:prstGeom prst="roundRect">
             <a:avLst>
-              <a:gd name="adj" fmla="val 7273"/>
+              <a:gd name="adj" fmla="val 5161"/>
             </a:avLst>
           </a:prstGeom>
           <a:solidFill>
@@ -2487,39 +2577,14 @@
       </p:sp>
       <p:sp>
         <p:nvSpPr>
-          <p:cNvPr id="4" name="dot"/>
-          <p:cNvSpPr/>
-          <p:nvPr/>
-        </p:nvSpPr>
-        <p:spPr>
-          <a:xfrm>
-            <a:off x="731520" y="1645920"/>
-            <a:ext cx="384048" cy="384048"/>
-          </a:xfrm>
-          <a:prstGeom prst="ellipse">
-            <a:avLst/>
-          </a:prstGeom>
-          <a:solidFill>
-            <a:schemeClr val="accent3"/>
-          </a:solidFill>
-          <a:ln w="12700">
-            <a:solidFill>
-              <a:schemeClr val="accent3"/>
-            </a:solidFill>
-            <a:prstDash val="solid"/>
-          </a:ln>
-        </p:spPr>
-      </p:sp>
-      <p:sp>
-        <p:nvSpPr>
-          <p:cNvPr id="5" name="Text 3"/>
-          <p:cNvSpPr txBox="1"/>
-          <p:nvPr/>
-        </p:nvSpPr>
-        <p:spPr>
-          <a:xfrm>
-            <a:off x="1234440" y="1572768"/>
-            <a:ext cx="4572000" cy="320040"/>
+          <p:cNvPr id="4" name="Text 2"/>
+          <p:cNvSpPr txBox="1"/>
+          <p:nvPr/>
+        </p:nvSpPr>
+        <p:spPr>
+          <a:xfrm>
+            <a:off x="777240" y="1627632"/>
+            <a:ext cx="2240280" cy="731520"/>
           </a:xfrm>
           <a:prstGeom prst="rect">
             <a:avLst/>
@@ -2535,30 +2600,30 @@
               <a:buNone/>
             </a:pPr>
             <a:r>
-              <a:rPr lang="en-US" sz="1400" b="1" dirty="0">
-                <a:solidFill>
-                  <a:schemeClr val="tx1"/>
+              <a:rPr lang="en-US" sz="3600" b="1" dirty="0">
+                <a:solidFill>
+                  <a:schemeClr val="accent2"/>
                 </a:solidFill>
                 <a:latin typeface="Arial" pitchFamily="34" charset="0"/>
                 <a:ea typeface="Arial" pitchFamily="34" charset="-122"/>
                 <a:cs typeface="Arial" pitchFamily="34" charset="-120"/>
               </a:rPr>
-              <a:t>Authenticity</a:t>
-            </a:r>
-            <a:endParaRPr lang="en-US" sz="1400" dirty="0"/>
-          </a:p>
-        </p:txBody>
-      </p:sp>
-      <p:sp>
-        <p:nvSpPr>
-          <p:cNvPr id="6" name="Text 4"/>
-          <p:cNvSpPr txBox="1"/>
-          <p:nvPr/>
-        </p:nvSpPr>
-        <p:spPr>
-          <a:xfrm>
-            <a:off x="1234440" y="1892808"/>
-            <a:ext cx="4617720" cy="548640"/>
+              <a:t>272</a:t>
+            </a:r>
+            <a:endParaRPr lang="en-US" sz="3600" dirty="0"/>
+          </a:p>
+        </p:txBody>
+      </p:sp>
+      <p:sp>
+        <p:nvSpPr>
+          <p:cNvPr id="5" name="Text 3"/>
+          <p:cNvSpPr txBox="1"/>
+          <p:nvPr/>
+        </p:nvSpPr>
+        <p:spPr>
+          <a:xfrm>
+            <a:off x="777240" y="2359152"/>
+            <a:ext cx="2240280" cy="457200"/>
           </a:xfrm>
           <a:prstGeom prst="rect">
             <a:avLst/>
@@ -2574,31 +2639,31 @@
               <a:buNone/>
             </a:pPr>
             <a:r>
-              <a:rPr lang="en-US" sz="1150" dirty="0">
+              <a:rPr lang="en-US" sz="1200" dirty="0">
                 <a:solidFill>
                   <a:schemeClr val="tx2"/>
                 </a:solidFill>
               </a:rPr>
-              <a:t>every signal, heartbeat and ack carries an Ed25519 signature; the device pins the platform key and signs with its own</a:t>
-            </a:r>
-            <a:endParaRPr lang="en-US" sz="1150" dirty="0"/>
-          </a:p>
-        </p:txBody>
-      </p:sp>
-      <p:sp>
-        <p:nvSpPr>
-          <p:cNvPr id="7" name="sec Replay"/>
+              <a:t>households on the board, 8,070 houses represented</a:t>
+            </a:r>
+            <a:endParaRPr lang="en-US" sz="1200" dirty="0"/>
+          </a:p>
+        </p:txBody>
+      </p:sp>
+      <p:sp>
+        <p:nvSpPr>
+          <p:cNvPr id="6" name="stat street transformers, 24 feeders, 8 substations with Wiener Netze names"/>
           <p:cNvSpPr/>
           <p:nvPr/>
         </p:nvSpPr>
         <p:spPr>
           <a:xfrm>
-            <a:off x="6217920" y="1463040"/>
-            <a:ext cx="5440680" cy="1005840"/>
+            <a:off x="3383280" y="1463040"/>
+            <a:ext cx="2697480" cy="1417320"/>
           </a:xfrm>
           <a:prstGeom prst="roundRect">
             <a:avLst>
-              <a:gd name="adj" fmla="val 7273"/>
+              <a:gd name="adj" fmla="val 5161"/>
             </a:avLst>
           </a:prstGeom>
           <a:solidFill>
@@ -2614,39 +2679,14 @@
       </p:sp>
       <p:sp>
         <p:nvSpPr>
-          <p:cNvPr id="8" name="dot"/>
-          <p:cNvSpPr/>
-          <p:nvPr/>
-        </p:nvSpPr>
-        <p:spPr>
-          <a:xfrm>
-            <a:off x="6400800" y="1645920"/>
-            <a:ext cx="384048" cy="384048"/>
-          </a:xfrm>
-          <a:prstGeom prst="ellipse">
-            <a:avLst/>
-          </a:prstGeom>
-          <a:solidFill>
-            <a:schemeClr val="accent3"/>
-          </a:solidFill>
-          <a:ln w="12700">
-            <a:solidFill>
-              <a:schemeClr val="accent3"/>
-            </a:solidFill>
-            <a:prstDash val="solid"/>
-          </a:ln>
-        </p:spPr>
-      </p:sp>
-      <p:sp>
-        <p:nvSpPr>
-          <p:cNvPr id="9" name="Text 7"/>
-          <p:cNvSpPr txBox="1"/>
-          <p:nvPr/>
-        </p:nvSpPr>
-        <p:spPr>
-          <a:xfrm>
-            <a:off x="6903720" y="1572768"/>
-            <a:ext cx="4572000" cy="320040"/>
+          <p:cNvPr id="7" name="Text 5"/>
+          <p:cNvSpPr txBox="1"/>
+          <p:nvPr/>
+        </p:nvSpPr>
+        <p:spPr>
+          <a:xfrm>
+            <a:off x="3611880" y="1627632"/>
+            <a:ext cx="2240280" cy="731520"/>
           </a:xfrm>
           <a:prstGeom prst="rect">
             <a:avLst/>
@@ -2662,30 +2702,30 @@
               <a:buNone/>
             </a:pPr>
             <a:r>
-              <a:rPr lang="en-US" sz="1400" b="1" dirty="0">
-                <a:solidFill>
-                  <a:schemeClr val="tx1"/>
+              <a:rPr lang="en-US" sz="3600" b="1" dirty="0">
+                <a:solidFill>
+                  <a:schemeClr val="accent2"/>
                 </a:solidFill>
                 <a:latin typeface="Arial" pitchFamily="34" charset="0"/>
                 <a:ea typeface="Arial" pitchFamily="34" charset="-122"/>
                 <a:cs typeface="Arial" pitchFamily="34" charset="-120"/>
               </a:rPr>
-              <a:t>Replay</a:t>
-            </a:r>
-            <a:endParaRPr lang="en-US" sz="1400" dirty="0"/>
-          </a:p>
-        </p:txBody>
-      </p:sp>
-      <p:sp>
-        <p:nvSpPr>
-          <p:cNvPr id="10" name="Text 8"/>
-          <p:cNvSpPr txBox="1"/>
-          <p:nvPr/>
-        </p:nvSpPr>
-        <p:spPr>
-          <a:xfrm>
-            <a:off x="6903720" y="1892808"/>
-            <a:ext cx="4617720" cy="548640"/>
+              <a:t>72</a:t>
+            </a:r>
+            <a:endParaRPr lang="en-US" sz="3600" dirty="0"/>
+          </a:p>
+        </p:txBody>
+      </p:sp>
+      <p:sp>
+        <p:nvSpPr>
+          <p:cNvPr id="8" name="Text 6"/>
+          <p:cNvSpPr txBox="1"/>
+          <p:nvPr/>
+        </p:nvSpPr>
+        <p:spPr>
+          <a:xfrm>
+            <a:off x="3611880" y="2359152"/>
+            <a:ext cx="2240280" cy="457200"/>
           </a:xfrm>
           <a:prstGeom prst="rect">
             <a:avLst/>
@@ -2701,31 +2741,31 @@
               <a:buNone/>
             </a:pPr>
             <a:r>
-              <a:rPr lang="en-US" sz="1150" dirty="0">
+              <a:rPr lang="en-US" sz="1200" dirty="0">
                 <a:solidFill>
                   <a:schemeClr val="tx2"/>
                 </a:solidFill>
               </a:rPr>
-              <a:t>monotonic sequence numbers persisted on the device, 120 s freshness, heartbeats with sequence and timestamp</a:t>
-            </a:r>
-            <a:endParaRPr lang="en-US" sz="1150" dirty="0"/>
-          </a:p>
-        </p:txBody>
-      </p:sp>
-      <p:sp>
-        <p:nvSpPr>
-          <p:cNvPr id="11" name="sec Bounded"/>
+              <a:t>street transformers, 24 feeders, 8 substations with Wiener Netze names</a:t>
+            </a:r>
+            <a:endParaRPr lang="en-US" sz="1200" dirty="0"/>
+          </a:p>
+        </p:txBody>
+      </p:sp>
+      <p:sp>
+        <p:nvSpPr>
+          <p:cNvPr id="9" name="stat real devices: a Victron plant and a Viessmann heat pump, 60 km from here"/>
           <p:cNvSpPr/>
           <p:nvPr/>
         </p:nvSpPr>
         <p:spPr>
           <a:xfrm>
-            <a:off x="548640" y="2606040"/>
-            <a:ext cx="5440680" cy="1005840"/>
+            <a:off x="6217920" y="1463040"/>
+            <a:ext cx="2697480" cy="1417320"/>
           </a:xfrm>
           <a:prstGeom prst="roundRect">
             <a:avLst>
-              <a:gd name="adj" fmla="val 7273"/>
+              <a:gd name="adj" fmla="val 5161"/>
             </a:avLst>
           </a:prstGeom>
           <a:solidFill>
@@ -2741,39 +2781,14 @@
       </p:sp>
       <p:sp>
         <p:nvSpPr>
-          <p:cNvPr id="12" name="dot"/>
-          <p:cNvSpPr/>
-          <p:nvPr/>
-        </p:nvSpPr>
-        <p:spPr>
-          <a:xfrm>
-            <a:off x="731520" y="2788920"/>
-            <a:ext cx="384048" cy="384048"/>
-          </a:xfrm>
-          <a:prstGeom prst="ellipse">
-            <a:avLst/>
-          </a:prstGeom>
-          <a:solidFill>
-            <a:schemeClr val="accent3"/>
-          </a:solidFill>
-          <a:ln w="12700">
-            <a:solidFill>
-              <a:schemeClr val="accent3"/>
-            </a:solidFill>
-            <a:prstDash val="solid"/>
-          </a:ln>
-        </p:spPr>
-      </p:sp>
-      <p:sp>
-        <p:nvSpPr>
-          <p:cNvPr id="13" name="Text 11"/>
-          <p:cNvSpPr txBox="1"/>
-          <p:nvPr/>
-        </p:nvSpPr>
-        <p:spPr>
-          <a:xfrm>
-            <a:off x="1234440" y="2715768"/>
-            <a:ext cx="4572000" cy="320040"/>
+          <p:cNvPr id="10" name="Text 8"/>
+          <p:cNvSpPr txBox="1"/>
+          <p:nvPr/>
+        </p:nvSpPr>
+        <p:spPr>
+          <a:xfrm>
+            <a:off x="6446520" y="1627632"/>
+            <a:ext cx="2240280" cy="731520"/>
           </a:xfrm>
           <a:prstGeom prst="rect">
             <a:avLst/>
@@ -2789,30 +2804,30 @@
               <a:buNone/>
             </a:pPr>
             <a:r>
-              <a:rPr lang="en-US" sz="1400" b="1" dirty="0">
-                <a:solidFill>
-                  <a:schemeClr val="tx1"/>
+              <a:rPr lang="en-US" sz="3600" b="1" dirty="0">
+                <a:solidFill>
+                  <a:schemeClr val="accent3"/>
                 </a:solidFill>
                 <a:latin typeface="Arial" pitchFamily="34" charset="0"/>
                 <a:ea typeface="Arial" pitchFamily="34" charset="-122"/>
                 <a:cs typeface="Arial" pitchFamily="34" charset="-120"/>
               </a:rPr>
-              <a:t>Bounded</a:t>
-            </a:r>
-            <a:endParaRPr lang="en-US" sz="1400" dirty="0"/>
-          </a:p>
-        </p:txBody>
-      </p:sp>
-      <p:sp>
-        <p:nvSpPr>
-          <p:cNvPr id="14" name="Text 12"/>
-          <p:cNvSpPr txBox="1"/>
-          <p:nvPr/>
-        </p:nvSpPr>
-        <p:spPr>
-          <a:xfrm>
-            <a:off x="1234440" y="3035808"/>
-            <a:ext cx="4617720" cy="548640"/>
+              <a:t>2</a:t>
+            </a:r>
+            <a:endParaRPr lang="en-US" sz="3600" dirty="0"/>
+          </a:p>
+        </p:txBody>
+      </p:sp>
+      <p:sp>
+        <p:nvSpPr>
+          <p:cNvPr id="11" name="Text 9"/>
+          <p:cNvSpPr txBox="1"/>
+          <p:nvPr/>
+        </p:nvSpPr>
+        <p:spPr>
+          <a:xfrm>
+            <a:off x="6446520" y="2359152"/>
+            <a:ext cx="2240280" cy="457200"/>
           </a:xfrm>
           <a:prstGeom prst="rect">
             <a:avLst/>
@@ -2828,31 +2843,31 @@
               <a:buNone/>
             </a:pPr>
             <a:r>
-              <a:rPr lang="en-US" sz="1150" dirty="0">
+              <a:rPr lang="en-US" sz="1200" dirty="0">
                 <a:solidFill>
                   <a:schemeClr val="tx2"/>
                 </a:solidFill>
               </a:rPr>
-              <a:t>limits, never setpoints; four-hour window enforced on the device itself; depth and rate capped by the guard</a:t>
-            </a:r>
-            <a:endParaRPr lang="en-US" sz="1150" dirty="0"/>
-          </a:p>
-        </p:txBody>
-      </p:sp>
-      <p:sp>
-        <p:nvSpPr>
-          <p:cNvPr id="15" name="sec Owner veto"/>
+              <a:t>real devices: a Victron plant and a Viessmann heat pump, 60 km from here</a:t>
+            </a:r>
+            <a:endParaRPr lang="en-US" sz="1200" dirty="0"/>
+          </a:p>
+        </p:txBody>
+      </p:sp>
+      <p:sp>
+        <p:nvSpPr>
+          <p:cNvPr id="12" name="stat DeepSeek decision latency on the DGX Spark"/>
           <p:cNvSpPr/>
           <p:nvPr/>
         </p:nvSpPr>
         <p:spPr>
           <a:xfrm>
-            <a:off x="6217920" y="2606040"/>
-            <a:ext cx="5440680" cy="1005840"/>
+            <a:off x="9052560" y="1463040"/>
+            <a:ext cx="2587752" cy="1417320"/>
           </a:xfrm>
           <a:prstGeom prst="roundRect">
             <a:avLst>
-              <a:gd name="adj" fmla="val 7273"/>
+              <a:gd name="adj" fmla="val 5161"/>
             </a:avLst>
           </a:prstGeom>
           <a:solidFill>
@@ -2868,24 +2883,99 @@
       </p:sp>
       <p:sp>
         <p:nvSpPr>
-          <p:cNvPr id="16" name="dot"/>
+          <p:cNvPr id="13" name="Text 11"/>
+          <p:cNvSpPr txBox="1"/>
+          <p:nvPr/>
+        </p:nvSpPr>
+        <p:spPr>
+          <a:xfrm>
+            <a:off x="9281160" y="1627632"/>
+            <a:ext cx="2130552" cy="731520"/>
+          </a:xfrm>
+          <a:prstGeom prst="rect">
+            <a:avLst/>
+          </a:prstGeom>
+          <a:noFill/>
+          <a:ln/>
+        </p:spPr>
+        <p:txBody>
+          <a:bodyPr wrap="square" lIns="0" tIns="0" rIns="0" bIns="0" rtlCol="0" anchor="t"/>
+          <a:lstStyle/>
+          <a:p>
+            <a:pPr indent="0" marL="0">
+              <a:buNone/>
+            </a:pPr>
+            <a:r>
+              <a:rPr lang="en-US" sz="3600" b="1" dirty="0">
+                <a:solidFill>
+                  <a:schemeClr val="accent1"/>
+                </a:solidFill>
+                <a:latin typeface="Arial" pitchFamily="34" charset="0"/>
+                <a:ea typeface="Arial" pitchFamily="34" charset="-122"/>
+                <a:cs typeface="Arial" pitchFamily="34" charset="-120"/>
+              </a:rPr>
+              <a:t>~3 s</a:t>
+            </a:r>
+            <a:endParaRPr lang="en-US" sz="3600" dirty="0"/>
+          </a:p>
+        </p:txBody>
+      </p:sp>
+      <p:sp>
+        <p:nvSpPr>
+          <p:cNvPr id="14" name="Text 12"/>
+          <p:cNvSpPr txBox="1"/>
+          <p:nvPr/>
+        </p:nvSpPr>
+        <p:spPr>
+          <a:xfrm>
+            <a:off x="9281160" y="2359152"/>
+            <a:ext cx="2130552" cy="457200"/>
+          </a:xfrm>
+          <a:prstGeom prst="rect">
+            <a:avLst/>
+          </a:prstGeom>
+          <a:noFill/>
+          <a:ln/>
+        </p:spPr>
+        <p:txBody>
+          <a:bodyPr wrap="square" lIns="0" tIns="0" rIns="0" bIns="0" rtlCol="0" anchor="t"/>
+          <a:lstStyle/>
+          <a:p>
+            <a:pPr indent="0" marL="0">
+              <a:buNone/>
+            </a:pPr>
+            <a:r>
+              <a:rPr lang="en-US" sz="1200" dirty="0">
+                <a:solidFill>
+                  <a:schemeClr val="tx2"/>
+                </a:solidFill>
+              </a:rPr>
+              <a:t>DeepSeek decision latency on the DGX Spark</a:t>
+            </a:r>
+            <a:endParaRPr lang="en-US" sz="1200" dirty="0"/>
+          </a:p>
+        </p:txBody>
+      </p:sp>
+      <p:sp>
+        <p:nvSpPr>
+          <p:cNvPr id="15" name="dot"/>
           <p:cNvSpPr/>
           <p:nvPr/>
         </p:nvSpPr>
         <p:spPr>
           <a:xfrm>
-            <a:off x="6400800" y="2788920"/>
+            <a:off x="548640" y="3200400"/>
             <a:ext cx="384048" cy="384048"/>
           </a:xfrm>
           <a:prstGeom prst="ellipse">
             <a:avLst/>
           </a:prstGeom>
           <a:solidFill>
-            <a:schemeClr val="accent3"/>
+            <a:schemeClr val="accent1"/>
           </a:solidFill>
           <a:ln w="12700">
             <a:solidFill>
-              <a:schemeClr val="accent3"/>
+              <a:schemeClr val="accent1"/>
             </a:solidFill>
             <a:prstDash val="solid"/>
           </a:ln>
@@ -2893,14 +2983,14 @@
       </p:sp>
       <p:sp>
         <p:nvSpPr>
-          <p:cNvPr id="17" name="Text 15"/>
-          <p:cNvSpPr txBox="1"/>
-          <p:nvPr/>
-        </p:nvSpPr>
-        <p:spPr>
-          <a:xfrm>
-            <a:off x="6903720" y="2715768"/>
-            <a:ext cx="4572000" cy="320040"/>
+          <p:cNvPr id="16" name="Text 14"/>
+          <p:cNvSpPr txBox="1"/>
+          <p:nvPr/>
+        </p:nvSpPr>
+        <p:spPr>
+          <a:xfrm>
+            <a:off x="1097280" y="3154680"/>
+            <a:ext cx="4937760" cy="320040"/>
           </a:xfrm>
           <a:prstGeom prst="rect">
             <a:avLst/>
@@ -2924,7 +3014,7 @@
                 <a:ea typeface="Arial" pitchFamily="34" charset="-122"/>
                 <a:cs typeface="Arial" pitchFamily="34" charset="-120"/>
               </a:rPr>
-              <a:t>Owner veto</a:t>
+              <a:t>Real plant</a:t>
             </a:r>
             <a:endParaRPr lang="en-US" sz="1400" dirty="0"/>
           </a:p>
@@ -2932,14 +3022,14 @@
       </p:sp>
       <p:sp>
         <p:nvSpPr>
-          <p:cNvPr id="18" name="Text 16"/>
-          <p:cNvSpPr txBox="1"/>
-          <p:nvPr/>
-        </p:nvSpPr>
-        <p:spPr>
-          <a:xfrm>
-            <a:off x="6903720" y="3035808"/>
-            <a:ext cx="4617720" cy="548640"/>
+          <p:cNvPr id="17" name="Text 15"/>
+          <p:cNvSpPr txBox="1"/>
+          <p:nvPr/>
+        </p:nvSpPr>
+        <p:spPr>
+          <a:xfrm>
+            <a:off x="1097280" y="3474720"/>
+            <a:ext cx="4937760" cy="640080"/>
           </a:xfrm>
           <a:prstGeom prst="rect">
             <a:avLst/>
@@ -2960,7 +3050,7 @@
                   <a:schemeClr val="tx2"/>
                 </a:solidFill>
               </a:rPr>
-              <a:t>minimum SoC, max current, opt-out merged on the device; a compromised DSO key moves nothing past them</a:t>
+              <a:t>Cerbo GX on Venus OS Large, a 53-node Node-RED agent we deploy over the admin API; EV Charging Station throttled first; ESS limits written and restored</a:t>
             </a:r>
             <a:endParaRPr lang="en-US" sz="1150" dirty="0"/>
           </a:p>
@@ -2968,26 +3058,24 @@
       </p:sp>
       <p:sp>
         <p:nvSpPr>
-          <p:cNvPr id="19" name="sec Fail-safe"/>
+          <p:cNvPr id="18" name="dot"/>
           <p:cNvSpPr/>
           <p:nvPr/>
         </p:nvSpPr>
         <p:spPr>
           <a:xfrm>
-            <a:off x="548640" y="3749040"/>
-            <a:ext cx="5440680" cy="1005840"/>
-          </a:xfrm>
-          <a:prstGeom prst="roundRect">
-            <a:avLst>
-              <a:gd name="adj" fmla="val 7273"/>
-            </a:avLst>
+            <a:off x="6217920" y="3200400"/>
+            <a:ext cx="384048" cy="384048"/>
+          </a:xfrm>
+          <a:prstGeom prst="ellipse">
+            <a:avLst/>
           </a:prstGeom>
           <a:solidFill>
-            <a:schemeClr val="bg2"/>
+            <a:schemeClr val="accent1"/>
           </a:solidFill>
-          <a:ln w="9525">
+          <a:ln w="12700">
             <a:solidFill>
-              <a:schemeClr val="bg2"/>
+              <a:schemeClr val="accent1"/>
             </a:solidFill>
             <a:prstDash val="solid"/>
           </a:ln>
@@ -2995,24 +3083,99 @@
       </p:sp>
       <p:sp>
         <p:nvSpPr>
-          <p:cNvPr id="20" name="dot"/>
+          <p:cNvPr id="19" name="Text 17"/>
+          <p:cNvSpPr txBox="1"/>
+          <p:nvPr/>
+        </p:nvSpPr>
+        <p:spPr>
+          <a:xfrm>
+            <a:off x="6766560" y="3154680"/>
+            <a:ext cx="4937760" cy="320040"/>
+          </a:xfrm>
+          <a:prstGeom prst="rect">
+            <a:avLst/>
+          </a:prstGeom>
+          <a:noFill/>
+          <a:ln/>
+        </p:spPr>
+        <p:txBody>
+          <a:bodyPr wrap="square" lIns="0" tIns="0" rIns="0" bIns="0" rtlCol="0" anchor="t"/>
+          <a:lstStyle/>
+          <a:p>
+            <a:pPr indent="0" marL="0">
+              <a:buNone/>
+            </a:pPr>
+            <a:r>
+              <a:rPr lang="en-US" sz="1400" b="1" dirty="0">
+                <a:solidFill>
+                  <a:schemeClr val="tx1"/>
+                </a:solidFill>
+                <a:latin typeface="Arial" pitchFamily="34" charset="0"/>
+                <a:ea typeface="Arial" pitchFamily="34" charset="-122"/>
+                <a:cs typeface="Arial" pitchFamily="34" charset="-120"/>
+              </a:rPr>
+              <a:t>Heat pump</a:t>
+            </a:r>
+            <a:endParaRPr lang="en-US" sz="1400" dirty="0"/>
+          </a:p>
+        </p:txBody>
+      </p:sp>
+      <p:sp>
+        <p:nvSpPr>
+          <p:cNvPr id="20" name="Text 18"/>
+          <p:cNvSpPr txBox="1"/>
+          <p:nvPr/>
+        </p:nvSpPr>
+        <p:spPr>
+          <a:xfrm>
+            <a:off x="6766560" y="3474720"/>
+            <a:ext cx="4937760" cy="640080"/>
+          </a:xfrm>
+          <a:prstGeom prst="rect">
+            <a:avLst/>
+          </a:prstGeom>
+          <a:noFill/>
+          <a:ln/>
+        </p:spPr>
+        <p:txBody>
+          <a:bodyPr wrap="square" lIns="0" tIns="0" rIns="0" bIns="0" rtlCol="0" anchor="t"/>
+          <a:lstStyle/>
+          <a:p>
+            <a:pPr indent="0" marL="0">
+              <a:buNone/>
+            </a:pPr>
+            <a:r>
+              <a:rPr lang="en-US" sz="1150" dirty="0">
+                <a:solidFill>
+                  <a:schemeClr val="tx2"/>
+                </a:solidFill>
+              </a:rPr>
+              <a:t>Vitocal CU401B through the ViCare REST API with a refresh token; hot-water setpoint and one-time charge, verified on the unit</a:t>
+            </a:r>
+            <a:endParaRPr lang="en-US" sz="1150" dirty="0"/>
+          </a:p>
+        </p:txBody>
+      </p:sp>
+      <p:sp>
+        <p:nvSpPr>
+          <p:cNvPr id="21" name="dot"/>
           <p:cNvSpPr/>
           <p:nvPr/>
         </p:nvSpPr>
         <p:spPr>
           <a:xfrm>
-            <a:off x="731520" y="3931920"/>
+            <a:off x="548640" y="4187952"/>
             <a:ext cx="384048" cy="384048"/>
           </a:xfrm>
           <a:prstGeom prst="ellipse">
             <a:avLst/>
           </a:prstGeom>
           <a:solidFill>
-            <a:schemeClr val="accent3"/>
+            <a:schemeClr val="accent1"/>
           </a:solidFill>
           <a:ln w="12700">
             <a:solidFill>
-              <a:schemeClr val="accent3"/>
+              <a:schemeClr val="accent1"/>
             </a:solidFill>
             <a:prstDash val="solid"/>
           </a:ln>
@@ -3020,14 +3183,14 @@
       </p:sp>
       <p:sp>
         <p:nvSpPr>
-          <p:cNvPr id="21" name="Text 19"/>
-          <p:cNvSpPr txBox="1"/>
-          <p:nvPr/>
-        </p:nvSpPr>
-        <p:spPr>
-          <a:xfrm>
-            <a:off x="1234440" y="3858768"/>
-            <a:ext cx="4572000" cy="320040"/>
+          <p:cNvPr id="22" name="Text 20"/>
+          <p:cNvSpPr txBox="1"/>
+          <p:nvPr/>
+        </p:nvSpPr>
+        <p:spPr>
+          <a:xfrm>
+            <a:off x="1097280" y="4142232"/>
+            <a:ext cx="4937760" cy="320040"/>
           </a:xfrm>
           <a:prstGeom prst="rect">
             <a:avLst/>
@@ -3051,7 +3214,7 @@
                 <a:ea typeface="Arial" pitchFamily="34" charset="-122"/>
                 <a:cs typeface="Arial" pitchFamily="34" charset="-120"/>
               </a:rPr>
-              <a:t>Fail-safe</a:t>
+              <a:t>Transport</a:t>
             </a:r>
             <a:endParaRPr lang="en-US" sz="1400" dirty="0"/>
           </a:p>
@@ -3059,14 +3222,14 @@
       </p:sp>
       <p:sp>
         <p:nvSpPr>
-          <p:cNvPr id="22" name="Text 20"/>
-          <p:cNvSpPr txBox="1"/>
-          <p:nvPr/>
-        </p:nvSpPr>
-        <p:spPr>
-          <a:xfrm>
-            <a:off x="1234440" y="4178808"/>
-            <a:ext cx="4617720" cy="548640"/>
+          <p:cNvPr id="23" name="Text 21"/>
+          <p:cNvSpPr txBox="1"/>
+          <p:nvPr/>
+        </p:nvSpPr>
+        <p:spPr>
+          <a:xfrm>
+            <a:off x="1097280" y="4462272"/>
+            <a:ext cx="4937760" cy="640080"/>
           </a:xfrm>
           <a:prstGeom prst="rect">
             <a:avLst/>
@@ -3087,7 +3250,7 @@
                   <a:schemeClr val="tx2"/>
                 </a:solidFill>
               </a:rPr>
-              <a:t>window end, heartbeat loss or RELEASE restore the owner's settings; a dead platform leaves every house in owner mode</a:t>
+              <a:t>Mosquitto on our own server, Let's Encrypt, TLS only, credentials and topic access lists; devices open outbound connections only</a:t>
             </a:r>
             <a:endParaRPr lang="en-US" sz="1150" dirty="0"/>
           </a:p>
@@ -3095,26 +3258,24 @@
       </p:sp>
       <p:sp>
         <p:nvSpPr>
-          <p:cNvPr id="23" name="sec Transport"/>
+          <p:cNvPr id="24" name="dot"/>
           <p:cNvSpPr/>
           <p:nvPr/>
         </p:nvSpPr>
         <p:spPr>
           <a:xfrm>
-            <a:off x="6217920" y="3749040"/>
-            <a:ext cx="5440680" cy="1005840"/>
-          </a:xfrm>
-          <a:prstGeom prst="roundRect">
-            <a:avLst>
-              <a:gd name="adj" fmla="val 7273"/>
-            </a:avLst>
+            <a:off x="6217920" y="4187952"/>
+            <a:ext cx="384048" cy="384048"/>
+          </a:xfrm>
+          <a:prstGeom prst="ellipse">
+            <a:avLst/>
           </a:prstGeom>
           <a:solidFill>
-            <a:schemeClr val="bg2"/>
+            <a:schemeClr val="accent1"/>
           </a:solidFill>
-          <a:ln w="9525">
+          <a:ln w="12700">
             <a:solidFill>
-              <a:schemeClr val="bg2"/>
+              <a:schemeClr val="accent1"/>
             </a:solidFill>
             <a:prstDash val="solid"/>
           </a:ln>
@@ -3122,24 +3283,99 @@
       </p:sp>
       <p:sp>
         <p:nvSpPr>
-          <p:cNvPr id="24" name="dot"/>
+          <p:cNvPr id="25" name="Text 23"/>
+          <p:cNvSpPr txBox="1"/>
+          <p:nvPr/>
+        </p:nvSpPr>
+        <p:spPr>
+          <a:xfrm>
+            <a:off x="6766560" y="4142232"/>
+            <a:ext cx="4937760" cy="320040"/>
+          </a:xfrm>
+          <a:prstGeom prst="rect">
+            <a:avLst/>
+          </a:prstGeom>
+          <a:noFill/>
+          <a:ln/>
+        </p:spPr>
+        <p:txBody>
+          <a:bodyPr wrap="square" lIns="0" tIns="0" rIns="0" bIns="0" rtlCol="0" anchor="t"/>
+          <a:lstStyle/>
+          <a:p>
+            <a:pPr indent="0" marL="0">
+              <a:buNone/>
+            </a:pPr>
+            <a:r>
+              <a:rPr lang="en-US" sz="1400" b="1" dirty="0">
+                <a:solidFill>
+                  <a:schemeClr val="tx1"/>
+                </a:solidFill>
+                <a:latin typeface="Arial" pitchFamily="34" charset="0"/>
+                <a:ea typeface="Arial" pitchFamily="34" charset="-122"/>
+                <a:cs typeface="Arial" pitchFamily="34" charset="-120"/>
+              </a:rPr>
+              <a:t>Platform</a:t>
+            </a:r>
+            <a:endParaRPr lang="en-US" sz="1400" dirty="0"/>
+          </a:p>
+        </p:txBody>
+      </p:sp>
+      <p:sp>
+        <p:nvSpPr>
+          <p:cNvPr id="26" name="Text 24"/>
+          <p:cNvSpPr txBox="1"/>
+          <p:nvPr/>
+        </p:nvSpPr>
+        <p:spPr>
+          <a:xfrm>
+            <a:off x="6766560" y="4462272"/>
+            <a:ext cx="4937760" cy="640080"/>
+          </a:xfrm>
+          <a:prstGeom prst="rect">
+            <a:avLst/>
+          </a:prstGeom>
+          <a:noFill/>
+          <a:ln/>
+        </p:spPr>
+        <p:txBody>
+          <a:bodyPr wrap="square" lIns="0" tIns="0" rIns="0" bIns="0" rtlCol="0" anchor="t"/>
+          <a:lstStyle/>
+          <a:p>
+            <a:pPr indent="0" marL="0">
+              <a:buNone/>
+            </a:pPr>
+            <a:r>
+              <a:rPr lang="en-US" sz="1150" dirty="0">
+                <a:solidFill>
+                  <a:schemeClr val="tx2"/>
+                </a:solidFill>
+              </a:rPr>
+              <a:t>FastAPI on a Ubuntu box behind Apache and Let's Encrypt; registry tree, guard, signing, history, autopilot; public board at gridzilla.victronlab.sk</a:t>
+            </a:r>
+            <a:endParaRPr lang="en-US" sz="1150" dirty="0"/>
+          </a:p>
+        </p:txBody>
+      </p:sp>
+      <p:sp>
+        <p:nvSpPr>
+          <p:cNvPr id="27" name="dot"/>
           <p:cNvSpPr/>
           <p:nvPr/>
         </p:nvSpPr>
         <p:spPr>
           <a:xfrm>
-            <a:off x="6400800" y="3931920"/>
+            <a:off x="548640" y="5175504"/>
             <a:ext cx="384048" cy="384048"/>
           </a:xfrm>
           <a:prstGeom prst="ellipse">
             <a:avLst/>
           </a:prstGeom>
           <a:solidFill>
-            <a:schemeClr val="accent3"/>
+            <a:schemeClr val="accent1"/>
           </a:solidFill>
           <a:ln w="12700">
             <a:solidFill>
-              <a:schemeClr val="accent3"/>
+              <a:schemeClr val="accent1"/>
             </a:solidFill>
             <a:prstDash val="solid"/>
           </a:ln>
@@ -3147,14 +3383,14 @@
       </p:sp>
       <p:sp>
         <p:nvSpPr>
-          <p:cNvPr id="25" name="Text 23"/>
-          <p:cNvSpPr txBox="1"/>
-          <p:nvPr/>
-        </p:nvSpPr>
-        <p:spPr>
-          <a:xfrm>
-            <a:off x="6903720" y="3858768"/>
-            <a:ext cx="4572000" cy="320040"/>
+          <p:cNvPr id="28" name="Text 26"/>
+          <p:cNvSpPr txBox="1"/>
+          <p:nvPr/>
+        </p:nvSpPr>
+        <p:spPr>
+          <a:xfrm>
+            <a:off x="1097280" y="5129784"/>
+            <a:ext cx="4937760" cy="320040"/>
           </a:xfrm>
           <a:prstGeom prst="rect">
             <a:avLst/>
@@ -3178,7 +3414,7 @@
                 <a:ea typeface="Arial" pitchFamily="34" charset="-122"/>
                 <a:cs typeface="Arial" pitchFamily="34" charset="-120"/>
               </a:rPr>
-              <a:t>Transport</a:t>
+              <a:t>Simulation</a:t>
             </a:r>
             <a:endParaRPr lang="en-US" sz="1400" dirty="0"/>
           </a:p>
@@ -3186,14 +3422,14 @@
       </p:sp>
       <p:sp>
         <p:nvSpPr>
-          <p:cNvPr id="26" name="Text 24"/>
-          <p:cNvSpPr txBox="1"/>
-          <p:nvPr/>
-        </p:nvSpPr>
-        <p:spPr>
-          <a:xfrm>
-            <a:off x="6903720" y="4178808"/>
-            <a:ext cx="4617720" cy="548640"/>
+          <p:cNvPr id="29" name="Text 27"/>
+          <p:cNvSpPr txBox="1"/>
+          <p:nvPr/>
+        </p:nvSpPr>
+        <p:spPr>
+          <a:xfrm>
+            <a:off x="1097280" y="5449824"/>
+            <a:ext cx="4937760" cy="640080"/>
           </a:xfrm>
           <a:prstGeom prst="rect">
             <a:avLst/>
@@ -3214,7 +3450,7 @@
                   <a:schemeClr val="tx2"/>
                 </a:solidFill>
               </a:rPr>
-              <a:t>TLS with a real certificate, per-role credentials, topic ACLs; a device cannot publish a signal even if it tried</a:t>
+              <a:t>262 households with battery, PV, EV commutes, heat pumps and boilers with real tank physics; each agent speaks the same protocol as the Cerbo</a:t>
             </a:r>
             <a:endParaRPr lang="en-US" sz="1150" dirty="0"/>
           </a:p>
@@ -3222,26 +3458,24 @@
       </p:sp>
       <p:sp>
         <p:nvSpPr>
-          <p:cNvPr id="27" name="open items"/>
+          <p:cNvPr id="30" name="dot"/>
           <p:cNvSpPr/>
           <p:nvPr/>
         </p:nvSpPr>
         <p:spPr>
           <a:xfrm>
-            <a:off x="548640" y="5029200"/>
-            <a:ext cx="11091672" cy="1143000"/>
-          </a:xfrm>
-          <a:prstGeom prst="roundRect">
-            <a:avLst>
-              <a:gd name="adj" fmla="val 6400"/>
-            </a:avLst>
+            <a:off x="6217920" y="5175504"/>
+            <a:ext cx="384048" cy="384048"/>
+          </a:xfrm>
+          <a:prstGeom prst="ellipse">
+            <a:avLst/>
           </a:prstGeom>
           <a:solidFill>
-            <a:srgbClr val="1D2127"/>
+            <a:schemeClr val="accent1"/>
           </a:solidFill>
-          <a:ln w="9525">
+          <a:ln w="12700">
             <a:solidFill>
-              <a:srgbClr val="C98500"/>
+              <a:schemeClr val="accent1"/>
             </a:solidFill>
             <a:prstDash val="solid"/>
           </a:ln>
@@ -3249,14 +3483,14 @@
       </p:sp>
       <p:sp>
         <p:nvSpPr>
-          <p:cNvPr id="28" name="Text 26"/>
-          <p:cNvSpPr txBox="1"/>
-          <p:nvPr/>
-        </p:nvSpPr>
-        <p:spPr>
-          <a:xfrm>
-            <a:off x="777240" y="5120640"/>
-            <a:ext cx="3657600" cy="320040"/>
+          <p:cNvPr id="31" name="Text 29"/>
+          <p:cNvSpPr txBox="1"/>
+          <p:nvPr/>
+        </p:nvSpPr>
+        <p:spPr>
+          <a:xfrm>
+            <a:off x="6766560" y="5129784"/>
+            <a:ext cx="4937760" cy="320040"/>
           </a:xfrm>
           <a:prstGeom prst="rect">
             <a:avLst/>
@@ -3272,27 +3506,30 @@
               <a:buNone/>
             </a:pPr>
             <a:r>
-              <a:rPr lang="en-US" sz="1300" b="1" dirty="0">
-                <a:solidFill>
-                  <a:schemeClr val="accent6"/>
-                </a:solidFill>
-              </a:rPr>
-              <a:t>Named before you ask</a:t>
-            </a:r>
-            <a:endParaRPr lang="en-US" sz="1300" dirty="0"/>
-          </a:p>
-        </p:txBody>
-      </p:sp>
-      <p:sp>
-        <p:nvSpPr>
-          <p:cNvPr id="29" name="Text 27"/>
-          <p:cNvSpPr txBox="1"/>
-          <p:nvPr/>
-        </p:nvSpPr>
-        <p:spPr>
-          <a:xfrm>
-            <a:off x="777240" y="5440680"/>
-            <a:ext cx="10634472" cy="685800"/>
+              <a:rPr lang="en-US" sz="1400" b="1" dirty="0">
+                <a:solidFill>
+                  <a:schemeClr val="tx1"/>
+                </a:solidFill>
+                <a:latin typeface="Arial" pitchFamily="34" charset="0"/>
+                <a:ea typeface="Arial" pitchFamily="34" charset="-122"/>
+                <a:cs typeface="Arial" pitchFamily="34" charset="-120"/>
+              </a:rPr>
+              <a:t>Protocol</a:t>
+            </a:r>
+            <a:endParaRPr lang="en-US" sz="1400" dirty="0"/>
+          </a:p>
+        </p:txBody>
+      </p:sp>
+      <p:sp>
+        <p:nvSpPr>
+          <p:cNvPr id="32" name="Text 30"/>
+          <p:cNvSpPr txBox="1"/>
+          <p:nvPr/>
+        </p:nvSpPr>
+        <p:spPr>
+          <a:xfrm>
+            <a:off x="6766560" y="5449824"/>
+            <a:ext cx="4937760" cy="640080"/>
           </a:xfrm>
           <a:prstGeom prst="rect">
             <a:avLst/>
@@ -3308,14 +3545,14 @@
               <a:buNone/>
             </a:pPr>
             <a:r>
-              <a:rPr lang="en-US" sz="1200" dirty="0">
+              <a:rPr lang="en-US" sz="1150" dirty="0">
                 <a:solidFill>
                   <a:schemeClr val="tx2"/>
                 </a:solidFill>
               </a:rPr>
-              <a:t>Enrolment is open, any device id can register a key; production binds it to the meter point with a one-time code. The operator board has no login for the demo; production is SSO plus a two-person rule for feeder-level signals. Neither changes the protocol.</a:t>
-            </a:r>
-            <a:endParaRPr lang="en-US" sz="1200" dirty="0"/>
+              <a:t>Frozen as PROTOCOL.md with JSON Schemas for envelope, signal and ack; any vendor can implement the eight functions from it</a:t>
+            </a:r>
+            <a:endParaRPr lang="en-US" sz="1150" dirty="0"/>
           </a:p>
         </p:txBody>
       </p:sp>
@@ -3421,7 +3658,7 @@
                   <a:schemeClr val="tx1"/>
                 </a:solidFill>
               </a:rPr>
-              <a:t>Any vendor, four lines each. Any household, paid on the meter</a:t>
+              <a:t>Security of the control plane: the DSO can ask, it can never command</a:t>
             </a:r>
             <a:endParaRPr lang="en-US" sz="3200" dirty="0"/>
           </a:p>
@@ -3429,18 +3666,18 @@
       </p:sp>
       <p:sp>
         <p:nvSpPr>
-          <p:cNvPr id="3" name="vendors"/>
+          <p:cNvPr id="3" name="sec Authenticity"/>
           <p:cNvSpPr/>
           <p:nvPr/>
         </p:nvSpPr>
         <p:spPr>
           <a:xfrm>
             <a:off x="548640" y="1463040"/>
-            <a:ext cx="5486400" cy="4663440"/>
+            <a:ext cx="5440680" cy="1005840"/>
           </a:xfrm>
           <a:prstGeom prst="roundRect">
             <a:avLst>
-              <a:gd name="adj" fmla="val 1569"/>
+              <a:gd name="adj" fmla="val 7273"/>
             </a:avLst>
           </a:prstGeom>
           <a:solidFill>
@@ -3456,14 +3693,39 @@
       </p:sp>
       <p:sp>
         <p:nvSpPr>
-          <p:cNvPr id="4" name="Text 2"/>
-          <p:cNvSpPr txBox="1"/>
-          <p:nvPr/>
-        </p:nvSpPr>
-        <p:spPr>
-          <a:xfrm>
-            <a:off x="777240" y="1600200"/>
-            <a:ext cx="5029200" cy="365760"/>
+          <p:cNvPr id="4" name="dot"/>
+          <p:cNvSpPr/>
+          <p:nvPr/>
+        </p:nvSpPr>
+        <p:spPr>
+          <a:xfrm>
+            <a:off x="731520" y="1645920"/>
+            <a:ext cx="384048" cy="384048"/>
+          </a:xfrm>
+          <a:prstGeom prst="ellipse">
+            <a:avLst/>
+          </a:prstGeom>
+          <a:solidFill>
+            <a:schemeClr val="accent3"/>
+          </a:solidFill>
+          <a:ln w="12700">
+            <a:solidFill>
+              <a:schemeClr val="accent3"/>
+            </a:solidFill>
+            <a:prstDash val="solid"/>
+          </a:ln>
+        </p:spPr>
+      </p:sp>
+      <p:sp>
+        <p:nvSpPr>
+          <p:cNvPr id="5" name="Text 3"/>
+          <p:cNvSpPr txBox="1"/>
+          <p:nvPr/>
+        </p:nvSpPr>
+        <p:spPr>
+          <a:xfrm>
+            <a:off x="1234440" y="1572768"/>
+            <a:ext cx="4572000" cy="320040"/>
           </a:xfrm>
           <a:prstGeom prst="rect">
             <a:avLst/>
@@ -3479,125 +3741,70 @@
               <a:buNone/>
             </a:pPr>
             <a:r>
-              <a:rPr lang="en-US" sz="1500" b="1" dirty="0">
-                <a:solidFill>
-                  <a:schemeClr val="accent1"/>
-                </a:solidFill>
-              </a:rPr>
-              <a:t>Three paths to the same agent</a:t>
-            </a:r>
-            <a:endParaRPr lang="en-US" sz="1500" dirty="0"/>
-          </a:p>
-        </p:txBody>
-      </p:sp>
-      <p:sp>
-        <p:nvSpPr>
-          <p:cNvPr id="5" name="Text 3"/>
-          <p:cNvSpPr txBox="1"/>
-          <p:nvPr/>
-        </p:nvSpPr>
-        <p:spPr>
-          <a:xfrm>
-            <a:off x="777240" y="2057400"/>
-            <a:ext cx="5029200" cy="3931920"/>
-          </a:xfrm>
-          <a:prstGeom prst="rect">
-            <a:avLst/>
-          </a:prstGeom>
-          <a:noFill/>
-          <a:ln/>
-        </p:spPr>
-        <p:txBody>
-          <a:bodyPr wrap="square" lIns="0" tIns="0" rIns="0" bIns="0" rtlCol="0" anchor="t"/>
-          <a:lstStyle/>
-          <a:p>
-            <a:pPr marL="342900" indent="-342900">
-              <a:spcAft>
-                <a:spcPts val="600"/>
-              </a:spcAft>
-              <a:buSzPct val="100000"/>
-              <a:buChar char="•"/>
-            </a:pPr>
-            <a:r>
-              <a:rPr lang="en-US" sz="1300" dirty="0">
+              <a:rPr lang="en-US" sz="1400" b="1" dirty="0">
                 <a:solidFill>
                   <a:schemeClr val="tx1"/>
                 </a:solidFill>
-              </a:rPr>
-              <a:t>Vendor cloud: GoodWe SEMS, Huawei FusionSolar, SolarEdge, Tesla Fleet, SMA, Fronius. Export limit, discharge to cover load, forced discharge schedule, grid charge schedule</a:t>
-            </a:r>
-            <a:endParaRPr lang="en-US" sz="1300" dirty="0"/>
-          </a:p>
-          <a:p>
-            <a:pPr marL="342900" indent="-342900">
-              <a:spcAft>
-                <a:spcPts val="600"/>
-              </a:spcAft>
-              <a:buSzPct val="100000"/>
-              <a:buChar char="•"/>
-            </a:pPr>
-            <a:r>
-              <a:rPr lang="en-US" sz="1300" dirty="0">
-                <a:solidFill>
-                  <a:schemeClr val="tx1"/>
-                </a:solidFill>
-              </a:rPr>
-              <a:t>Local controller: Home Assistant, EVCC, OpenEMS, SunSpec Modbus. What the demo runs on Node-RED today</a:t>
-            </a:r>
-            <a:endParaRPr lang="en-US" sz="1300" dirty="0"/>
-          </a:p>
-          <a:p>
-            <a:pPr marL="342900" indent="-342900">
-              <a:spcAft>
-                <a:spcPts val="600"/>
-              </a:spcAft>
-              <a:buSzPct val="100000"/>
-              <a:buChar char="•"/>
-            </a:pPr>
-            <a:r>
-              <a:rPr lang="en-US" sz="1300" dirty="0">
-                <a:solidFill>
-                  <a:schemeClr val="tx1"/>
-                </a:solidFill>
-              </a:rPr>
-              <a:t>Standards gateway: EEBus LPC and LPP are literally our import and export caps; OpenADR 3, IEC 61850, OCPP 2.0.1 for chargers</a:t>
-            </a:r>
-            <a:endParaRPr lang="en-US" sz="1300" dirty="0"/>
-          </a:p>
-          <a:p>
-            <a:pPr marL="342900" indent="-342900">
-              <a:spcAft>
-                <a:spcPts val="600"/>
-              </a:spcAft>
-              <a:buSzPct val="100000"/>
-              <a:buChar char="•"/>
-            </a:pPr>
-            <a:r>
-              <a:rPr lang="en-US" sz="1300" dirty="0">
-                <a:solidFill>
-                  <a:schemeClr val="tx1"/>
-                </a:solidFill>
-              </a:rPr>
-              <a:t>GoodWe is one apply function away: the registers and the hardware are on the team</a:t>
-            </a:r>
-            <a:endParaRPr lang="en-US" sz="1300" dirty="0"/>
-          </a:p>
-        </p:txBody>
-      </p:sp>
-      <p:sp>
-        <p:nvSpPr>
-          <p:cNvPr id="6" name="incentives"/>
+                <a:latin typeface="Arial" pitchFamily="34" charset="0"/>
+                <a:ea typeface="Arial" pitchFamily="34" charset="-122"/>
+                <a:cs typeface="Arial" pitchFamily="34" charset="-120"/>
+              </a:rPr>
+              <a:t>Authenticity</a:t>
+            </a:r>
+            <a:endParaRPr lang="en-US" sz="1400" dirty="0"/>
+          </a:p>
+        </p:txBody>
+      </p:sp>
+      <p:sp>
+        <p:nvSpPr>
+          <p:cNvPr id="6" name="Text 4"/>
+          <p:cNvSpPr txBox="1"/>
+          <p:nvPr/>
+        </p:nvSpPr>
+        <p:spPr>
+          <a:xfrm>
+            <a:off x="1234440" y="1892808"/>
+            <a:ext cx="4617720" cy="548640"/>
+          </a:xfrm>
+          <a:prstGeom prst="rect">
+            <a:avLst/>
+          </a:prstGeom>
+          <a:noFill/>
+          <a:ln/>
+        </p:spPr>
+        <p:txBody>
+          <a:bodyPr wrap="square" lIns="0" tIns="0" rIns="0" bIns="0" rtlCol="0" anchor="t"/>
+          <a:lstStyle/>
+          <a:p>
+            <a:pPr indent="0" marL="0">
+              <a:buNone/>
+            </a:pPr>
+            <a:r>
+              <a:rPr lang="en-US" sz="1150" dirty="0">
+                <a:solidFill>
+                  <a:schemeClr val="tx2"/>
+                </a:solidFill>
+              </a:rPr>
+              <a:t>every signal, heartbeat and ack carries an Ed25519 signature; the device pins the platform key and signs with its own</a:t>
+            </a:r>
+            <a:endParaRPr lang="en-US" sz="1150" dirty="0"/>
+          </a:p>
+        </p:txBody>
+      </p:sp>
+      <p:sp>
+        <p:nvSpPr>
+          <p:cNvPr id="7" name="sec Replay"/>
           <p:cNvSpPr/>
           <p:nvPr/>
         </p:nvSpPr>
         <p:spPr>
           <a:xfrm>
             <a:off x="6217920" y="1463040"/>
-            <a:ext cx="5422392" cy="4663440"/>
+            <a:ext cx="5440680" cy="1005840"/>
           </a:xfrm>
           <a:prstGeom prst="roundRect">
             <a:avLst>
-              <a:gd name="adj" fmla="val 1569"/>
+              <a:gd name="adj" fmla="val 7273"/>
             </a:avLst>
           </a:prstGeom>
           <a:solidFill>
@@ -3613,14 +3820,39 @@
       </p:sp>
       <p:sp>
         <p:nvSpPr>
-          <p:cNvPr id="7" name="Text 5"/>
-          <p:cNvSpPr txBox="1"/>
-          <p:nvPr/>
-        </p:nvSpPr>
-        <p:spPr>
-          <a:xfrm>
-            <a:off x="6446520" y="1600200"/>
-            <a:ext cx="5029200" cy="365760"/>
+          <p:cNvPr id="8" name="dot"/>
+          <p:cNvSpPr/>
+          <p:nvPr/>
+        </p:nvSpPr>
+        <p:spPr>
+          <a:xfrm>
+            <a:off x="6400800" y="1645920"/>
+            <a:ext cx="384048" cy="384048"/>
+          </a:xfrm>
+          <a:prstGeom prst="ellipse">
+            <a:avLst/>
+          </a:prstGeom>
+          <a:solidFill>
+            <a:schemeClr val="accent3"/>
+          </a:solidFill>
+          <a:ln w="12700">
+            <a:solidFill>
+              <a:schemeClr val="accent3"/>
+            </a:solidFill>
+            <a:prstDash val="solid"/>
+          </a:ln>
+        </p:spPr>
+      </p:sp>
+      <p:sp>
+        <p:nvSpPr>
+          <p:cNvPr id="9" name="Text 7"/>
+          <p:cNvSpPr txBox="1"/>
+          <p:nvPr/>
+        </p:nvSpPr>
+        <p:spPr>
+          <a:xfrm>
+            <a:off x="6903720" y="1572768"/>
+            <a:ext cx="4572000" cy="320040"/>
           </a:xfrm>
           <a:prstGeom prst="rect">
             <a:avLst/>
@@ -3636,126 +3868,660 @@
               <a:buNone/>
             </a:pPr>
             <a:r>
-              <a:rPr lang="en-US" sz="1500" b="1" dirty="0">
-                <a:solidFill>
-                  <a:schemeClr val="accent3"/>
-                </a:solidFill>
-              </a:rPr>
-              <a:t>Why a DSO pays and a household joins</a:t>
-            </a:r>
-            <a:endParaRPr lang="en-US" sz="1500" dirty="0"/>
-          </a:p>
-        </p:txBody>
-      </p:sp>
-      <p:sp>
-        <p:nvSpPr>
-          <p:cNvPr id="8" name="Text 6"/>
-          <p:cNvSpPr txBox="1"/>
-          <p:nvPr/>
-        </p:nvSpPr>
-        <p:spPr>
-          <a:xfrm>
-            <a:off x="6446520" y="2057400"/>
-            <a:ext cx="4983480" cy="3931920"/>
-          </a:xfrm>
-          <a:prstGeom prst="rect">
-            <a:avLst/>
-          </a:prstGeom>
-          <a:noFill/>
-          <a:ln/>
-        </p:spPr>
-        <p:txBody>
-          <a:bodyPr wrap="square" lIns="0" tIns="0" rIns="0" bIns="0" rtlCol="0" anchor="t"/>
-          <a:lstStyle/>
-          <a:p>
-            <a:pPr marL="342900" indent="-342900">
-              <a:spcAft>
-                <a:spcPts val="600"/>
-              </a:spcAft>
-              <a:buSzPct val="100000"/>
-              <a:buChar char="•"/>
-            </a:pPr>
-            <a:r>
-              <a:rPr lang="en-US" sz="1300" dirty="0">
+              <a:rPr lang="en-US" sz="1400" b="1" dirty="0">
                 <a:solidFill>
                   <a:schemeClr val="tx1"/>
                 </a:solidFill>
-              </a:rPr>
-              <a:t>Limits are verifiable, reductions are not: the DSO's own smart meter answers yes or no per 15-minute interval. No baseline to inflate</a:t>
+                <a:latin typeface="Arial" pitchFamily="34" charset="0"/>
+                <a:ea typeface="Arial" pitchFamily="34" charset="-122"/>
+                <a:cs typeface="Arial" pitchFamily="34" charset="-120"/>
+              </a:rPr>
+              <a:t>Replay</a:t>
+            </a:r>
+            <a:endParaRPr lang="en-US" sz="1400" dirty="0"/>
+          </a:p>
+        </p:txBody>
+      </p:sp>
+      <p:sp>
+        <p:nvSpPr>
+          <p:cNvPr id="10" name="Text 8"/>
+          <p:cNvSpPr txBox="1"/>
+          <p:nvPr/>
+        </p:nvSpPr>
+        <p:spPr>
+          <a:xfrm>
+            <a:off x="6903720" y="1892808"/>
+            <a:ext cx="4617720" cy="548640"/>
+          </a:xfrm>
+          <a:prstGeom prst="rect">
+            <a:avLst/>
+          </a:prstGeom>
+          <a:noFill/>
+          <a:ln/>
+        </p:spPr>
+        <p:txBody>
+          <a:bodyPr wrap="square" lIns="0" tIns="0" rIns="0" bIns="0" rtlCol="0" anchor="t"/>
+          <a:lstStyle/>
+          <a:p>
+            <a:pPr indent="0" marL="0">
+              <a:buNone/>
+            </a:pPr>
+            <a:r>
+              <a:rPr lang="en-US" sz="1150" dirty="0">
+                <a:solidFill>
+                  <a:schemeClr val="tx2"/>
+                </a:solidFill>
+              </a:rPr>
+              <a:t>monotonic sequence numbers persisted on the device, 120 s freshness, heartbeats with sequence and timestamp</a:t>
+            </a:r>
+            <a:endParaRPr lang="en-US" sz="1150" dirty="0"/>
+          </a:p>
+        </p:txBody>
+      </p:sp>
+      <p:sp>
+        <p:nvSpPr>
+          <p:cNvPr id="11" name="sec Bounded"/>
+          <p:cNvSpPr/>
+          <p:nvPr/>
+        </p:nvSpPr>
+        <p:spPr>
+          <a:xfrm>
+            <a:off x="548640" y="2606040"/>
+            <a:ext cx="5440680" cy="1005840"/>
+          </a:xfrm>
+          <a:prstGeom prst="roundRect">
+            <a:avLst>
+              <a:gd name="adj" fmla="val 7273"/>
+            </a:avLst>
+          </a:prstGeom>
+          <a:solidFill>
+            <a:schemeClr val="bg2"/>
+          </a:solidFill>
+          <a:ln w="9525">
+            <a:solidFill>
+              <a:schemeClr val="bg2"/>
+            </a:solidFill>
+            <a:prstDash val="solid"/>
+          </a:ln>
+        </p:spPr>
+      </p:sp>
+      <p:sp>
+        <p:nvSpPr>
+          <p:cNvPr id="12" name="dot"/>
+          <p:cNvSpPr/>
+          <p:nvPr/>
+        </p:nvSpPr>
+        <p:spPr>
+          <a:xfrm>
+            <a:off x="731520" y="2788920"/>
+            <a:ext cx="384048" cy="384048"/>
+          </a:xfrm>
+          <a:prstGeom prst="ellipse">
+            <a:avLst/>
+          </a:prstGeom>
+          <a:solidFill>
+            <a:schemeClr val="accent3"/>
+          </a:solidFill>
+          <a:ln w="12700">
+            <a:solidFill>
+              <a:schemeClr val="accent3"/>
+            </a:solidFill>
+            <a:prstDash val="solid"/>
+          </a:ln>
+        </p:spPr>
+      </p:sp>
+      <p:sp>
+        <p:nvSpPr>
+          <p:cNvPr id="13" name="Text 11"/>
+          <p:cNvSpPr txBox="1"/>
+          <p:nvPr/>
+        </p:nvSpPr>
+        <p:spPr>
+          <a:xfrm>
+            <a:off x="1234440" y="2715768"/>
+            <a:ext cx="4572000" cy="320040"/>
+          </a:xfrm>
+          <a:prstGeom prst="rect">
+            <a:avLst/>
+          </a:prstGeom>
+          <a:noFill/>
+          <a:ln/>
+        </p:spPr>
+        <p:txBody>
+          <a:bodyPr wrap="square" lIns="0" tIns="0" rIns="0" bIns="0" rtlCol="0" anchor="t"/>
+          <a:lstStyle/>
+          <a:p>
+            <a:pPr indent="0" marL="0">
+              <a:buNone/>
+            </a:pPr>
+            <a:r>
+              <a:rPr lang="en-US" sz="1400" b="1" dirty="0">
+                <a:solidFill>
+                  <a:schemeClr val="tx1"/>
+                </a:solidFill>
+                <a:latin typeface="Arial" pitchFamily="34" charset="0"/>
+                <a:ea typeface="Arial" pitchFamily="34" charset="-122"/>
+                <a:cs typeface="Arial" pitchFamily="34" charset="-120"/>
+              </a:rPr>
+              <a:t>Bounded</a:t>
+            </a:r>
+            <a:endParaRPr lang="en-US" sz="1400" dirty="0"/>
+          </a:p>
+        </p:txBody>
+      </p:sp>
+      <p:sp>
+        <p:nvSpPr>
+          <p:cNvPr id="14" name="Text 12"/>
+          <p:cNvSpPr txBox="1"/>
+          <p:nvPr/>
+        </p:nvSpPr>
+        <p:spPr>
+          <a:xfrm>
+            <a:off x="1234440" y="3035808"/>
+            <a:ext cx="4617720" cy="548640"/>
+          </a:xfrm>
+          <a:prstGeom prst="rect">
+            <a:avLst/>
+          </a:prstGeom>
+          <a:noFill/>
+          <a:ln/>
+        </p:spPr>
+        <p:txBody>
+          <a:bodyPr wrap="square" lIns="0" tIns="0" rIns="0" bIns="0" rtlCol="0" anchor="t"/>
+          <a:lstStyle/>
+          <a:p>
+            <a:pPr indent="0" marL="0">
+              <a:buNone/>
+            </a:pPr>
+            <a:r>
+              <a:rPr lang="en-US" sz="1150" dirty="0">
+                <a:solidFill>
+                  <a:schemeClr val="tx2"/>
+                </a:solidFill>
+              </a:rPr>
+              <a:t>limits, never setpoints; four-hour window enforced on the device itself; depth and rate capped by the guard</a:t>
+            </a:r>
+            <a:endParaRPr lang="en-US" sz="1150" dirty="0"/>
+          </a:p>
+        </p:txBody>
+      </p:sp>
+      <p:sp>
+        <p:nvSpPr>
+          <p:cNvPr id="15" name="sec Owner veto"/>
+          <p:cNvSpPr/>
+          <p:nvPr/>
+        </p:nvSpPr>
+        <p:spPr>
+          <a:xfrm>
+            <a:off x="6217920" y="2606040"/>
+            <a:ext cx="5440680" cy="1005840"/>
+          </a:xfrm>
+          <a:prstGeom prst="roundRect">
+            <a:avLst>
+              <a:gd name="adj" fmla="val 7273"/>
+            </a:avLst>
+          </a:prstGeom>
+          <a:solidFill>
+            <a:schemeClr val="bg2"/>
+          </a:solidFill>
+          <a:ln w="9525">
+            <a:solidFill>
+              <a:schemeClr val="bg2"/>
+            </a:solidFill>
+            <a:prstDash val="solid"/>
+          </a:ln>
+        </p:spPr>
+      </p:sp>
+      <p:sp>
+        <p:nvSpPr>
+          <p:cNvPr id="16" name="dot"/>
+          <p:cNvSpPr/>
+          <p:nvPr/>
+        </p:nvSpPr>
+        <p:spPr>
+          <a:xfrm>
+            <a:off x="6400800" y="2788920"/>
+            <a:ext cx="384048" cy="384048"/>
+          </a:xfrm>
+          <a:prstGeom prst="ellipse">
+            <a:avLst/>
+          </a:prstGeom>
+          <a:solidFill>
+            <a:schemeClr val="accent3"/>
+          </a:solidFill>
+          <a:ln w="12700">
+            <a:solidFill>
+              <a:schemeClr val="accent3"/>
+            </a:solidFill>
+            <a:prstDash val="solid"/>
+          </a:ln>
+        </p:spPr>
+      </p:sp>
+      <p:sp>
+        <p:nvSpPr>
+          <p:cNvPr id="17" name="Text 15"/>
+          <p:cNvSpPr txBox="1"/>
+          <p:nvPr/>
+        </p:nvSpPr>
+        <p:spPr>
+          <a:xfrm>
+            <a:off x="6903720" y="2715768"/>
+            <a:ext cx="4572000" cy="320040"/>
+          </a:xfrm>
+          <a:prstGeom prst="rect">
+            <a:avLst/>
+          </a:prstGeom>
+          <a:noFill/>
+          <a:ln/>
+        </p:spPr>
+        <p:txBody>
+          <a:bodyPr wrap="square" lIns="0" tIns="0" rIns="0" bIns="0" rtlCol="0" anchor="t"/>
+          <a:lstStyle/>
+          <a:p>
+            <a:pPr indent="0" marL="0">
+              <a:buNone/>
+            </a:pPr>
+            <a:r>
+              <a:rPr lang="en-US" sz="1400" b="1" dirty="0">
+                <a:solidFill>
+                  <a:schemeClr val="tx1"/>
+                </a:solidFill>
+                <a:latin typeface="Arial" pitchFamily="34" charset="0"/>
+                <a:ea typeface="Arial" pitchFamily="34" charset="-122"/>
+                <a:cs typeface="Arial" pitchFamily="34" charset="-120"/>
+              </a:rPr>
+              <a:t>Owner veto</a:t>
+            </a:r>
+            <a:endParaRPr lang="en-US" sz="1400" dirty="0"/>
+          </a:p>
+        </p:txBody>
+      </p:sp>
+      <p:sp>
+        <p:nvSpPr>
+          <p:cNvPr id="18" name="Text 16"/>
+          <p:cNvSpPr txBox="1"/>
+          <p:nvPr/>
+        </p:nvSpPr>
+        <p:spPr>
+          <a:xfrm>
+            <a:off x="6903720" y="3035808"/>
+            <a:ext cx="4617720" cy="548640"/>
+          </a:xfrm>
+          <a:prstGeom prst="rect">
+            <a:avLst/>
+          </a:prstGeom>
+          <a:noFill/>
+          <a:ln/>
+        </p:spPr>
+        <p:txBody>
+          <a:bodyPr wrap="square" lIns="0" tIns="0" rIns="0" bIns="0" rtlCol="0" anchor="t"/>
+          <a:lstStyle/>
+          <a:p>
+            <a:pPr indent="0" marL="0">
+              <a:buNone/>
+            </a:pPr>
+            <a:r>
+              <a:rPr lang="en-US" sz="1150" dirty="0">
+                <a:solidFill>
+                  <a:schemeClr val="tx2"/>
+                </a:solidFill>
+              </a:rPr>
+              <a:t>minimum SoC, max current, opt-out merged on the device; a compromised DSO key moves nothing past them</a:t>
+            </a:r>
+            <a:endParaRPr lang="en-US" sz="1150" dirty="0"/>
+          </a:p>
+        </p:txBody>
+      </p:sp>
+      <p:sp>
+        <p:nvSpPr>
+          <p:cNvPr id="19" name="sec Fail-safe"/>
+          <p:cNvSpPr/>
+          <p:nvPr/>
+        </p:nvSpPr>
+        <p:spPr>
+          <a:xfrm>
+            <a:off x="548640" y="3749040"/>
+            <a:ext cx="5440680" cy="1005840"/>
+          </a:xfrm>
+          <a:prstGeom prst="roundRect">
+            <a:avLst>
+              <a:gd name="adj" fmla="val 7273"/>
+            </a:avLst>
+          </a:prstGeom>
+          <a:solidFill>
+            <a:schemeClr val="bg2"/>
+          </a:solidFill>
+          <a:ln w="9525">
+            <a:solidFill>
+              <a:schemeClr val="bg2"/>
+            </a:solidFill>
+            <a:prstDash val="solid"/>
+          </a:ln>
+        </p:spPr>
+      </p:sp>
+      <p:sp>
+        <p:nvSpPr>
+          <p:cNvPr id="20" name="dot"/>
+          <p:cNvSpPr/>
+          <p:nvPr/>
+        </p:nvSpPr>
+        <p:spPr>
+          <a:xfrm>
+            <a:off x="731520" y="3931920"/>
+            <a:ext cx="384048" cy="384048"/>
+          </a:xfrm>
+          <a:prstGeom prst="ellipse">
+            <a:avLst/>
+          </a:prstGeom>
+          <a:solidFill>
+            <a:schemeClr val="accent3"/>
+          </a:solidFill>
+          <a:ln w="12700">
+            <a:solidFill>
+              <a:schemeClr val="accent3"/>
+            </a:solidFill>
+            <a:prstDash val="solid"/>
+          </a:ln>
+        </p:spPr>
+      </p:sp>
+      <p:sp>
+        <p:nvSpPr>
+          <p:cNvPr id="21" name="Text 19"/>
+          <p:cNvSpPr txBox="1"/>
+          <p:nvPr/>
+        </p:nvSpPr>
+        <p:spPr>
+          <a:xfrm>
+            <a:off x="1234440" y="3858768"/>
+            <a:ext cx="4572000" cy="320040"/>
+          </a:xfrm>
+          <a:prstGeom prst="rect">
+            <a:avLst/>
+          </a:prstGeom>
+          <a:noFill/>
+          <a:ln/>
+        </p:spPr>
+        <p:txBody>
+          <a:bodyPr wrap="square" lIns="0" tIns="0" rIns="0" bIns="0" rtlCol="0" anchor="t"/>
+          <a:lstStyle/>
+          <a:p>
+            <a:pPr indent="0" marL="0">
+              <a:buNone/>
+            </a:pPr>
+            <a:r>
+              <a:rPr lang="en-US" sz="1400" b="1" dirty="0">
+                <a:solidFill>
+                  <a:schemeClr val="tx1"/>
+                </a:solidFill>
+                <a:latin typeface="Arial" pitchFamily="34" charset="0"/>
+                <a:ea typeface="Arial" pitchFamily="34" charset="-122"/>
+                <a:cs typeface="Arial" pitchFamily="34" charset="-120"/>
+              </a:rPr>
+              <a:t>Fail-safe</a:t>
+            </a:r>
+            <a:endParaRPr lang="en-US" sz="1400" dirty="0"/>
+          </a:p>
+        </p:txBody>
+      </p:sp>
+      <p:sp>
+        <p:nvSpPr>
+          <p:cNvPr id="22" name="Text 20"/>
+          <p:cNvSpPr txBox="1"/>
+          <p:nvPr/>
+        </p:nvSpPr>
+        <p:spPr>
+          <a:xfrm>
+            <a:off x="1234440" y="4178808"/>
+            <a:ext cx="4617720" cy="548640"/>
+          </a:xfrm>
+          <a:prstGeom prst="rect">
+            <a:avLst/>
+          </a:prstGeom>
+          <a:noFill/>
+          <a:ln/>
+        </p:spPr>
+        <p:txBody>
+          <a:bodyPr wrap="square" lIns="0" tIns="0" rIns="0" bIns="0" rtlCol="0" anchor="t"/>
+          <a:lstStyle/>
+          <a:p>
+            <a:pPr indent="0" marL="0">
+              <a:buNone/>
+            </a:pPr>
+            <a:r>
+              <a:rPr lang="en-US" sz="1150" dirty="0">
+                <a:solidFill>
+                  <a:schemeClr val="tx2"/>
+                </a:solidFill>
+              </a:rPr>
+              <a:t>window end, heartbeat loss or RELEASE restore the owner's settings; a dead platform leaves every house in owner mode</a:t>
+            </a:r>
+            <a:endParaRPr lang="en-US" sz="1150" dirty="0"/>
+          </a:p>
+        </p:txBody>
+      </p:sp>
+      <p:sp>
+        <p:nvSpPr>
+          <p:cNvPr id="23" name="sec Transport"/>
+          <p:cNvSpPr/>
+          <p:nvPr/>
+        </p:nvSpPr>
+        <p:spPr>
+          <a:xfrm>
+            <a:off x="6217920" y="3749040"/>
+            <a:ext cx="5440680" cy="1005840"/>
+          </a:xfrm>
+          <a:prstGeom prst="roundRect">
+            <a:avLst>
+              <a:gd name="adj" fmla="val 7273"/>
+            </a:avLst>
+          </a:prstGeom>
+          <a:solidFill>
+            <a:schemeClr val="bg2"/>
+          </a:solidFill>
+          <a:ln w="9525">
+            <a:solidFill>
+              <a:schemeClr val="bg2"/>
+            </a:solidFill>
+            <a:prstDash val="solid"/>
+          </a:ln>
+        </p:spPr>
+      </p:sp>
+      <p:sp>
+        <p:nvSpPr>
+          <p:cNvPr id="24" name="dot"/>
+          <p:cNvSpPr/>
+          <p:nvPr/>
+        </p:nvSpPr>
+        <p:spPr>
+          <a:xfrm>
+            <a:off x="6400800" y="3931920"/>
+            <a:ext cx="384048" cy="384048"/>
+          </a:xfrm>
+          <a:prstGeom prst="ellipse">
+            <a:avLst/>
+          </a:prstGeom>
+          <a:solidFill>
+            <a:schemeClr val="accent3"/>
+          </a:solidFill>
+          <a:ln w="12700">
+            <a:solidFill>
+              <a:schemeClr val="accent3"/>
+            </a:solidFill>
+            <a:prstDash val="solid"/>
+          </a:ln>
+        </p:spPr>
+      </p:sp>
+      <p:sp>
+        <p:nvSpPr>
+          <p:cNvPr id="25" name="Text 23"/>
+          <p:cNvSpPr txBox="1"/>
+          <p:nvPr/>
+        </p:nvSpPr>
+        <p:spPr>
+          <a:xfrm>
+            <a:off x="6903720" y="3858768"/>
+            <a:ext cx="4572000" cy="320040"/>
+          </a:xfrm>
+          <a:prstGeom prst="rect">
+            <a:avLst/>
+          </a:prstGeom>
+          <a:noFill/>
+          <a:ln/>
+        </p:spPr>
+        <p:txBody>
+          <a:bodyPr wrap="square" lIns="0" tIns="0" rIns="0" bIns="0" rtlCol="0" anchor="t"/>
+          <a:lstStyle/>
+          <a:p>
+            <a:pPr indent="0" marL="0">
+              <a:buNone/>
+            </a:pPr>
+            <a:r>
+              <a:rPr lang="en-US" sz="1400" b="1" dirty="0">
+                <a:solidFill>
+                  <a:schemeClr val="tx1"/>
+                </a:solidFill>
+                <a:latin typeface="Arial" pitchFamily="34" charset="0"/>
+                <a:ea typeface="Arial" pitchFamily="34" charset="-122"/>
+                <a:cs typeface="Arial" pitchFamily="34" charset="-120"/>
+              </a:rPr>
+              <a:t>Transport</a:t>
+            </a:r>
+            <a:endParaRPr lang="en-US" sz="1400" dirty="0"/>
+          </a:p>
+        </p:txBody>
+      </p:sp>
+      <p:sp>
+        <p:nvSpPr>
+          <p:cNvPr id="26" name="Text 24"/>
+          <p:cNvSpPr txBox="1"/>
+          <p:nvPr/>
+        </p:nvSpPr>
+        <p:spPr>
+          <a:xfrm>
+            <a:off x="6903720" y="4178808"/>
+            <a:ext cx="4617720" cy="548640"/>
+          </a:xfrm>
+          <a:prstGeom prst="rect">
+            <a:avLst/>
+          </a:prstGeom>
+          <a:noFill/>
+          <a:ln/>
+        </p:spPr>
+        <p:txBody>
+          <a:bodyPr wrap="square" lIns="0" tIns="0" rIns="0" bIns="0" rtlCol="0" anchor="t"/>
+          <a:lstStyle/>
+          <a:p>
+            <a:pPr indent="0" marL="0">
+              <a:buNone/>
+            </a:pPr>
+            <a:r>
+              <a:rPr lang="en-US" sz="1150" dirty="0">
+                <a:solidFill>
+                  <a:schemeClr val="tx2"/>
+                </a:solidFill>
+              </a:rPr>
+              <a:t>TLS with a real certificate, per-role credentials, topic ACLs; a device cannot publish a signal even if it tried</a:t>
+            </a:r>
+            <a:endParaRPr lang="en-US" sz="1150" dirty="0"/>
+          </a:p>
+        </p:txBody>
+      </p:sp>
+      <p:sp>
+        <p:nvSpPr>
+          <p:cNvPr id="27" name="open items"/>
+          <p:cNvSpPr/>
+          <p:nvPr/>
+        </p:nvSpPr>
+        <p:spPr>
+          <a:xfrm>
+            <a:off x="548640" y="5029200"/>
+            <a:ext cx="11091672" cy="1143000"/>
+          </a:xfrm>
+          <a:prstGeom prst="roundRect">
+            <a:avLst>
+              <a:gd name="adj" fmla="val 6400"/>
+            </a:avLst>
+          </a:prstGeom>
+          <a:solidFill>
+            <a:srgbClr val="1D2127"/>
+          </a:solidFill>
+          <a:ln w="9525">
+            <a:solidFill>
+              <a:srgbClr val="C98500"/>
+            </a:solidFill>
+            <a:prstDash val="solid"/>
+          </a:ln>
+        </p:spPr>
+      </p:sp>
+      <p:sp>
+        <p:nvSpPr>
+          <p:cNvPr id="28" name="Text 26"/>
+          <p:cNvSpPr txBox="1"/>
+          <p:nvPr/>
+        </p:nvSpPr>
+        <p:spPr>
+          <a:xfrm>
+            <a:off x="777240" y="5120640"/>
+            <a:ext cx="3657600" cy="320040"/>
+          </a:xfrm>
+          <a:prstGeom prst="rect">
+            <a:avLst/>
+          </a:prstGeom>
+          <a:noFill/>
+          <a:ln/>
+        </p:spPr>
+        <p:txBody>
+          <a:bodyPr wrap="square" lIns="0" tIns="0" rIns="0" bIns="0" rtlCol="0" anchor="t"/>
+          <a:lstStyle/>
+          <a:p>
+            <a:pPr indent="0" marL="0">
+              <a:buNone/>
+            </a:pPr>
+            <a:r>
+              <a:rPr lang="en-US" sz="1300" b="1" dirty="0">
+                <a:solidFill>
+                  <a:schemeClr val="accent6"/>
+                </a:solidFill>
+              </a:rPr>
+              <a:t>Named before you ask</a:t>
             </a:r>
             <a:endParaRPr lang="en-US" sz="1300" dirty="0"/>
           </a:p>
-          <a:p>
-            <a:pPr marL="342900" indent="-342900">
-              <a:spcAft>
-                <a:spcPts val="600"/>
-              </a:spcAft>
-              <a:buSzPct val="100000"/>
-              <a:buChar char="•"/>
-            </a:pPr>
-            <a:r>
-              <a:rPr lang="en-US" sz="1300" dirty="0">
-                <a:solidFill>
-                  <a:schemeClr val="tx1"/>
-                </a:solidFill>
-              </a:rPr>
-              <a:t>No ack, no pay; compliance gates the perks; the DSO's existing disconnect is the backstop in a crisis</a:t>
-            </a:r>
-            <a:endParaRPr lang="en-US" sz="1300" dirty="0"/>
-          </a:p>
-          <a:p>
-            <a:pPr marL="342900" indent="-342900">
-              <a:spcAft>
-                <a:spcPts val="600"/>
-              </a:spcAft>
-              <a:buSzPct val="100000"/>
-              <a:buChar char="•"/>
-            </a:pPr>
-            <a:r>
-              <a:rPr lang="en-US" sz="1300" dirty="0">
-                <a:solidFill>
-                  <a:schemeClr val="tx1"/>
-                </a:solidFill>
-              </a:rPr>
-              <a:t>The hook: a dynamic export limit beats today's static cap on all but a few afternoons, and gets a refused connection approved</a:t>
-            </a:r>
-            <a:endParaRPr lang="en-US" sz="1300" dirty="0"/>
-          </a:p>
-          <a:p>
-            <a:pPr marL="342900" indent="-342900">
-              <a:spcAft>
-                <a:spcPts val="600"/>
-              </a:spcAft>
-              <a:buSzPct val="100000"/>
-              <a:buChar char="•"/>
-            </a:pPr>
-            <a:r>
-              <a:rPr lang="en-US" sz="1300" dirty="0">
-                <a:solidFill>
-                  <a:schemeClr val="tx1"/>
-                </a:solidFill>
-              </a:rPr>
-              <a:t>Plus an availability fee, per-kWh payment for forced feed-in, a full battery before an outage, and a shorter shedding queue</a:t>
-            </a:r>
-            <a:endParaRPr lang="en-US" sz="1300" dirty="0"/>
-          </a:p>
-          <a:p>
-            <a:pPr marL="342900" indent="-342900">
-              <a:spcAft>
-                <a:spcPts val="600"/>
-              </a:spcAft>
-              <a:buSzPct val="100000"/>
-              <a:buChar char="•"/>
-            </a:pPr>
-            <a:r>
-              <a:rPr lang="en-US" sz="1300" dirty="0">
-                <a:solidFill>
-                  <a:schemeClr val="tx1"/>
-                </a:solidFill>
-              </a:rPr>
-              <a:t>Noon export is worthless when everyone exports; the same kilowatt-hours leave at six, paid</a:t>
-            </a:r>
-            <a:endParaRPr lang="en-US" sz="1300" dirty="0"/>
+        </p:txBody>
+      </p:sp>
+      <p:sp>
+        <p:nvSpPr>
+          <p:cNvPr id="29" name="Text 27"/>
+          <p:cNvSpPr txBox="1"/>
+          <p:nvPr/>
+        </p:nvSpPr>
+        <p:spPr>
+          <a:xfrm>
+            <a:off x="777240" y="5440680"/>
+            <a:ext cx="10634472" cy="685800"/>
+          </a:xfrm>
+          <a:prstGeom prst="rect">
+            <a:avLst/>
+          </a:prstGeom>
+          <a:noFill/>
+          <a:ln/>
+        </p:spPr>
+        <p:txBody>
+          <a:bodyPr wrap="square" lIns="0" tIns="0" rIns="0" bIns="0" rtlCol="0" anchor="t"/>
+          <a:lstStyle/>
+          <a:p>
+            <a:pPr indent="0" marL="0">
+              <a:buNone/>
+            </a:pPr>
+            <a:r>
+              <a:rPr lang="en-US" sz="1200" dirty="0">
+                <a:solidFill>
+                  <a:schemeClr val="tx2"/>
+                </a:solidFill>
+              </a:rPr>
+              <a:t>Enrolment is open, any device id can register a key; production binds it to the meter point with a one-time code. The operator board has no login for the demo; production is SSO plus a two-person rule for feeder-level signals. Neither changes the protocol.</a:t>
+            </a:r>
+            <a:endParaRPr lang="en-US" sz="1200" dirty="0"/>
           </a:p>
         </p:txBody>
       </p:sp>
@@ -3831,6 +4597,446 @@
       </p:grpSpPr>
       <p:sp>
         <p:nvSpPr>
+          <p:cNvPr id="2" name="Text 0"/>
+          <p:cNvSpPr/>
+          <p:nvPr>
+            <p:ph idx="100" type="title" hasCustomPrompt="1"/>
+          </p:nvPr>
+        </p:nvSpPr>
+        <p:spPr>
+          <a:xfrm>
+            <a:off x="548640" y="411480"/>
+            <a:ext cx="11091672" cy="822960"/>
+          </a:xfrm>
+          <a:prstGeom prst="rect">
+            <a:avLst/>
+          </a:prstGeom>
+          <a:noFill/>
+          <a:ln/>
+        </p:spPr>
+        <p:txBody>
+          <a:bodyPr wrap="square" lIns="0" tIns="0" rIns="0" bIns="0" rtlCol="0" anchor="ctr"/>
+          <a:lstStyle/>
+          <a:p>
+            <a:pPr algn="l" indent="0" marL="0">
+              <a:buNone/>
+            </a:pPr>
+            <a:r>
+              <a:rPr lang="en-US" sz="3200" b="1" dirty="0">
+                <a:solidFill>
+                  <a:schemeClr val="tx1"/>
+                </a:solidFill>
+              </a:rPr>
+              <a:t>Any vendor, four lines each. Any household, paid on the meter</a:t>
+            </a:r>
+            <a:endParaRPr lang="en-US" sz="3200" dirty="0"/>
+          </a:p>
+        </p:txBody>
+      </p:sp>
+      <p:sp>
+        <p:nvSpPr>
+          <p:cNvPr id="3" name="vendors"/>
+          <p:cNvSpPr/>
+          <p:nvPr/>
+        </p:nvSpPr>
+        <p:spPr>
+          <a:xfrm>
+            <a:off x="548640" y="1463040"/>
+            <a:ext cx="5486400" cy="4663440"/>
+          </a:xfrm>
+          <a:prstGeom prst="roundRect">
+            <a:avLst>
+              <a:gd name="adj" fmla="val 1569"/>
+            </a:avLst>
+          </a:prstGeom>
+          <a:solidFill>
+            <a:schemeClr val="bg2"/>
+          </a:solidFill>
+          <a:ln w="9525">
+            <a:solidFill>
+              <a:schemeClr val="bg2"/>
+            </a:solidFill>
+            <a:prstDash val="solid"/>
+          </a:ln>
+        </p:spPr>
+      </p:sp>
+      <p:sp>
+        <p:nvSpPr>
+          <p:cNvPr id="4" name="Text 2"/>
+          <p:cNvSpPr txBox="1"/>
+          <p:nvPr/>
+        </p:nvSpPr>
+        <p:spPr>
+          <a:xfrm>
+            <a:off x="777240" y="1600200"/>
+            <a:ext cx="5029200" cy="365760"/>
+          </a:xfrm>
+          <a:prstGeom prst="rect">
+            <a:avLst/>
+          </a:prstGeom>
+          <a:noFill/>
+          <a:ln/>
+        </p:spPr>
+        <p:txBody>
+          <a:bodyPr wrap="square" lIns="0" tIns="0" rIns="0" bIns="0" rtlCol="0" anchor="t"/>
+          <a:lstStyle/>
+          <a:p>
+            <a:pPr indent="0" marL="0">
+              <a:buNone/>
+            </a:pPr>
+            <a:r>
+              <a:rPr lang="en-US" sz="1500" b="1" dirty="0">
+                <a:solidFill>
+                  <a:schemeClr val="accent1"/>
+                </a:solidFill>
+              </a:rPr>
+              <a:t>Three paths to the same agent</a:t>
+            </a:r>
+            <a:endParaRPr lang="en-US" sz="1500" dirty="0"/>
+          </a:p>
+        </p:txBody>
+      </p:sp>
+      <p:sp>
+        <p:nvSpPr>
+          <p:cNvPr id="5" name="Text 3"/>
+          <p:cNvSpPr txBox="1"/>
+          <p:nvPr/>
+        </p:nvSpPr>
+        <p:spPr>
+          <a:xfrm>
+            <a:off x="777240" y="2057400"/>
+            <a:ext cx="5029200" cy="3931920"/>
+          </a:xfrm>
+          <a:prstGeom prst="rect">
+            <a:avLst/>
+          </a:prstGeom>
+          <a:noFill/>
+          <a:ln/>
+        </p:spPr>
+        <p:txBody>
+          <a:bodyPr wrap="square" lIns="0" tIns="0" rIns="0" bIns="0" rtlCol="0" anchor="t"/>
+          <a:lstStyle/>
+          <a:p>
+            <a:pPr marL="342900" indent="-342900">
+              <a:spcAft>
+                <a:spcPts val="600"/>
+              </a:spcAft>
+              <a:buSzPct val="100000"/>
+              <a:buChar char="•"/>
+            </a:pPr>
+            <a:r>
+              <a:rPr lang="en-US" sz="1300" dirty="0">
+                <a:solidFill>
+                  <a:schemeClr val="tx1"/>
+                </a:solidFill>
+              </a:rPr>
+              <a:t>Vendor cloud: GoodWe SEMS, Huawei FusionSolar, SolarEdge, Tesla Fleet, SMA, Fronius. Export limit, discharge to cover load, forced discharge schedule, grid charge schedule</a:t>
+            </a:r>
+            <a:endParaRPr lang="en-US" sz="1300" dirty="0"/>
+          </a:p>
+          <a:p>
+            <a:pPr marL="342900" indent="-342900">
+              <a:spcAft>
+                <a:spcPts val="600"/>
+              </a:spcAft>
+              <a:buSzPct val="100000"/>
+              <a:buChar char="•"/>
+            </a:pPr>
+            <a:r>
+              <a:rPr lang="en-US" sz="1300" dirty="0">
+                <a:solidFill>
+                  <a:schemeClr val="tx1"/>
+                </a:solidFill>
+              </a:rPr>
+              <a:t>Local controller: Home Assistant, EVCC, OpenEMS, SunSpec Modbus. What the demo runs on Node-RED today</a:t>
+            </a:r>
+            <a:endParaRPr lang="en-US" sz="1300" dirty="0"/>
+          </a:p>
+          <a:p>
+            <a:pPr marL="342900" indent="-342900">
+              <a:spcAft>
+                <a:spcPts val="600"/>
+              </a:spcAft>
+              <a:buSzPct val="100000"/>
+              <a:buChar char="•"/>
+            </a:pPr>
+            <a:r>
+              <a:rPr lang="en-US" sz="1300" dirty="0">
+                <a:solidFill>
+                  <a:schemeClr val="tx1"/>
+                </a:solidFill>
+              </a:rPr>
+              <a:t>Standards gateway: EEBus LPC and LPP are literally our import and export caps; OpenADR 3, IEC 61850, OCPP 2.0.1 for chargers</a:t>
+            </a:r>
+            <a:endParaRPr lang="en-US" sz="1300" dirty="0"/>
+          </a:p>
+          <a:p>
+            <a:pPr marL="342900" indent="-342900">
+              <a:spcAft>
+                <a:spcPts val="600"/>
+              </a:spcAft>
+              <a:buSzPct val="100000"/>
+              <a:buChar char="•"/>
+            </a:pPr>
+            <a:r>
+              <a:rPr lang="en-US" sz="1300" dirty="0">
+                <a:solidFill>
+                  <a:schemeClr val="tx1"/>
+                </a:solidFill>
+              </a:rPr>
+              <a:t>GoodWe is one apply function away: the registers and the hardware are on the team</a:t>
+            </a:r>
+            <a:endParaRPr lang="en-US" sz="1300" dirty="0"/>
+          </a:p>
+        </p:txBody>
+      </p:sp>
+      <p:sp>
+        <p:nvSpPr>
+          <p:cNvPr id="6" name="incentives"/>
+          <p:cNvSpPr/>
+          <p:nvPr/>
+        </p:nvSpPr>
+        <p:spPr>
+          <a:xfrm>
+            <a:off x="6217920" y="1463040"/>
+            <a:ext cx="5422392" cy="4663440"/>
+          </a:xfrm>
+          <a:prstGeom prst="roundRect">
+            <a:avLst>
+              <a:gd name="adj" fmla="val 1569"/>
+            </a:avLst>
+          </a:prstGeom>
+          <a:solidFill>
+            <a:schemeClr val="bg2"/>
+          </a:solidFill>
+          <a:ln w="9525">
+            <a:solidFill>
+              <a:schemeClr val="bg2"/>
+            </a:solidFill>
+            <a:prstDash val="solid"/>
+          </a:ln>
+        </p:spPr>
+      </p:sp>
+      <p:sp>
+        <p:nvSpPr>
+          <p:cNvPr id="7" name="Text 5"/>
+          <p:cNvSpPr txBox="1"/>
+          <p:nvPr/>
+        </p:nvSpPr>
+        <p:spPr>
+          <a:xfrm>
+            <a:off x="6446520" y="1600200"/>
+            <a:ext cx="5029200" cy="365760"/>
+          </a:xfrm>
+          <a:prstGeom prst="rect">
+            <a:avLst/>
+          </a:prstGeom>
+          <a:noFill/>
+          <a:ln/>
+        </p:spPr>
+        <p:txBody>
+          <a:bodyPr wrap="square" lIns="0" tIns="0" rIns="0" bIns="0" rtlCol="0" anchor="t"/>
+          <a:lstStyle/>
+          <a:p>
+            <a:pPr indent="0" marL="0">
+              <a:buNone/>
+            </a:pPr>
+            <a:r>
+              <a:rPr lang="en-US" sz="1500" b="1" dirty="0">
+                <a:solidFill>
+                  <a:schemeClr val="accent3"/>
+                </a:solidFill>
+              </a:rPr>
+              <a:t>Why a DSO pays and a household joins</a:t>
+            </a:r>
+            <a:endParaRPr lang="en-US" sz="1500" dirty="0"/>
+          </a:p>
+        </p:txBody>
+      </p:sp>
+      <p:sp>
+        <p:nvSpPr>
+          <p:cNvPr id="8" name="Text 6"/>
+          <p:cNvSpPr txBox="1"/>
+          <p:nvPr/>
+        </p:nvSpPr>
+        <p:spPr>
+          <a:xfrm>
+            <a:off x="6446520" y="2057400"/>
+            <a:ext cx="4983480" cy="3931920"/>
+          </a:xfrm>
+          <a:prstGeom prst="rect">
+            <a:avLst/>
+          </a:prstGeom>
+          <a:noFill/>
+          <a:ln/>
+        </p:spPr>
+        <p:txBody>
+          <a:bodyPr wrap="square" lIns="0" tIns="0" rIns="0" bIns="0" rtlCol="0" anchor="t"/>
+          <a:lstStyle/>
+          <a:p>
+            <a:pPr marL="342900" indent="-342900">
+              <a:spcAft>
+                <a:spcPts val="600"/>
+              </a:spcAft>
+              <a:buSzPct val="100000"/>
+              <a:buChar char="•"/>
+            </a:pPr>
+            <a:r>
+              <a:rPr lang="en-US" sz="1300" dirty="0">
+                <a:solidFill>
+                  <a:schemeClr val="tx1"/>
+                </a:solidFill>
+              </a:rPr>
+              <a:t>Limits are verifiable, reductions are not: the DSO's own smart meter answers yes or no per 15-minute interval. No baseline to inflate</a:t>
+            </a:r>
+            <a:endParaRPr lang="en-US" sz="1300" dirty="0"/>
+          </a:p>
+          <a:p>
+            <a:pPr marL="342900" indent="-342900">
+              <a:spcAft>
+                <a:spcPts val="600"/>
+              </a:spcAft>
+              <a:buSzPct val="100000"/>
+              <a:buChar char="•"/>
+            </a:pPr>
+            <a:r>
+              <a:rPr lang="en-US" sz="1300" dirty="0">
+                <a:solidFill>
+                  <a:schemeClr val="tx1"/>
+                </a:solidFill>
+              </a:rPr>
+              <a:t>No ack, no pay; compliance gates the perks; the DSO's existing disconnect is the backstop in a crisis</a:t>
+            </a:r>
+            <a:endParaRPr lang="en-US" sz="1300" dirty="0"/>
+          </a:p>
+          <a:p>
+            <a:pPr marL="342900" indent="-342900">
+              <a:spcAft>
+                <a:spcPts val="600"/>
+              </a:spcAft>
+              <a:buSzPct val="100000"/>
+              <a:buChar char="•"/>
+            </a:pPr>
+            <a:r>
+              <a:rPr lang="en-US" sz="1300" dirty="0">
+                <a:solidFill>
+                  <a:schemeClr val="tx1"/>
+                </a:solidFill>
+              </a:rPr>
+              <a:t>The hook: a dynamic export limit beats today's static cap on all but a few afternoons, and gets a refused connection approved</a:t>
+            </a:r>
+            <a:endParaRPr lang="en-US" sz="1300" dirty="0"/>
+          </a:p>
+          <a:p>
+            <a:pPr marL="342900" indent="-342900">
+              <a:spcAft>
+                <a:spcPts val="600"/>
+              </a:spcAft>
+              <a:buSzPct val="100000"/>
+              <a:buChar char="•"/>
+            </a:pPr>
+            <a:r>
+              <a:rPr lang="en-US" sz="1300" dirty="0">
+                <a:solidFill>
+                  <a:schemeClr val="tx1"/>
+                </a:solidFill>
+              </a:rPr>
+              <a:t>Plus an availability fee, per-kWh payment for forced feed-in, a full battery before an outage, and a shorter shedding queue</a:t>
+            </a:r>
+            <a:endParaRPr lang="en-US" sz="1300" dirty="0"/>
+          </a:p>
+          <a:p>
+            <a:pPr marL="342900" indent="-342900">
+              <a:spcAft>
+                <a:spcPts val="600"/>
+              </a:spcAft>
+              <a:buSzPct val="100000"/>
+              <a:buChar char="•"/>
+            </a:pPr>
+            <a:r>
+              <a:rPr lang="en-US" sz="1300" dirty="0">
+                <a:solidFill>
+                  <a:schemeClr val="tx1"/>
+                </a:solidFill>
+              </a:rPr>
+              <a:t>Noon export is worthless when everyone exports; the same kilowatt-hours leave at six, paid</a:t>
+            </a:r>
+            <a:endParaRPr lang="en-US" sz="1300" dirty="0"/>
+          </a:p>
+        </p:txBody>
+      </p:sp>
+      <p:sp>
+        <p:nvSpPr>
+          <p:cNvPr id="25" name="Slide Number Placeholder 0"/>
+          <p:cNvSpPr>
+            <a:spLocks noGrp="1"/>
+          </p:cNvSpPr>
+          <p:nvPr>
+            <p:ph type="sldNum" sz="quarter" idx="4294967295"/>
+          </p:nvPr>
+        </p:nvSpPr>
+        <p:spPr>
+          <a:xfrm>
+            <a:off x="11183112" y="6400800"/>
+            <a:ext cx="457200" cy="274320"/>
+          </a:xfrm>
+          <a:prstGeom prst="rect">
+            <a:avLst/>
+          </a:prstGeom>
+          <a:extLst>
+            <a:ext uri="{C572A759-6A51-4108-AA02-DFA0A04FC94B}">
+              <ma14:wrappingTextBoxFlag xmlns:ma14="http://schemas.microsoft.com/office/mac/drawingml/2011/main" val="0"/>
+            </a:ext>
+          </a:extLst>
+        </p:spPr>
+        <p:txBody>
+          <a:bodyPr/>
+          <a:lstStyle>
+            <a:lvl1pPr>
+              <a:defRPr sz="1000">
+                <a:solidFill>
+                  <a:srgbClr val="A2A9B3"/>
+                </a:solidFill>
+              </a:defRPr>
+            </a:lvl1pPr>
+          </a:lstStyle>
+          <a:p>
+            <a:pPr algn="l"/>
+            <a:fld id="{F7021451-1387-4CA6-816F-3879F97B5CBC}" type="slidenum">
+              <a:rPr b="0" lang="en-US"/>
+              <a:t>12</a:t>
+            </a:fld>
+            <a:endParaRPr lang="en-US"/>
+          </a:p>
+        </p:txBody>
+      </p:sp>
+    </p:spTree>
+  </p:cSld>
+  <p:clrMapOvr>
+    <a:masterClrMapping/>
+  </p:clrMapOvr>
+</p:sld>
+</file>
+
+<file path=ppt/slides/slide13.xml><?xml version="1.0" encoding="utf-8"?>
+<p:sld xmlns:a="http://schemas.openxmlformats.org/drawingml/2006/main" xmlns:r="http://schemas.openxmlformats.org/officeDocument/2006/relationships" xmlns:p="http://schemas.openxmlformats.org/presentationml/2006/main">
+  <p:cSld name="Slide 13">
+    <p:spTree>
+      <p:nvGrpSpPr>
+        <p:cNvPr id="1" name=""/>
+        <p:cNvGrpSpPr/>
+        <p:nvPr/>
+      </p:nvGrpSpPr>
+      <p:grpSpPr>
+        <a:xfrm>
+          <a:off x="0" y="0"/>
+          <a:ext cx="0" cy="0"/>
+          <a:chOff x="0" y="0"/>
+          <a:chExt cx="0" cy="0"/>
+        </a:xfrm>
+      </p:grpSpPr>
+      <p:sp>
+        <p:nvSpPr>
           <p:cNvPr id="2" name="dot"/>
           <p:cNvSpPr/>
           <p:nvPr/>
@@ -8443,7 +9649,7 @@
                   <a:schemeClr val="tx1"/>
                 </a:solidFill>
               </a:rPr>
-              <a:t>Live, three windows: this deck, the Gridzilla board, VRM</a:t>
+              <a:t>The monster is on a diet: water-filling flattens every street</a:t>
             </a:r>
             <a:endParaRPr lang="en-US" sz="3200" dirty="0"/>
           </a:p>
@@ -8451,7 +9657,7 @@
       </p:sp>
       <p:pic>
         <p:nvPicPr>
-          <p:cNvPr id="3" name="Presentation view of the live board" descr="/private/tmp/claude-501/-Users-mathew-Library-Mobile-Documents-com-apple-CloudDocs-Workspaces--ai-projects-hackaton/6847b38a-4405-4bc8-878f-68767b84da8f/scratchpad/deck/board.png">    </p:cNvPr>
+          <p:cNvPr id="3" name="Vienna 24-hour plan: without Gridzilla, with the diet plan, level L" descr="/private/tmp/claude-501/-Users-mathew-Library-Mobile-Documents-com-apple-CloudDocs-Workspaces--ai-projects-hackaton/6847b38a-4405-4bc8-878f-68767b84da8f/scratchpad/deck/flatchart.png">    </p:cNvPr>
           <p:cNvPicPr>
             <a:picLocks noChangeAspect="1"/>
           </p:cNvPicPr>
@@ -8465,8 +9671,8 @@
         </p:blipFill>
         <p:spPr>
           <a:xfrm>
-            <a:off x="548640" y="1371600"/>
-            <a:ext cx="7589520" cy="4389120"/>
+            <a:off x="548640" y="1417320"/>
+            <a:ext cx="7863840" cy="4754880"/>
           </a:xfrm>
           <a:prstGeom prst="rect">
             <a:avLst/>
@@ -8475,18 +9681,18 @@
       </p:pic>
       <p:sp>
         <p:nvSpPr>
-          <p:cNvPr id="4" name="demo script"/>
+          <p:cNvPr id="4" name="stat Vienna evening peak, of transformer rating: 29.0 MW becomes 18.1 MW"/>
           <p:cNvSpPr/>
           <p:nvPr/>
         </p:nvSpPr>
         <p:spPr>
           <a:xfrm>
-            <a:off x="8412480" y="1371600"/>
-            <a:ext cx="3200400" cy="4389120"/>
+            <a:off x="8686800" y="1417320"/>
+            <a:ext cx="2926080" cy="1417320"/>
           </a:xfrm>
           <a:prstGeom prst="roundRect">
             <a:avLst>
-              <a:gd name="adj" fmla="val 2286"/>
+              <a:gd name="adj" fmla="val 5161"/>
             </a:avLst>
           </a:prstGeom>
           <a:solidFill>
@@ -8508,8 +9714,8 @@
         </p:nvSpPr>
         <p:spPr>
           <a:xfrm>
-            <a:off x="8641080" y="1508760"/>
-            <a:ext cx="2743200" cy="365760"/>
+            <a:off x="8915400" y="1581912"/>
+            <a:ext cx="2468880" cy="731520"/>
           </a:xfrm>
           <a:prstGeom prst="rect">
             <a:avLst/>
@@ -8525,144 +9731,257 @@
               <a:buNone/>
             </a:pPr>
             <a:r>
-              <a:rPr lang="en-US" sz="1500" b="1" dirty="0">
+              <a:rPr lang="en-US" sz="3600" b="1" dirty="0">
+                <a:solidFill>
+                  <a:schemeClr val="accent3"/>
+                </a:solidFill>
+                <a:latin typeface="Arial" pitchFamily="34" charset="0"/>
+                <a:ea typeface="Arial" pitchFamily="34" charset="-122"/>
+                <a:cs typeface="Arial" pitchFamily="34" charset="-120"/>
+              </a:rPr>
+              <a:t>97 → 61 %</a:t>
+            </a:r>
+            <a:endParaRPr lang="en-US" sz="3600" dirty="0"/>
+          </a:p>
+        </p:txBody>
+      </p:sp>
+      <p:sp>
+        <p:nvSpPr>
+          <p:cNvPr id="6" name="Text 3"/>
+          <p:cNvSpPr txBox="1"/>
+          <p:nvPr/>
+        </p:nvSpPr>
+        <p:spPr>
+          <a:xfrm>
+            <a:off x="8915400" y="2313432"/>
+            <a:ext cx="2468880" cy="457200"/>
+          </a:xfrm>
+          <a:prstGeom prst="rect">
+            <a:avLst/>
+          </a:prstGeom>
+          <a:noFill/>
+          <a:ln/>
+        </p:spPr>
+        <p:txBody>
+          <a:bodyPr wrap="square" lIns="0" tIns="0" rIns="0" bIns="0" rtlCol="0" anchor="t"/>
+          <a:lstStyle/>
+          <a:p>
+            <a:pPr indent="0" marL="0">
+              <a:buNone/>
+            </a:pPr>
+            <a:r>
+              <a:rPr lang="en-US" sz="1200" dirty="0">
+                <a:solidFill>
+                  <a:schemeClr val="tx2"/>
+                </a:solidFill>
+              </a:rPr>
+              <a:t>Vienna evening peak, of transformer rating: 29.0 MW becomes 18.1 MW</a:t>
+            </a:r>
+            <a:endParaRPr lang="en-US" sz="1200" dirty="0"/>
+          </a:p>
+        </p:txBody>
+      </p:sp>
+      <p:sp>
+        <p:nvSpPr>
+          <p:cNvPr id="7" name="stat of car charging moved from dinner into the night valley; every car full by 07:00"/>
+          <p:cNvSpPr/>
+          <p:nvPr/>
+        </p:nvSpPr>
+        <p:spPr>
+          <a:xfrm>
+            <a:off x="8686800" y="3017520"/>
+            <a:ext cx="2926080" cy="1417320"/>
+          </a:xfrm>
+          <a:prstGeom prst="roundRect">
+            <a:avLst>
+              <a:gd name="adj" fmla="val 5161"/>
+            </a:avLst>
+          </a:prstGeom>
+          <a:solidFill>
+            <a:schemeClr val="bg2"/>
+          </a:solidFill>
+          <a:ln w="9525">
+            <a:solidFill>
+              <a:schemeClr val="bg2"/>
+            </a:solidFill>
+            <a:prstDash val="solid"/>
+          </a:ln>
+        </p:spPr>
+      </p:sp>
+      <p:sp>
+        <p:nvSpPr>
+          <p:cNvPr id="8" name="Text 5"/>
+          <p:cNvSpPr txBox="1"/>
+          <p:nvPr/>
+        </p:nvSpPr>
+        <p:spPr>
+          <a:xfrm>
+            <a:off x="8915400" y="3182112"/>
+            <a:ext cx="2468880" cy="731520"/>
+          </a:xfrm>
+          <a:prstGeom prst="rect">
+            <a:avLst/>
+          </a:prstGeom>
+          <a:noFill/>
+          <a:ln/>
+        </p:spPr>
+        <p:txBody>
+          <a:bodyPr wrap="square" lIns="0" tIns="0" rIns="0" bIns="0" rtlCol="0" anchor="t"/>
+          <a:lstStyle/>
+          <a:p>
+            <a:pPr indent="0" marL="0">
+              <a:buNone/>
+            </a:pPr>
+            <a:r>
+              <a:rPr lang="en-US" sz="3600" b="1" dirty="0">
                 <a:solidFill>
                   <a:schemeClr val="accent1"/>
                 </a:solidFill>
-              </a:rPr>
-              <a:t>Four minutes, alt-tab</a:t>
-            </a:r>
-            <a:endParaRPr lang="en-US" sz="1500" dirty="0"/>
-          </a:p>
-        </p:txBody>
-      </p:sp>
-      <p:sp>
-        <p:nvSpPr>
-          <p:cNvPr id="6" name="Text 3"/>
-          <p:cNvSpPr txBox="1"/>
-          <p:nvPr/>
-        </p:nvSpPr>
-        <p:spPr>
-          <a:xfrm>
-            <a:off x="8641080" y="1965960"/>
-            <a:ext cx="2788920" cy="3657600"/>
-          </a:xfrm>
-          <a:prstGeom prst="rect">
-            <a:avLst/>
-          </a:prstGeom>
-          <a:noFill/>
-          <a:ln/>
-        </p:spPr>
-        <p:txBody>
-          <a:bodyPr wrap="square" lIns="0" tIns="0" rIns="0" bIns="0" rtlCol="0" anchor="t"/>
-          <a:lstStyle/>
-          <a:p>
-            <a:pPr marL="342900" indent="-342900">
-              <a:spcAft>
-                <a:spcPts val="600"/>
-              </a:spcAft>
-              <a:buSzPct val="100000"/>
-              <a:buChar char="•"/>
-            </a:pPr>
-            <a:r>
-              <a:rPr lang="en-US" sz="1250" dirty="0">
-                <a:solidFill>
-                  <a:schemeClr val="tx1"/>
-                </a:solidFill>
-              </a:rPr>
-              <a:t>Board: city view, 72 transformers, 272 households live, one of them real</a:t>
-            </a:r>
-            <a:endParaRPr lang="en-US" sz="1250" dirty="0"/>
-          </a:p>
-          <a:p>
-            <a:pPr marL="342900" indent="-342900">
-              <a:spcAft>
-                <a:spcPts val="600"/>
-              </a:spcAft>
-              <a:buSzPct val="100000"/>
-              <a:buChar char="•"/>
-            </a:pPr>
-            <a:r>
-              <a:rPr lang="en-US" sz="1250" dirty="0">
-                <a:solidFill>
-                  <a:schemeClr val="tx1"/>
-                </a:solidFill>
-              </a:rPr>
-              <a:t>Board: one DeepSeek review, sense, decide, guard, signed signal, countdown</a:t>
-            </a:r>
-            <a:endParaRPr lang="en-US" sz="1250" dirty="0"/>
-          </a:p>
-          <a:p>
-            <a:pPr marL="342900" indent="-342900">
-              <a:spcAft>
-                <a:spcPts val="600"/>
-              </a:spcAft>
-              <a:buSzPct val="100000"/>
-              <a:buChar char="•"/>
-            </a:pPr>
-            <a:r>
-              <a:rPr lang="en-US" sz="1250" dirty="0">
-                <a:solidFill>
-                  <a:schemeClr val="tx1"/>
-                </a:solidFill>
-              </a:rPr>
-              <a:t>Board: the curve, with vs without, on the transformer it chose</a:t>
-            </a:r>
-            <a:endParaRPr lang="en-US" sz="1250" dirty="0"/>
-          </a:p>
-          <a:p>
-            <a:pPr marL="342900" indent="-342900">
-              <a:spcAft>
-                <a:spcPts val="600"/>
-              </a:spcAft>
-              <a:buSzPct val="100000"/>
-              <a:buChar char="•"/>
-            </a:pPr>
-            <a:r>
-              <a:rPr lang="en-US" sz="1250" dirty="0">
-                <a:solidFill>
-                  <a:schemeClr val="tx1"/>
-                </a:solidFill>
-              </a:rPr>
-              <a:t>Board, pin Blatnica: send SUPPORT from the Manual tab; tiles move within seconds</a:t>
-            </a:r>
-            <a:endParaRPr lang="en-US" sz="1250" dirty="0"/>
-          </a:p>
-          <a:p>
-            <a:pPr marL="342900" indent="-342900">
-              <a:spcAft>
-                <a:spcPts val="600"/>
-              </a:spcAft>
-              <a:buSzPct val="100000"/>
-              <a:buChar char="•"/>
-            </a:pPr>
-            <a:r>
-              <a:rPr lang="en-US" sz="1250" dirty="0">
-                <a:solidFill>
-                  <a:schemeClr val="tx1"/>
-                </a:solidFill>
-              </a:rPr>
-              <a:t>VRM: the same plant from Victron's side, grid setpoint and battery power reacting</a:t>
-            </a:r>
-            <a:endParaRPr lang="en-US" sz="1250" dirty="0"/>
-          </a:p>
-          <a:p>
-            <a:pPr marL="342900" indent="-342900">
-              <a:spcAft>
-                <a:spcPts val="600"/>
-              </a:spcAft>
-              <a:buSzPct val="100000"/>
-              <a:buChar char="•"/>
-            </a:pPr>
-            <a:r>
-              <a:rPr lang="en-US" sz="1250" dirty="0">
-                <a:solidFill>
-                  <a:schemeClr val="tx1"/>
-                </a:solidFill>
-              </a:rPr>
-              <a:t>Board: pause the heartbeat, every house reverts to owner mode</a:t>
-            </a:r>
-            <a:endParaRPr lang="en-US" sz="1250" dirty="0"/>
+                <a:latin typeface="Arial" pitchFamily="34" charset="0"/>
+                <a:ea typeface="Arial" pitchFamily="34" charset="-122"/>
+                <a:cs typeface="Arial" pitchFamily="34" charset="-120"/>
+              </a:rPr>
+              <a:t>8.3 MWh</a:t>
+            </a:r>
+            <a:endParaRPr lang="en-US" sz="3600" dirty="0"/>
+          </a:p>
+        </p:txBody>
+      </p:sp>
+      <p:sp>
+        <p:nvSpPr>
+          <p:cNvPr id="9" name="Text 6"/>
+          <p:cNvSpPr txBox="1"/>
+          <p:nvPr/>
+        </p:nvSpPr>
+        <p:spPr>
+          <a:xfrm>
+            <a:off x="8915400" y="3913632"/>
+            <a:ext cx="2468880" cy="457200"/>
+          </a:xfrm>
+          <a:prstGeom prst="rect">
+            <a:avLst/>
+          </a:prstGeom>
+          <a:noFill/>
+          <a:ln/>
+        </p:spPr>
+        <p:txBody>
+          <a:bodyPr wrap="square" lIns="0" tIns="0" rIns="0" bIns="0" rtlCol="0" anchor="t"/>
+          <a:lstStyle/>
+          <a:p>
+            <a:pPr indent="0" marL="0">
+              <a:buNone/>
+            </a:pPr>
+            <a:r>
+              <a:rPr lang="en-US" sz="1200" dirty="0">
+                <a:solidFill>
+                  <a:schemeClr val="tx2"/>
+                </a:solidFill>
+              </a:rPr>
+              <a:t>of car charging moved from dinner into the night valley; every car full by 07:00</a:t>
+            </a:r>
+            <a:endParaRPr lang="en-US" sz="1200" dirty="0"/>
+          </a:p>
+        </p:txBody>
+      </p:sp>
+      <p:sp>
+        <p:nvSpPr>
+          <p:cNvPr id="10" name="stat the lowest level where the cars fit below it and the peak above it fits in the batteries. Two ceilings per 15 min, per house, signed, renewed every 2 h"/>
+          <p:cNvSpPr/>
+          <p:nvPr/>
+        </p:nvSpPr>
+        <p:spPr>
+          <a:xfrm>
+            <a:off x="8686800" y="4617720"/>
+            <a:ext cx="2926080" cy="1417320"/>
+          </a:xfrm>
+          <a:prstGeom prst="roundRect">
+            <a:avLst>
+              <a:gd name="adj" fmla="val 5161"/>
+            </a:avLst>
+          </a:prstGeom>
+          <a:solidFill>
+            <a:schemeClr val="bg2"/>
+          </a:solidFill>
+          <a:ln w="9525">
+            <a:solidFill>
+              <a:schemeClr val="bg2"/>
+            </a:solidFill>
+            <a:prstDash val="solid"/>
+          </a:ln>
+        </p:spPr>
+      </p:sp>
+      <p:sp>
+        <p:nvSpPr>
+          <p:cNvPr id="11" name="Text 8"/>
+          <p:cNvSpPr txBox="1"/>
+          <p:nvPr/>
+        </p:nvSpPr>
+        <p:spPr>
+          <a:xfrm>
+            <a:off x="8915400" y="4782312"/>
+            <a:ext cx="2468880" cy="731520"/>
+          </a:xfrm>
+          <a:prstGeom prst="rect">
+            <a:avLst/>
+          </a:prstGeom>
+          <a:noFill/>
+          <a:ln/>
+        </p:spPr>
+        <p:txBody>
+          <a:bodyPr wrap="square" lIns="0" tIns="0" rIns="0" bIns="0" rtlCol="0" anchor="t"/>
+          <a:lstStyle/>
+          <a:p>
+            <a:pPr indent="0" marL="0">
+              <a:buNone/>
+            </a:pPr>
+            <a:r>
+              <a:rPr lang="en-US" sz="3600" b="1" dirty="0">
+                <a:solidFill>
+                  <a:schemeClr val="accent2"/>
+                </a:solidFill>
+                <a:latin typeface="Arial" pitchFamily="34" charset="0"/>
+                <a:ea typeface="Arial" pitchFamily="34" charset="-122"/>
+                <a:cs typeface="Arial" pitchFamily="34" charset="-120"/>
+              </a:rPr>
+              <a:t>L</a:t>
+            </a:r>
+            <a:endParaRPr lang="en-US" sz="3600" dirty="0"/>
+          </a:p>
+        </p:txBody>
+      </p:sp>
+      <p:sp>
+        <p:nvSpPr>
+          <p:cNvPr id="12" name="Text 9"/>
+          <p:cNvSpPr txBox="1"/>
+          <p:nvPr/>
+        </p:nvSpPr>
+        <p:spPr>
+          <a:xfrm>
+            <a:off x="8915400" y="5513832"/>
+            <a:ext cx="2468880" cy="457200"/>
+          </a:xfrm>
+          <a:prstGeom prst="rect">
+            <a:avLst/>
+          </a:prstGeom>
+          <a:noFill/>
+          <a:ln/>
+        </p:spPr>
+        <p:txBody>
+          <a:bodyPr wrap="square" lIns="0" tIns="0" rIns="0" bIns="0" rtlCol="0" anchor="t"/>
+          <a:lstStyle/>
+          <a:p>
+            <a:pPr indent="0" marL="0">
+              <a:buNone/>
+            </a:pPr>
+            <a:r>
+              <a:rPr lang="en-US" sz="1200" dirty="0">
+                <a:solidFill>
+                  <a:schemeClr val="tx2"/>
+                </a:solidFill>
+              </a:rPr>
+              <a:t>the lowest level where the cars fit below it and the peak above it fits in the batteries. Two ceilings per 15 min, per house, signed, renewed every 2 h</a:t>
+            </a:r>
+            <a:endParaRPr lang="en-US" sz="1200" dirty="0"/>
           </a:p>
         </p:txBody>
       </p:sp>
@@ -8768,26 +10087,50 @@
                   <a:schemeClr val="tx1"/>
                 </a:solidFill>
               </a:rPr>
-              <a:t>Everything on that screen runs on real infrastructure today</a:t>
+              <a:t>Live, three windows: this deck, the Gridzilla board, VRM</a:t>
             </a:r>
             <a:endParaRPr lang="en-US" sz="3200" dirty="0"/>
           </a:p>
         </p:txBody>
       </p:sp>
-      <p:sp>
-        <p:nvSpPr>
-          <p:cNvPr id="3" name="stat households on the board, 8,070 houses represented"/>
+      <p:pic>
+        <p:nvPicPr>
+          <p:cNvPr id="3" name="Presentation view of the live board" descr="/private/tmp/claude-501/-Users-mathew-Library-Mobile-Documents-com-apple-CloudDocs-Workspaces--ai-projects-hackaton/6847b38a-4405-4bc8-878f-68767b84da8f/scratchpad/deck/board.png">    </p:cNvPr>
+          <p:cNvPicPr>
+            <a:picLocks noChangeAspect="1"/>
+          </p:cNvPicPr>
+          <p:nvPr/>
+        </p:nvPicPr>
+        <p:blipFill>
+          <a:blip r:embed="rId1"/>
+          <a:stretch>
+            <a:fillRect/>
+          </a:stretch>
+        </p:blipFill>
+        <p:spPr>
+          <a:xfrm>
+            <a:off x="548640" y="1371600"/>
+            <a:ext cx="7589520" cy="4389120"/>
+          </a:xfrm>
+          <a:prstGeom prst="rect">
+            <a:avLst/>
+          </a:prstGeom>
+        </p:spPr>
+      </p:pic>
+      <p:sp>
+        <p:nvSpPr>
+          <p:cNvPr id="4" name="demo script"/>
           <p:cNvSpPr/>
           <p:nvPr/>
         </p:nvSpPr>
         <p:spPr>
           <a:xfrm>
-            <a:off x="548640" y="1463040"/>
-            <a:ext cx="2697480" cy="1417320"/>
+            <a:off x="8412480" y="1371600"/>
+            <a:ext cx="3200400" cy="4389120"/>
           </a:xfrm>
           <a:prstGeom prst="roundRect">
             <a:avLst>
-              <a:gd name="adj" fmla="val 5161"/>
+              <a:gd name="adj" fmla="val 2286"/>
             </a:avLst>
           </a:prstGeom>
           <a:solidFill>
@@ -8803,14 +10146,14 @@
       </p:sp>
       <p:sp>
         <p:nvSpPr>
-          <p:cNvPr id="4" name="Text 2"/>
-          <p:cNvSpPr txBox="1"/>
-          <p:nvPr/>
-        </p:nvSpPr>
-        <p:spPr>
-          <a:xfrm>
-            <a:off x="777240" y="1627632"/>
-            <a:ext cx="2240280" cy="731520"/>
+          <p:cNvPr id="5" name="Text 2"/>
+          <p:cNvSpPr txBox="1"/>
+          <p:nvPr/>
+        </p:nvSpPr>
+        <p:spPr>
+          <a:xfrm>
+            <a:off x="8641080" y="1508760"/>
+            <a:ext cx="2743200" cy="365760"/>
           </a:xfrm>
           <a:prstGeom prst="rect">
             <a:avLst/>
@@ -8826,959 +10169,162 @@
               <a:buNone/>
             </a:pPr>
             <a:r>
-              <a:rPr lang="en-US" sz="3600" b="1" dirty="0">
-                <a:solidFill>
-                  <a:schemeClr val="accent2"/>
-                </a:solidFill>
-                <a:latin typeface="Arial" pitchFamily="34" charset="0"/>
-                <a:ea typeface="Arial" pitchFamily="34" charset="-122"/>
-                <a:cs typeface="Arial" pitchFamily="34" charset="-120"/>
-              </a:rPr>
-              <a:t>272</a:t>
-            </a:r>
-            <a:endParaRPr lang="en-US" sz="3600" dirty="0"/>
-          </a:p>
-        </p:txBody>
-      </p:sp>
-      <p:sp>
-        <p:nvSpPr>
-          <p:cNvPr id="5" name="Text 3"/>
-          <p:cNvSpPr txBox="1"/>
-          <p:nvPr/>
-        </p:nvSpPr>
-        <p:spPr>
-          <a:xfrm>
-            <a:off x="777240" y="2359152"/>
-            <a:ext cx="2240280" cy="457200"/>
-          </a:xfrm>
-          <a:prstGeom prst="rect">
-            <a:avLst/>
-          </a:prstGeom>
-          <a:noFill/>
-          <a:ln/>
-        </p:spPr>
-        <p:txBody>
-          <a:bodyPr wrap="square" lIns="0" tIns="0" rIns="0" bIns="0" rtlCol="0" anchor="t"/>
-          <a:lstStyle/>
-          <a:p>
-            <a:pPr indent="0" marL="0">
-              <a:buNone/>
-            </a:pPr>
-            <a:r>
-              <a:rPr lang="en-US" sz="1200" dirty="0">
-                <a:solidFill>
-                  <a:schemeClr val="tx2"/>
-                </a:solidFill>
-              </a:rPr>
-              <a:t>households on the board, 8,070 houses represented</a:t>
-            </a:r>
-            <a:endParaRPr lang="en-US" sz="1200" dirty="0"/>
-          </a:p>
-        </p:txBody>
-      </p:sp>
-      <p:sp>
-        <p:nvSpPr>
-          <p:cNvPr id="6" name="stat street transformers, 24 feeders, 8 substations with Wiener Netze names"/>
-          <p:cNvSpPr/>
-          <p:nvPr/>
-        </p:nvSpPr>
-        <p:spPr>
-          <a:xfrm>
-            <a:off x="3383280" y="1463040"/>
-            <a:ext cx="2697480" cy="1417320"/>
-          </a:xfrm>
-          <a:prstGeom prst="roundRect">
-            <a:avLst>
-              <a:gd name="adj" fmla="val 5161"/>
-            </a:avLst>
-          </a:prstGeom>
-          <a:solidFill>
-            <a:schemeClr val="bg2"/>
-          </a:solidFill>
-          <a:ln w="9525">
-            <a:solidFill>
-              <a:schemeClr val="bg2"/>
-            </a:solidFill>
-            <a:prstDash val="solid"/>
-          </a:ln>
-        </p:spPr>
-      </p:sp>
-      <p:sp>
-        <p:nvSpPr>
-          <p:cNvPr id="7" name="Text 5"/>
-          <p:cNvSpPr txBox="1"/>
-          <p:nvPr/>
-        </p:nvSpPr>
-        <p:spPr>
-          <a:xfrm>
-            <a:off x="3611880" y="1627632"/>
-            <a:ext cx="2240280" cy="731520"/>
-          </a:xfrm>
-          <a:prstGeom prst="rect">
-            <a:avLst/>
-          </a:prstGeom>
-          <a:noFill/>
-          <a:ln/>
-        </p:spPr>
-        <p:txBody>
-          <a:bodyPr wrap="square" lIns="0" tIns="0" rIns="0" bIns="0" rtlCol="0" anchor="t"/>
-          <a:lstStyle/>
-          <a:p>
-            <a:pPr indent="0" marL="0">
-              <a:buNone/>
-            </a:pPr>
-            <a:r>
-              <a:rPr lang="en-US" sz="3600" b="1" dirty="0">
-                <a:solidFill>
-                  <a:schemeClr val="accent2"/>
-                </a:solidFill>
-                <a:latin typeface="Arial" pitchFamily="34" charset="0"/>
-                <a:ea typeface="Arial" pitchFamily="34" charset="-122"/>
-                <a:cs typeface="Arial" pitchFamily="34" charset="-120"/>
-              </a:rPr>
-              <a:t>72</a:t>
-            </a:r>
-            <a:endParaRPr lang="en-US" sz="3600" dirty="0"/>
-          </a:p>
-        </p:txBody>
-      </p:sp>
-      <p:sp>
-        <p:nvSpPr>
-          <p:cNvPr id="8" name="Text 6"/>
-          <p:cNvSpPr txBox="1"/>
-          <p:nvPr/>
-        </p:nvSpPr>
-        <p:spPr>
-          <a:xfrm>
-            <a:off x="3611880" y="2359152"/>
-            <a:ext cx="2240280" cy="457200"/>
-          </a:xfrm>
-          <a:prstGeom prst="rect">
-            <a:avLst/>
-          </a:prstGeom>
-          <a:noFill/>
-          <a:ln/>
-        </p:spPr>
-        <p:txBody>
-          <a:bodyPr wrap="square" lIns="0" tIns="0" rIns="0" bIns="0" rtlCol="0" anchor="t"/>
-          <a:lstStyle/>
-          <a:p>
-            <a:pPr indent="0" marL="0">
-              <a:buNone/>
-            </a:pPr>
-            <a:r>
-              <a:rPr lang="en-US" sz="1200" dirty="0">
-                <a:solidFill>
-                  <a:schemeClr val="tx2"/>
-                </a:solidFill>
-              </a:rPr>
-              <a:t>street transformers, 24 feeders, 8 substations with Wiener Netze names</a:t>
-            </a:r>
-            <a:endParaRPr lang="en-US" sz="1200" dirty="0"/>
-          </a:p>
-        </p:txBody>
-      </p:sp>
-      <p:sp>
-        <p:nvSpPr>
-          <p:cNvPr id="9" name="stat real devices: a Victron plant and a Viessmann heat pump, 60 km from here"/>
-          <p:cNvSpPr/>
-          <p:nvPr/>
-        </p:nvSpPr>
-        <p:spPr>
-          <a:xfrm>
-            <a:off x="6217920" y="1463040"/>
-            <a:ext cx="2697480" cy="1417320"/>
-          </a:xfrm>
-          <a:prstGeom prst="roundRect">
-            <a:avLst>
-              <a:gd name="adj" fmla="val 5161"/>
-            </a:avLst>
-          </a:prstGeom>
-          <a:solidFill>
-            <a:schemeClr val="bg2"/>
-          </a:solidFill>
-          <a:ln w="9525">
-            <a:solidFill>
-              <a:schemeClr val="bg2"/>
-            </a:solidFill>
-            <a:prstDash val="solid"/>
-          </a:ln>
-        </p:spPr>
-      </p:sp>
-      <p:sp>
-        <p:nvSpPr>
-          <p:cNvPr id="10" name="Text 8"/>
-          <p:cNvSpPr txBox="1"/>
-          <p:nvPr/>
-        </p:nvSpPr>
-        <p:spPr>
-          <a:xfrm>
-            <a:off x="6446520" y="1627632"/>
-            <a:ext cx="2240280" cy="731520"/>
-          </a:xfrm>
-          <a:prstGeom prst="rect">
-            <a:avLst/>
-          </a:prstGeom>
-          <a:noFill/>
-          <a:ln/>
-        </p:spPr>
-        <p:txBody>
-          <a:bodyPr wrap="square" lIns="0" tIns="0" rIns="0" bIns="0" rtlCol="0" anchor="t"/>
-          <a:lstStyle/>
-          <a:p>
-            <a:pPr indent="0" marL="0">
-              <a:buNone/>
-            </a:pPr>
-            <a:r>
-              <a:rPr lang="en-US" sz="3600" b="1" dirty="0">
-                <a:solidFill>
-                  <a:schemeClr val="accent3"/>
-                </a:solidFill>
-                <a:latin typeface="Arial" pitchFamily="34" charset="0"/>
-                <a:ea typeface="Arial" pitchFamily="34" charset="-122"/>
-                <a:cs typeface="Arial" pitchFamily="34" charset="-120"/>
-              </a:rPr>
-              <a:t>2</a:t>
-            </a:r>
-            <a:endParaRPr lang="en-US" sz="3600" dirty="0"/>
-          </a:p>
-        </p:txBody>
-      </p:sp>
-      <p:sp>
-        <p:nvSpPr>
-          <p:cNvPr id="11" name="Text 9"/>
-          <p:cNvSpPr txBox="1"/>
-          <p:nvPr/>
-        </p:nvSpPr>
-        <p:spPr>
-          <a:xfrm>
-            <a:off x="6446520" y="2359152"/>
-            <a:ext cx="2240280" cy="457200"/>
-          </a:xfrm>
-          <a:prstGeom prst="rect">
-            <a:avLst/>
-          </a:prstGeom>
-          <a:noFill/>
-          <a:ln/>
-        </p:spPr>
-        <p:txBody>
-          <a:bodyPr wrap="square" lIns="0" tIns="0" rIns="0" bIns="0" rtlCol="0" anchor="t"/>
-          <a:lstStyle/>
-          <a:p>
-            <a:pPr indent="0" marL="0">
-              <a:buNone/>
-            </a:pPr>
-            <a:r>
-              <a:rPr lang="en-US" sz="1200" dirty="0">
-                <a:solidFill>
-                  <a:schemeClr val="tx2"/>
-                </a:solidFill>
-              </a:rPr>
-              <a:t>real devices: a Victron plant and a Viessmann heat pump, 60 km from here</a:t>
-            </a:r>
-            <a:endParaRPr lang="en-US" sz="1200" dirty="0"/>
-          </a:p>
-        </p:txBody>
-      </p:sp>
-      <p:sp>
-        <p:nvSpPr>
-          <p:cNvPr id="12" name="stat DeepSeek decision latency on the DGX Spark"/>
-          <p:cNvSpPr/>
-          <p:nvPr/>
-        </p:nvSpPr>
-        <p:spPr>
-          <a:xfrm>
-            <a:off x="9052560" y="1463040"/>
-            <a:ext cx="2587752" cy="1417320"/>
-          </a:xfrm>
-          <a:prstGeom prst="roundRect">
-            <a:avLst>
-              <a:gd name="adj" fmla="val 5161"/>
-            </a:avLst>
-          </a:prstGeom>
-          <a:solidFill>
-            <a:schemeClr val="bg2"/>
-          </a:solidFill>
-          <a:ln w="9525">
-            <a:solidFill>
-              <a:schemeClr val="bg2"/>
-            </a:solidFill>
-            <a:prstDash val="solid"/>
-          </a:ln>
-        </p:spPr>
-      </p:sp>
-      <p:sp>
-        <p:nvSpPr>
-          <p:cNvPr id="13" name="Text 11"/>
-          <p:cNvSpPr txBox="1"/>
-          <p:nvPr/>
-        </p:nvSpPr>
-        <p:spPr>
-          <a:xfrm>
-            <a:off x="9281160" y="1627632"/>
-            <a:ext cx="2130552" cy="731520"/>
-          </a:xfrm>
-          <a:prstGeom prst="rect">
-            <a:avLst/>
-          </a:prstGeom>
-          <a:noFill/>
-          <a:ln/>
-        </p:spPr>
-        <p:txBody>
-          <a:bodyPr wrap="square" lIns="0" tIns="0" rIns="0" bIns="0" rtlCol="0" anchor="t"/>
-          <a:lstStyle/>
-          <a:p>
-            <a:pPr indent="0" marL="0">
-              <a:buNone/>
-            </a:pPr>
-            <a:r>
-              <a:rPr lang="en-US" sz="3600" b="1" dirty="0">
+              <a:rPr lang="en-US" sz="1500" b="1" dirty="0">
                 <a:solidFill>
                   <a:schemeClr val="accent1"/>
                 </a:solidFill>
-                <a:latin typeface="Arial" pitchFamily="34" charset="0"/>
-                <a:ea typeface="Arial" pitchFamily="34" charset="-122"/>
-                <a:cs typeface="Arial" pitchFamily="34" charset="-120"/>
-              </a:rPr>
-              <a:t>~3 s</a:t>
-            </a:r>
-            <a:endParaRPr lang="en-US" sz="3600" dirty="0"/>
-          </a:p>
-        </p:txBody>
-      </p:sp>
-      <p:sp>
-        <p:nvSpPr>
-          <p:cNvPr id="14" name="Text 12"/>
-          <p:cNvSpPr txBox="1"/>
-          <p:nvPr/>
-        </p:nvSpPr>
-        <p:spPr>
-          <a:xfrm>
-            <a:off x="9281160" y="2359152"/>
-            <a:ext cx="2130552" cy="457200"/>
-          </a:xfrm>
-          <a:prstGeom prst="rect">
-            <a:avLst/>
-          </a:prstGeom>
-          <a:noFill/>
-          <a:ln/>
-        </p:spPr>
-        <p:txBody>
-          <a:bodyPr wrap="square" lIns="0" tIns="0" rIns="0" bIns="0" rtlCol="0" anchor="t"/>
-          <a:lstStyle/>
-          <a:p>
-            <a:pPr indent="0" marL="0">
-              <a:buNone/>
-            </a:pPr>
-            <a:r>
-              <a:rPr lang="en-US" sz="1200" dirty="0">
-                <a:solidFill>
-                  <a:schemeClr val="tx2"/>
-                </a:solidFill>
-              </a:rPr>
-              <a:t>DeepSeek decision latency on the DGX Spark</a:t>
-            </a:r>
-            <a:endParaRPr lang="en-US" sz="1200" dirty="0"/>
-          </a:p>
-        </p:txBody>
-      </p:sp>
-      <p:sp>
-        <p:nvSpPr>
-          <p:cNvPr id="15" name="dot"/>
-          <p:cNvSpPr/>
-          <p:nvPr/>
-        </p:nvSpPr>
-        <p:spPr>
-          <a:xfrm>
-            <a:off x="548640" y="3200400"/>
-            <a:ext cx="384048" cy="384048"/>
-          </a:xfrm>
-          <a:prstGeom prst="ellipse">
-            <a:avLst/>
-          </a:prstGeom>
-          <a:solidFill>
-            <a:schemeClr val="accent1"/>
-          </a:solidFill>
-          <a:ln w="12700">
-            <a:solidFill>
-              <a:schemeClr val="accent1"/>
-            </a:solidFill>
-            <a:prstDash val="solid"/>
-          </a:ln>
-        </p:spPr>
-      </p:sp>
-      <p:sp>
-        <p:nvSpPr>
-          <p:cNvPr id="16" name="Text 14"/>
-          <p:cNvSpPr txBox="1"/>
-          <p:nvPr/>
-        </p:nvSpPr>
-        <p:spPr>
-          <a:xfrm>
-            <a:off x="1097280" y="3154680"/>
-            <a:ext cx="4937760" cy="320040"/>
-          </a:xfrm>
-          <a:prstGeom prst="rect">
-            <a:avLst/>
-          </a:prstGeom>
-          <a:noFill/>
-          <a:ln/>
-        </p:spPr>
-        <p:txBody>
-          <a:bodyPr wrap="square" lIns="0" tIns="0" rIns="0" bIns="0" rtlCol="0" anchor="t"/>
-          <a:lstStyle/>
-          <a:p>
-            <a:pPr indent="0" marL="0">
-              <a:buNone/>
-            </a:pPr>
-            <a:r>
-              <a:rPr lang="en-US" sz="1400" b="1" dirty="0">
+              </a:rPr>
+              <a:t>Four minutes, alt-tab</a:t>
+            </a:r>
+            <a:endParaRPr lang="en-US" sz="1500" dirty="0"/>
+          </a:p>
+        </p:txBody>
+      </p:sp>
+      <p:sp>
+        <p:nvSpPr>
+          <p:cNvPr id="6" name="Text 3"/>
+          <p:cNvSpPr txBox="1"/>
+          <p:nvPr/>
+        </p:nvSpPr>
+        <p:spPr>
+          <a:xfrm>
+            <a:off x="8641080" y="1965960"/>
+            <a:ext cx="2788920" cy="3657600"/>
+          </a:xfrm>
+          <a:prstGeom prst="rect">
+            <a:avLst/>
+          </a:prstGeom>
+          <a:noFill/>
+          <a:ln/>
+        </p:spPr>
+        <p:txBody>
+          <a:bodyPr wrap="square" lIns="0" tIns="0" rIns="0" bIns="0" rtlCol="0" anchor="t"/>
+          <a:lstStyle/>
+          <a:p>
+            <a:pPr marL="342900" indent="-342900">
+              <a:spcAft>
+                <a:spcPts val="600"/>
+              </a:spcAft>
+              <a:buSzPct val="100000"/>
+              <a:buChar char="•"/>
+            </a:pPr>
+            <a:r>
+              <a:rPr lang="en-US" sz="1250" dirty="0">
                 <a:solidFill>
                   <a:schemeClr val="tx1"/>
                 </a:solidFill>
-                <a:latin typeface="Arial" pitchFamily="34" charset="0"/>
-                <a:ea typeface="Arial" pitchFamily="34" charset="-122"/>
-                <a:cs typeface="Arial" pitchFamily="34" charset="-120"/>
-              </a:rPr>
-              <a:t>Real plant</a:t>
-            </a:r>
-            <a:endParaRPr lang="en-US" sz="1400" dirty="0"/>
-          </a:p>
-        </p:txBody>
-      </p:sp>
-      <p:sp>
-        <p:nvSpPr>
-          <p:cNvPr id="17" name="Text 15"/>
-          <p:cNvSpPr txBox="1"/>
-          <p:nvPr/>
-        </p:nvSpPr>
-        <p:spPr>
-          <a:xfrm>
-            <a:off x="1097280" y="3474720"/>
-            <a:ext cx="4937760" cy="640080"/>
-          </a:xfrm>
-          <a:prstGeom prst="rect">
-            <a:avLst/>
-          </a:prstGeom>
-          <a:noFill/>
-          <a:ln/>
-        </p:spPr>
-        <p:txBody>
-          <a:bodyPr wrap="square" lIns="0" tIns="0" rIns="0" bIns="0" rtlCol="0" anchor="t"/>
-          <a:lstStyle/>
-          <a:p>
-            <a:pPr indent="0" marL="0">
-              <a:buNone/>
-            </a:pPr>
-            <a:r>
-              <a:rPr lang="en-US" sz="1150" dirty="0">
-                <a:solidFill>
-                  <a:schemeClr val="tx2"/>
-                </a:solidFill>
-              </a:rPr>
-              <a:t>Cerbo GX on Venus OS Large, a 53-node Node-RED agent we deploy over the admin API; EV Charging Station throttled first; ESS limits written and restored</a:t>
-            </a:r>
-            <a:endParaRPr lang="en-US" sz="1150" dirty="0"/>
-          </a:p>
-        </p:txBody>
-      </p:sp>
-      <p:sp>
-        <p:nvSpPr>
-          <p:cNvPr id="18" name="dot"/>
-          <p:cNvSpPr/>
-          <p:nvPr/>
-        </p:nvSpPr>
-        <p:spPr>
-          <a:xfrm>
-            <a:off x="6217920" y="3200400"/>
-            <a:ext cx="384048" cy="384048"/>
-          </a:xfrm>
-          <a:prstGeom prst="ellipse">
-            <a:avLst/>
-          </a:prstGeom>
-          <a:solidFill>
-            <a:schemeClr val="accent1"/>
-          </a:solidFill>
-          <a:ln w="12700">
-            <a:solidFill>
-              <a:schemeClr val="accent1"/>
-            </a:solidFill>
-            <a:prstDash val="solid"/>
-          </a:ln>
-        </p:spPr>
-      </p:sp>
-      <p:sp>
-        <p:nvSpPr>
-          <p:cNvPr id="19" name="Text 17"/>
-          <p:cNvSpPr txBox="1"/>
-          <p:nvPr/>
-        </p:nvSpPr>
-        <p:spPr>
-          <a:xfrm>
-            <a:off x="6766560" y="3154680"/>
-            <a:ext cx="4937760" cy="320040"/>
-          </a:xfrm>
-          <a:prstGeom prst="rect">
-            <a:avLst/>
-          </a:prstGeom>
-          <a:noFill/>
-          <a:ln/>
-        </p:spPr>
-        <p:txBody>
-          <a:bodyPr wrap="square" lIns="0" tIns="0" rIns="0" bIns="0" rtlCol="0" anchor="t"/>
-          <a:lstStyle/>
-          <a:p>
-            <a:pPr indent="0" marL="0">
-              <a:buNone/>
-            </a:pPr>
-            <a:r>
-              <a:rPr lang="en-US" sz="1400" b="1" dirty="0">
+              </a:rPr>
+              <a:t>Board: city view, 72 transformers, 272 households live, one of them real</a:t>
+            </a:r>
+            <a:endParaRPr lang="en-US" sz="1250" dirty="0"/>
+          </a:p>
+          <a:p>
+            <a:pPr marL="342900" indent="-342900">
+              <a:spcAft>
+                <a:spcPts val="600"/>
+              </a:spcAft>
+              <a:buSzPct val="100000"/>
+              <a:buChar char="•"/>
+            </a:pPr>
+            <a:r>
+              <a:rPr lang="en-US" sz="1250" dirty="0">
                 <a:solidFill>
                   <a:schemeClr val="tx1"/>
                 </a:solidFill>
-                <a:latin typeface="Arial" pitchFamily="34" charset="0"/>
-                <a:ea typeface="Arial" pitchFamily="34" charset="-122"/>
-                <a:cs typeface="Arial" pitchFamily="34" charset="-120"/>
-              </a:rPr>
-              <a:t>Heat pump</a:t>
-            </a:r>
-            <a:endParaRPr lang="en-US" sz="1400" dirty="0"/>
-          </a:p>
-        </p:txBody>
-      </p:sp>
-      <p:sp>
-        <p:nvSpPr>
-          <p:cNvPr id="20" name="Text 18"/>
-          <p:cNvSpPr txBox="1"/>
-          <p:nvPr/>
-        </p:nvSpPr>
-        <p:spPr>
-          <a:xfrm>
-            <a:off x="6766560" y="3474720"/>
-            <a:ext cx="4937760" cy="640080"/>
-          </a:xfrm>
-          <a:prstGeom prst="rect">
-            <a:avLst/>
-          </a:prstGeom>
-          <a:noFill/>
-          <a:ln/>
-        </p:spPr>
-        <p:txBody>
-          <a:bodyPr wrap="square" lIns="0" tIns="0" rIns="0" bIns="0" rtlCol="0" anchor="t"/>
-          <a:lstStyle/>
-          <a:p>
-            <a:pPr indent="0" marL="0">
-              <a:buNone/>
-            </a:pPr>
-            <a:r>
-              <a:rPr lang="en-US" sz="1150" dirty="0">
-                <a:solidFill>
-                  <a:schemeClr val="tx2"/>
-                </a:solidFill>
-              </a:rPr>
-              <a:t>Vitocal CU401B through the ViCare REST API with a refresh token; hot-water setpoint and one-time charge, verified on the unit</a:t>
-            </a:r>
-            <a:endParaRPr lang="en-US" sz="1150" dirty="0"/>
-          </a:p>
-        </p:txBody>
-      </p:sp>
-      <p:sp>
-        <p:nvSpPr>
-          <p:cNvPr id="21" name="dot"/>
-          <p:cNvSpPr/>
-          <p:nvPr/>
-        </p:nvSpPr>
-        <p:spPr>
-          <a:xfrm>
-            <a:off x="548640" y="4187952"/>
-            <a:ext cx="384048" cy="384048"/>
-          </a:xfrm>
-          <a:prstGeom prst="ellipse">
-            <a:avLst/>
-          </a:prstGeom>
-          <a:solidFill>
-            <a:schemeClr val="accent1"/>
-          </a:solidFill>
-          <a:ln w="12700">
-            <a:solidFill>
-              <a:schemeClr val="accent1"/>
-            </a:solidFill>
-            <a:prstDash val="solid"/>
-          </a:ln>
-        </p:spPr>
-      </p:sp>
-      <p:sp>
-        <p:nvSpPr>
-          <p:cNvPr id="22" name="Text 20"/>
-          <p:cNvSpPr txBox="1"/>
-          <p:nvPr/>
-        </p:nvSpPr>
-        <p:spPr>
-          <a:xfrm>
-            <a:off x="1097280" y="4142232"/>
-            <a:ext cx="4937760" cy="320040"/>
-          </a:xfrm>
-          <a:prstGeom prst="rect">
-            <a:avLst/>
-          </a:prstGeom>
-          <a:noFill/>
-          <a:ln/>
-        </p:spPr>
-        <p:txBody>
-          <a:bodyPr wrap="square" lIns="0" tIns="0" rIns="0" bIns="0" rtlCol="0" anchor="t"/>
-          <a:lstStyle/>
-          <a:p>
-            <a:pPr indent="0" marL="0">
-              <a:buNone/>
-            </a:pPr>
-            <a:r>
-              <a:rPr lang="en-US" sz="1400" b="1" dirty="0">
+              </a:rPr>
+              <a:t>Board: one DeepSeek review, sense, decide, guard, signed signal, countdown</a:t>
+            </a:r>
+            <a:endParaRPr lang="en-US" sz="1250" dirty="0"/>
+          </a:p>
+          <a:p>
+            <a:pPr marL="342900" indent="-342900">
+              <a:spcAft>
+                <a:spcPts val="600"/>
+              </a:spcAft>
+              <a:buSzPct val="100000"/>
+              <a:buChar char="•"/>
+            </a:pPr>
+            <a:r>
+              <a:rPr lang="en-US" sz="1250" dirty="0">
                 <a:solidFill>
                   <a:schemeClr val="tx1"/>
                 </a:solidFill>
-                <a:latin typeface="Arial" pitchFamily="34" charset="0"/>
-                <a:ea typeface="Arial" pitchFamily="34" charset="-122"/>
-                <a:cs typeface="Arial" pitchFamily="34" charset="-120"/>
-              </a:rPr>
-              <a:t>Transport</a:t>
-            </a:r>
-            <a:endParaRPr lang="en-US" sz="1400" dirty="0"/>
-          </a:p>
-        </p:txBody>
-      </p:sp>
-      <p:sp>
-        <p:nvSpPr>
-          <p:cNvPr id="23" name="Text 21"/>
-          <p:cNvSpPr txBox="1"/>
-          <p:nvPr/>
-        </p:nvSpPr>
-        <p:spPr>
-          <a:xfrm>
-            <a:off x="1097280" y="4462272"/>
-            <a:ext cx="4937760" cy="640080"/>
-          </a:xfrm>
-          <a:prstGeom prst="rect">
-            <a:avLst/>
-          </a:prstGeom>
-          <a:noFill/>
-          <a:ln/>
-        </p:spPr>
-        <p:txBody>
-          <a:bodyPr wrap="square" lIns="0" tIns="0" rIns="0" bIns="0" rtlCol="0" anchor="t"/>
-          <a:lstStyle/>
-          <a:p>
-            <a:pPr indent="0" marL="0">
-              <a:buNone/>
-            </a:pPr>
-            <a:r>
-              <a:rPr lang="en-US" sz="1150" dirty="0">
-                <a:solidFill>
-                  <a:schemeClr val="tx2"/>
-                </a:solidFill>
-              </a:rPr>
-              <a:t>Mosquitto on our own server, Let's Encrypt, TLS only, credentials and topic access lists; devices open outbound connections only</a:t>
-            </a:r>
-            <a:endParaRPr lang="en-US" sz="1150" dirty="0"/>
-          </a:p>
-        </p:txBody>
-      </p:sp>
-      <p:sp>
-        <p:nvSpPr>
-          <p:cNvPr id="24" name="dot"/>
-          <p:cNvSpPr/>
-          <p:nvPr/>
-        </p:nvSpPr>
-        <p:spPr>
-          <a:xfrm>
-            <a:off x="6217920" y="4187952"/>
-            <a:ext cx="384048" cy="384048"/>
-          </a:xfrm>
-          <a:prstGeom prst="ellipse">
-            <a:avLst/>
-          </a:prstGeom>
-          <a:solidFill>
-            <a:schemeClr val="accent1"/>
-          </a:solidFill>
-          <a:ln w="12700">
-            <a:solidFill>
-              <a:schemeClr val="accent1"/>
-            </a:solidFill>
-            <a:prstDash val="solid"/>
-          </a:ln>
-        </p:spPr>
-      </p:sp>
-      <p:sp>
-        <p:nvSpPr>
-          <p:cNvPr id="25" name="Text 23"/>
-          <p:cNvSpPr txBox="1"/>
-          <p:nvPr/>
-        </p:nvSpPr>
-        <p:spPr>
-          <a:xfrm>
-            <a:off x="6766560" y="4142232"/>
-            <a:ext cx="4937760" cy="320040"/>
-          </a:xfrm>
-          <a:prstGeom prst="rect">
-            <a:avLst/>
-          </a:prstGeom>
-          <a:noFill/>
-          <a:ln/>
-        </p:spPr>
-        <p:txBody>
-          <a:bodyPr wrap="square" lIns="0" tIns="0" rIns="0" bIns="0" rtlCol="0" anchor="t"/>
-          <a:lstStyle/>
-          <a:p>
-            <a:pPr indent="0" marL="0">
-              <a:buNone/>
-            </a:pPr>
-            <a:r>
-              <a:rPr lang="en-US" sz="1400" b="1" dirty="0">
+              </a:rPr>
+              <a:t>Board: the curve, with vs without, on the transformer it chose</a:t>
+            </a:r>
+            <a:endParaRPr lang="en-US" sz="1250" dirty="0"/>
+          </a:p>
+          <a:p>
+            <a:pPr marL="342900" indent="-342900">
+              <a:spcAft>
+                <a:spcPts val="600"/>
+              </a:spcAft>
+              <a:buSzPct val="100000"/>
+              <a:buChar char="•"/>
+            </a:pPr>
+            <a:r>
+              <a:rPr lang="en-US" sz="1250" dirty="0">
                 <a:solidFill>
                   <a:schemeClr val="tx1"/>
                 </a:solidFill>
-                <a:latin typeface="Arial" pitchFamily="34" charset="0"/>
-                <a:ea typeface="Arial" pitchFamily="34" charset="-122"/>
-                <a:cs typeface="Arial" pitchFamily="34" charset="-120"/>
-              </a:rPr>
-              <a:t>Platform</a:t>
-            </a:r>
-            <a:endParaRPr lang="en-US" sz="1400" dirty="0"/>
-          </a:p>
-        </p:txBody>
-      </p:sp>
-      <p:sp>
-        <p:nvSpPr>
-          <p:cNvPr id="26" name="Text 24"/>
-          <p:cNvSpPr txBox="1"/>
-          <p:nvPr/>
-        </p:nvSpPr>
-        <p:spPr>
-          <a:xfrm>
-            <a:off x="6766560" y="4462272"/>
-            <a:ext cx="4937760" cy="640080"/>
-          </a:xfrm>
-          <a:prstGeom prst="rect">
-            <a:avLst/>
-          </a:prstGeom>
-          <a:noFill/>
-          <a:ln/>
-        </p:spPr>
-        <p:txBody>
-          <a:bodyPr wrap="square" lIns="0" tIns="0" rIns="0" bIns="0" rtlCol="0" anchor="t"/>
-          <a:lstStyle/>
-          <a:p>
-            <a:pPr indent="0" marL="0">
-              <a:buNone/>
-            </a:pPr>
-            <a:r>
-              <a:rPr lang="en-US" sz="1150" dirty="0">
-                <a:solidFill>
-                  <a:schemeClr val="tx2"/>
-                </a:solidFill>
-              </a:rPr>
-              <a:t>FastAPI on a Ubuntu box behind Apache and Let's Encrypt; registry tree, guard, signing, history, autopilot; public board at gridzilla.victronlab.sk</a:t>
-            </a:r>
-            <a:endParaRPr lang="en-US" sz="1150" dirty="0"/>
-          </a:p>
-        </p:txBody>
-      </p:sp>
-      <p:sp>
-        <p:nvSpPr>
-          <p:cNvPr id="27" name="dot"/>
-          <p:cNvSpPr/>
-          <p:nvPr/>
-        </p:nvSpPr>
-        <p:spPr>
-          <a:xfrm>
-            <a:off x="548640" y="5175504"/>
-            <a:ext cx="384048" cy="384048"/>
-          </a:xfrm>
-          <a:prstGeom prst="ellipse">
-            <a:avLst/>
-          </a:prstGeom>
-          <a:solidFill>
-            <a:schemeClr val="accent1"/>
-          </a:solidFill>
-          <a:ln w="12700">
-            <a:solidFill>
-              <a:schemeClr val="accent1"/>
-            </a:solidFill>
-            <a:prstDash val="solid"/>
-          </a:ln>
-        </p:spPr>
-      </p:sp>
-      <p:sp>
-        <p:nvSpPr>
-          <p:cNvPr id="28" name="Text 26"/>
-          <p:cNvSpPr txBox="1"/>
-          <p:nvPr/>
-        </p:nvSpPr>
-        <p:spPr>
-          <a:xfrm>
-            <a:off x="1097280" y="5129784"/>
-            <a:ext cx="4937760" cy="320040"/>
-          </a:xfrm>
-          <a:prstGeom prst="rect">
-            <a:avLst/>
-          </a:prstGeom>
-          <a:noFill/>
-          <a:ln/>
-        </p:spPr>
-        <p:txBody>
-          <a:bodyPr wrap="square" lIns="0" tIns="0" rIns="0" bIns="0" rtlCol="0" anchor="t"/>
-          <a:lstStyle/>
-          <a:p>
-            <a:pPr indent="0" marL="0">
-              <a:buNone/>
-            </a:pPr>
-            <a:r>
-              <a:rPr lang="en-US" sz="1400" b="1" dirty="0">
+              </a:rPr>
+              <a:t>Board, Flattening tab: the 24 h diet plan for Vienna, then one street; cars moved into the valley, batteries eat the peak</a:t>
+            </a:r>
+            <a:endParaRPr lang="en-US" sz="1250" dirty="0"/>
+          </a:p>
+          <a:p>
+            <a:pPr marL="342900" indent="-342900">
+              <a:spcAft>
+                <a:spcPts val="600"/>
+              </a:spcAft>
+              <a:buSzPct val="100000"/>
+              <a:buChar char="•"/>
+            </a:pPr>
+            <a:r>
+              <a:rPr lang="en-US" sz="1250" dirty="0">
                 <a:solidFill>
                   <a:schemeClr val="tx1"/>
                 </a:solidFill>
-                <a:latin typeface="Arial" pitchFamily="34" charset="0"/>
-                <a:ea typeface="Arial" pitchFamily="34" charset="-122"/>
-                <a:cs typeface="Arial" pitchFamily="34" charset="-120"/>
-              </a:rPr>
-              <a:t>Simulation</a:t>
-            </a:r>
-            <a:endParaRPr lang="en-US" sz="1400" dirty="0"/>
-          </a:p>
-        </p:txBody>
-      </p:sp>
-      <p:sp>
-        <p:nvSpPr>
-          <p:cNvPr id="29" name="Text 27"/>
-          <p:cNvSpPr txBox="1"/>
-          <p:nvPr/>
-        </p:nvSpPr>
-        <p:spPr>
-          <a:xfrm>
-            <a:off x="1097280" y="5449824"/>
-            <a:ext cx="4937760" cy="640080"/>
-          </a:xfrm>
-          <a:prstGeom prst="rect">
-            <a:avLst/>
-          </a:prstGeom>
-          <a:noFill/>
-          <a:ln/>
-        </p:spPr>
-        <p:txBody>
-          <a:bodyPr wrap="square" lIns="0" tIns="0" rIns="0" bIns="0" rtlCol="0" anchor="t"/>
-          <a:lstStyle/>
-          <a:p>
-            <a:pPr indent="0" marL="0">
-              <a:buNone/>
-            </a:pPr>
-            <a:r>
-              <a:rPr lang="en-US" sz="1150" dirty="0">
-                <a:solidFill>
-                  <a:schemeClr val="tx2"/>
-                </a:solidFill>
-              </a:rPr>
-              <a:t>262 households with battery, PV, EV commutes, heat pumps and boilers with real tank physics; each agent speaks the same protocol as the Cerbo</a:t>
-            </a:r>
-            <a:endParaRPr lang="en-US" sz="1150" dirty="0"/>
-          </a:p>
-        </p:txBody>
-      </p:sp>
-      <p:sp>
-        <p:nvSpPr>
-          <p:cNvPr id="30" name="dot"/>
-          <p:cNvSpPr/>
-          <p:nvPr/>
-        </p:nvSpPr>
-        <p:spPr>
-          <a:xfrm>
-            <a:off x="6217920" y="5175504"/>
-            <a:ext cx="384048" cy="384048"/>
-          </a:xfrm>
-          <a:prstGeom prst="ellipse">
-            <a:avLst/>
-          </a:prstGeom>
-          <a:solidFill>
-            <a:schemeClr val="accent1"/>
-          </a:solidFill>
-          <a:ln w="12700">
-            <a:solidFill>
-              <a:schemeClr val="accent1"/>
-            </a:solidFill>
-            <a:prstDash val="solid"/>
-          </a:ln>
-        </p:spPr>
-      </p:sp>
-      <p:sp>
-        <p:nvSpPr>
-          <p:cNvPr id="31" name="Text 29"/>
-          <p:cNvSpPr txBox="1"/>
-          <p:nvPr/>
-        </p:nvSpPr>
-        <p:spPr>
-          <a:xfrm>
-            <a:off x="6766560" y="5129784"/>
-            <a:ext cx="4937760" cy="320040"/>
-          </a:xfrm>
-          <a:prstGeom prst="rect">
-            <a:avLst/>
-          </a:prstGeom>
-          <a:noFill/>
-          <a:ln/>
-        </p:spPr>
-        <p:txBody>
-          <a:bodyPr wrap="square" lIns="0" tIns="0" rIns="0" bIns="0" rtlCol="0" anchor="t"/>
-          <a:lstStyle/>
-          <a:p>
-            <a:pPr indent="0" marL="0">
-              <a:buNone/>
-            </a:pPr>
-            <a:r>
-              <a:rPr lang="en-US" sz="1400" b="1" dirty="0">
+              </a:rPr>
+              <a:t>Board, pin Blatnica: send SUPPORT from the Manual tab; tiles move within seconds</a:t>
+            </a:r>
+            <a:endParaRPr lang="en-US" sz="1250" dirty="0"/>
+          </a:p>
+          <a:p>
+            <a:pPr marL="342900" indent="-342900">
+              <a:spcAft>
+                <a:spcPts val="600"/>
+              </a:spcAft>
+              <a:buSzPct val="100000"/>
+              <a:buChar char="•"/>
+            </a:pPr>
+            <a:r>
+              <a:rPr lang="en-US" sz="1250" dirty="0">
                 <a:solidFill>
                   <a:schemeClr val="tx1"/>
                 </a:solidFill>
-                <a:latin typeface="Arial" pitchFamily="34" charset="0"/>
-                <a:ea typeface="Arial" pitchFamily="34" charset="-122"/>
-                <a:cs typeface="Arial" pitchFamily="34" charset="-120"/>
-              </a:rPr>
-              <a:t>Protocol</a:t>
-            </a:r>
-            <a:endParaRPr lang="en-US" sz="1400" dirty="0"/>
-          </a:p>
-        </p:txBody>
-      </p:sp>
-      <p:sp>
-        <p:nvSpPr>
-          <p:cNvPr id="32" name="Text 30"/>
-          <p:cNvSpPr txBox="1"/>
-          <p:nvPr/>
-        </p:nvSpPr>
-        <p:spPr>
-          <a:xfrm>
-            <a:off x="6766560" y="5449824"/>
-            <a:ext cx="4937760" cy="640080"/>
-          </a:xfrm>
-          <a:prstGeom prst="rect">
-            <a:avLst/>
-          </a:prstGeom>
-          <a:noFill/>
-          <a:ln/>
-        </p:spPr>
-        <p:txBody>
-          <a:bodyPr wrap="square" lIns="0" tIns="0" rIns="0" bIns="0" rtlCol="0" anchor="t"/>
-          <a:lstStyle/>
-          <a:p>
-            <a:pPr indent="0" marL="0">
-              <a:buNone/>
-            </a:pPr>
-            <a:r>
-              <a:rPr lang="en-US" sz="1150" dirty="0">
-                <a:solidFill>
-                  <a:schemeClr val="tx2"/>
-                </a:solidFill>
-              </a:rPr>
-              <a:t>Frozen as PROTOCOL.md with JSON Schemas for envelope, signal and ack; any vendor can implement the eight functions from it</a:t>
-            </a:r>
-            <a:endParaRPr lang="en-US" sz="1150" dirty="0"/>
+              </a:rPr>
+              <a:t>VRM: the same plant from Victron's side, grid setpoint and battery power reacting</a:t>
+            </a:r>
+            <a:endParaRPr lang="en-US" sz="1250" dirty="0"/>
+          </a:p>
+          <a:p>
+            <a:pPr marL="342900" indent="-342900">
+              <a:spcAft>
+                <a:spcPts val="600"/>
+              </a:spcAft>
+              <a:buSzPct val="100000"/>
+              <a:buChar char="•"/>
+            </a:pPr>
+            <a:r>
+              <a:rPr lang="en-US" sz="1250" dirty="0">
+                <a:solidFill>
+                  <a:schemeClr val="tx1"/>
+                </a:solidFill>
+              </a:rPr>
+              <a:t>Board: pause the heartbeat, every house reverts to owner mode</a:t>
+            </a:r>
+            <a:endParaRPr lang="en-US" sz="1250" dirty="0"/>
           </a:p>
         </p:txBody>
       </p:sp>

</xml_diff>

<commit_message>
Deck: measured numbers on the real-vs-modelled slide
Co-Authored-By: Claude Fable 5.1 <noreply@anthropic.com>
</commit_message>
<xml_diff>
--- a/docs/Gridzilla-pitch.pptx
+++ b/docs/Gridzilla-pitch.pptx
@@ -121,24 +121,24 @@
   <p:extLst>
     <p:ext uri="{521415D9-36F7-43E2-AB2F-B90AF26B5E84}">
       <p14:sectionLst xmlns:p14="http://schemas.microsoft.com/office/powerpoint/2010/main">
-        <p14:section name="Opening" id="{0ee454b8-b806-d688-45da-da11d4935494}">
+        <p14:section name="Opening" id="{aaeff5cc-647c-ab6f-0cac-eb51b6cb00d6}">
           <p14:sldIdLst>
             <p14:sldId id="256"/>
           </p14:sldIdLst>
         </p14:section>
-        <p14:section name="Why" id="{62db21e0-0fdf-9e72-4eaa-f90ddf9689b7}">
+        <p14:section name="Why" id="{88e954c0-a29d-dce3-0dda-91b1aed04227}">
           <p14:sldIdLst>
             <p14:sldId id="257"/>
           </p14:sldIdLst>
         </p14:section>
-        <p14:section name="What" id="{84ef2d7e-51bc-2cff-f596-20ba7b39ba7e}">
+        <p14:section name="What" id="{8cbf00ac-b8b2-07dc-4767-fcf34f6ba030}">
           <p14:sldIdLst>
             <p14:sldId id="258"/>
             <p14:sldId id="259"/>
             <p14:sldId id="260"/>
           </p14:sldIdLst>
         </p14:section>
-        <p14:section name="How" id="{cc895447-e983-2689-57a9-1e36c51d390c}">
+        <p14:section name="How" id="{fd6e3254-ec55-dc75-25b8-27f4b7ce0194}">
           <p14:sldIdLst>
             <p14:sldId id="261"/>
             <p14:sldId id="262"/>
@@ -146,12 +146,12 @@
             <p14:sldId id="264"/>
           </p14:sldIdLst>
         </p14:section>
-        <p14:section name="Demo" id="{7fc0d29a-1ca7-38ce-1773-b0daf8ad3234}">
+        <p14:section name="Demo" id="{2cae6720-9792-f453-06e0-ef7299793987}">
           <p14:sldIdLst>
             <p14:sldId id="265"/>
           </p14:sldIdLst>
         </p14:section>
-        <p14:section name="Built" id="{34d0d58b-6b43-551f-0d9b-5f7b44f30710}">
+        <p14:section name="Built" id="{dd64a633-5978-9bdc-96b8-04f38816e973}">
           <p14:sldIdLst>
             <p14:sldId id="266"/>
             <p14:sldId id="267"/>
@@ -159,7 +159,7 @@
             <p14:sldId id="269"/>
           </p14:sldIdLst>
         </p14:section>
-        <p14:section name="Close" id="{32e0c8af-d44e-2cee-3936-b8eb80f3ea67}">
+        <p14:section name="Close" id="{6c229dad-7ee5-a40d-f9b2-543e1c1a9439}">
           <p14:sldIdLst>
             <p14:sldId id="270"/>
           </p14:sldIdLst>
@@ -1800,7 +1800,7 @@
           <a:p>
             <a:r>
               <a:rPr lang="en-US" dirty="0"/>
-              <a:t>8:00-8:45. Say it before the jury asks: the signal path and the algorithm are real, the fleet is simulated, and here is exactly how much the simulation flatters us. The street number is defensible from published pilots; the city number is arithmetic on enrolment.</a:t>
+              <a:t>8:00-8:45. Say it before the jury asks: the signal path and the algorithm are real, the fleet is simulated, and the counterfactual is honest: same cars, same batteries, realistic charging coincidence. The street numbers sit inside published pilots; the city number is that times 2,184 enrolled houses.</a:t>
             </a:r>
             <a:endParaRPr lang="en-US" dirty="0"/>
           </a:p>
@@ -10849,7 +10849,7 @@
       </p:pic>
       <p:sp>
         <p:nvSpPr>
-          <p:cNvPr id="4" name="stat Vienna evening peak, of transformer rating: 23.7 MW becomes 13.4 MW"/>
+          <p:cNvPr id="4" name="stat the planner's forecast for tonight, of transformer rating: 23.7 MW becomes 13.4 MW. Measured result on the next slide"/>
           <p:cNvSpPr/>
           <p:nvPr/>
         </p:nvSpPr>
@@ -10943,7 +10943,7 @@
                   <a:schemeClr val="tx2"/>
                 </a:solidFill>
               </a:rPr>
-              <a:t>Vienna evening peak, of transformer rating: 23.7 MW becomes 13.4 MW</a:t>
+              <a:t>the planner's forecast for tonight, of transformer rating: 23.7 MW becomes 13.4 MW. Measured result on the next slide</a:t>
             </a:r>
             <a:endParaRPr lang="en-US" sz="1200" dirty="0"/>
           </a:p>
@@ -11422,7 +11422,7 @@
                   <a:schemeClr val="tx1"/>
                 </a:solidFill>
               </a:rPr>
-              <a:t>One street in the program: 25-30 % off its evening peak, inside what published smart-charging and home-battery pilots report (3-6 kW per EV house, 1-2 kW per battery at the peak)</a:t>
+              <a:t>Measured on streets with cars: 18-31 % off the evening peak, inside what published smart-charging and home-battery pilots report (3-6 kW per EV house, 1-2 kW per battery at the peak)</a:t>
             </a:r>
             <a:endParaRPr lang="en-US" sz="1250" dirty="0"/>
           </a:p>
@@ -11571,7 +11571,7 @@
                   <a:schemeClr val="tx1"/>
                 </a:solidFill>
               </a:rPr>
-              <a:t>The "without" curve assumes every car starts at full power the moment it is plugged in; real uncontrolled charging has 40-60 % coincidence, so the true gap is about half</a:t>
+              <a:t>The "without" curve is the same houses with no signal: a car charges on 55 % of nights, arrivals spread over three hours, full power until full. No inflated coincidence</a:t>
             </a:r>
             <a:endParaRPr lang="en-US" sz="1250" dirty="0"/>
           </a:p>
@@ -11597,7 +11597,7 @@
       </p:sp>
       <p:sp>
         <p:nvSpPr>
-          <p:cNvPr id="11" name="stat one street, Erdberg-47: 615 → 439 kW at the peak, 29 %. The number we stand behind"/>
+          <p:cNvPr id="11" name="stat one street, Speising-22: 574 → 398 kW at the evening peak, 31 %, measured tonight"/>
           <p:cNvSpPr/>
           <p:nvPr/>
         </p:nvSpPr>
@@ -11691,7 +11691,7 @@
                   <a:schemeClr val="tx2"/>
                 </a:solidFill>
               </a:rPr>
-              <a:t>one street, Erdberg-47: 615 → 439 kW at the peak, 29 %. The number we stand behind</a:t>
+              <a:t>one street, Speising-22: 574 → 398 kW at the evening peak, 31 %, measured tonight</a:t>
             </a:r>
             <a:endParaRPr lang="en-US" sz="1200" dirty="0"/>
           </a:p>
@@ -11699,7 +11699,7 @@
       </p:sp>
       <p:sp>
         <p:nvSpPr>
-          <p:cNvPr id="14" name="stat Vienna, if 2,000 houses enrol: the street effect times enrolment, with the coincidence caveat"/>
+          <p:cNvPr id="14" name="stat Vienna with 2,184 enrolled houses: 26.6 → 21.7 MW at the evening peak, 19 %, measured tonight"/>
           <p:cNvSpPr/>
           <p:nvPr/>
         </p:nvSpPr>
@@ -11757,7 +11757,7 @@
                 <a:ea typeface="Arial" pitchFamily="34" charset="-122"/>
                 <a:cs typeface="Arial" pitchFamily="34" charset="-120"/>
               </a:rPr>
-              <a:t>−11 MW</a:t>
+              <a:t>−5.2 MW</a:t>
             </a:r>
             <a:endParaRPr lang="en-US" sz="3600" dirty="0"/>
           </a:p>
@@ -11793,7 +11793,7 @@
                   <a:schemeClr val="tx2"/>
                 </a:solidFill>
               </a:rPr>
-              <a:t>Vienna, if 2,000 houses enrol: the street effect times enrolment, with the coincidence caveat</a:t>
+              <a:t>Vienna with 2,184 enrolled houses: 26.6 → 21.7 MW at the evening peak, 19 %, measured tonight</a:t>
             </a:r>
             <a:endParaRPr lang="en-US" sz="1200" dirty="0"/>
           </a:p>
@@ -11801,7 +11801,7 @@
       </p:sp>
       <p:sp>
         <p:nvSpPr>
-          <p:cNvPr id="17" name="stat the same fleet with realistic charging coincidence. Still a substation's worth of peak"/>
+          <p:cNvPr id="17" name="stat on a street where no car charged tonight: the gap is the cars and the batteries, nothing else"/>
           <p:cNvSpPr/>
           <p:nvPr/>
         </p:nvSpPr>
@@ -11859,7 +11859,7 @@
                 <a:ea typeface="Arial" pitchFamily="34" charset="-122"/>
                 <a:cs typeface="Arial" pitchFamily="34" charset="-120"/>
               </a:rPr>
-              <a:t>~5-6 MW</a:t>
+              <a:t>0 kW</a:t>
             </a:r>
             <a:endParaRPr lang="en-US" sz="3600" dirty="0"/>
           </a:p>
@@ -11895,7 +11895,7 @@
                   <a:schemeClr val="tx2"/>
                 </a:solidFill>
               </a:rPr>
-              <a:t>the same fleet with realistic charging coincidence. Still a substation's worth of peak</a:t>
+              <a:t>on a street where no car charged tonight: the gap is the cars and the batteries, nothing else</a:t>
             </a:r>
             <a:endParaRPr lang="en-US" sz="1200" dirty="0"/>
           </a:p>

</xml_diff>

<commit_message>
Deck: STRETCH presented as the grid-forming vision, on the signals slide, the production slide and the close
Co-Authored-By: Claude Fable 5.1 <noreply@anthropic.com>
</commit_message>
<xml_diff>
--- a/docs/Gridzilla-pitch.pptx
+++ b/docs/Gridzilla-pitch.pptx
@@ -121,24 +121,24 @@
   <p:extLst>
     <p:ext uri="{521415D9-36F7-43E2-AB2F-B90AF26B5E84}">
       <p14:sectionLst xmlns:p14="http://schemas.microsoft.com/office/powerpoint/2010/main">
-        <p14:section name="Opening" id="{aaeff5cc-647c-ab6f-0cac-eb51b6cb00d6}">
+        <p14:section name="Opening" id="{d5b1cbed-e42e-022d-4b36-58c646d50259}">
           <p14:sldIdLst>
             <p14:sldId id="256"/>
           </p14:sldIdLst>
         </p14:section>
-        <p14:section name="Why" id="{88e954c0-a29d-dce3-0dda-91b1aed04227}">
+        <p14:section name="Why" id="{ef45d961-ffb1-42ff-9b88-146055f98c39}">
           <p14:sldIdLst>
             <p14:sldId id="257"/>
           </p14:sldIdLst>
         </p14:section>
-        <p14:section name="What" id="{8cbf00ac-b8b2-07dc-4767-fcf34f6ba030}">
+        <p14:section name="What" id="{11dc471b-f47e-f999-d4aa-af93d19e1546}">
           <p14:sldIdLst>
             <p14:sldId id="258"/>
             <p14:sldId id="259"/>
             <p14:sldId id="260"/>
           </p14:sldIdLst>
         </p14:section>
-        <p14:section name="How" id="{fd6e3254-ec55-dc75-25b8-27f4b7ce0194}">
+        <p14:section name="How" id="{876204de-6b7f-3df0-d35a-e30b704ee831}">
           <p14:sldIdLst>
             <p14:sldId id="261"/>
             <p14:sldId id="262"/>
@@ -146,12 +146,12 @@
             <p14:sldId id="264"/>
           </p14:sldIdLst>
         </p14:section>
-        <p14:section name="Demo" id="{2cae6720-9792-f453-06e0-ef7299793987}">
+        <p14:section name="Demo" id="{55a81845-14d3-a79e-c431-6e8afdd207e7}">
           <p14:sldIdLst>
             <p14:sldId id="265"/>
           </p14:sldIdLst>
         </p14:section>
-        <p14:section name="Built" id="{dd64a633-5978-9bdc-96b8-04f38816e973}">
+        <p14:section name="Built" id="{96fb8840-77c5-c3a9-c943-c2578efa5cd3}">
           <p14:sldIdLst>
             <p14:sldId id="266"/>
             <p14:sldId id="267"/>
@@ -159,7 +159,7 @@
             <p14:sldId id="269"/>
           </p14:sldIdLst>
         </p14:section>
-        <p14:section name="Close" id="{6c229dad-7ee5-a40d-f9b2-543e1c1a9439}">
+        <p14:section name="Close" id="{f0b20f2f-b5d6-845e-879d-e54a8917bf87}">
           <p14:sldIdLst>
             <p14:sldId id="270"/>
           </p14:sldIdLst>
@@ -1360,7 +1360,7 @@
           <a:p>
             <a:r>
               <a:rPr lang="en-US" dirty="0"/>
-              <a:t>3:30-4:30. Do not read all six. Point at SUPPORT and ABSORB, the everyday ones, and PREPARE and STRETCH, the crisis ones.</a:t>
+              <a:t>3:30-4:30. Do not read all six. Point at SUPPORT and ABSORB, the everyday ones, PREPARE and RECOVER, the crisis ones, and name STRETCH as the vision: a street that keeps its lights on from its own basements needs grid-forming inverters, which are arriving. The protocol already has the signal for them.</a:t>
             </a:r>
             <a:endParaRPr lang="en-US" dirty="0"/>
           </a:p>
@@ -6127,7 +6127,7 @@
                   <a:schemeClr val="tx1"/>
                 </a:solidFill>
               </a:rPr>
-              <a:t>Plus the only tool a DSO has during an outage: STRETCH rations the batteries of a dark street</a:t>
+              <a:t>Plus a tool for the outage: PREPARE before it, RECOVER after it, and with grid-forming inverters STRETCH keeps a dark street alive from its own batteries</a:t>
             </a:r>
             <a:endParaRPr lang="en-US" sz="1450" dirty="0"/>
           </a:p>
@@ -6355,6 +6355,20 @@
             </a:r>
             <a:endParaRPr lang="en-US" sz="2200" dirty="0"/>
           </a:p>
+          <a:p>
+            <a:pPr algn="l" indent="0" marL="0">
+              <a:buNone/>
+            </a:pPr>
+            <a:r>
+              <a:rPr lang="en-US" sz="2200" dirty="0">
+                <a:solidFill>
+                  <a:schemeClr val="tx2"/>
+                </a:solidFill>
+              </a:rPr>
+              <a:t>The vision: streets that island on grid-forming inverters when the 22 kV line is gone, rationed by the same signal.</a:t>
+            </a:r>
+            <a:endParaRPr lang="en-US" sz="2200" dirty="0"/>
+          </a:p>
         </p:txBody>
       </p:sp>
       <p:sp>
@@ -8030,8 +8044,8 @@
         </p:nvSpPr>
         <p:spPr>
           <a:xfrm>
-            <a:off x="777240" y="2286000"/>
-            <a:ext cx="3108960" cy="822960"/>
+            <a:off x="777240" y="2212848"/>
+            <a:ext cx="3108960" cy="914400"/>
           </a:xfrm>
           <a:prstGeom prst="rect">
             <a:avLst/>
@@ -8157,8 +8171,8 @@
         </p:nvSpPr>
         <p:spPr>
           <a:xfrm>
-            <a:off x="4526280" y="2286000"/>
-            <a:ext cx="3108960" cy="822960"/>
+            <a:off x="4526280" y="2212848"/>
+            <a:ext cx="3108960" cy="914400"/>
           </a:xfrm>
           <a:prstGeom prst="rect">
             <a:avLst/>
@@ -8284,8 +8298,8 @@
         </p:nvSpPr>
         <p:spPr>
           <a:xfrm>
-            <a:off x="8275320" y="2286000"/>
-            <a:ext cx="3108960" cy="822960"/>
+            <a:off x="8275320" y="2212848"/>
+            <a:ext cx="3108960" cy="914400"/>
           </a:xfrm>
           <a:prstGeom prst="rect">
             <a:avLst/>
@@ -8314,7 +8328,7 @@
       </p:sp>
       <p:sp>
         <p:nvSpPr>
-          <p:cNvPr id="15" name="signal STRETCH"/>
+          <p:cNvPr id="15" name="signal STRETCH · vision"/>
           <p:cNvSpPr/>
           <p:nvPr/>
         </p:nvSpPr>
@@ -8397,7 +8411,7 @@
                 <a:ea typeface="Arial" pitchFamily="34" charset="-122"/>
                 <a:cs typeface="Arial" pitchFamily="34" charset="-120"/>
               </a:rPr>
-              <a:t>STRETCH</a:t>
+              <a:t>STRETCH · vision</a:t>
             </a:r>
             <a:endParaRPr lang="en-US" sz="1800" dirty="0"/>
           </a:p>
@@ -8411,8 +8425,8 @@
         </p:nvSpPr>
         <p:spPr>
           <a:xfrm>
-            <a:off x="777240" y="4069080"/>
-            <a:ext cx="3108960" cy="822960"/>
+            <a:off x="777240" y="3995928"/>
+            <a:ext cx="3108960" cy="914400"/>
           </a:xfrm>
           <a:prstGeom prst="rect">
             <a:avLst/>
@@ -8428,14 +8442,14 @@
               <a:buNone/>
             </a:pPr>
             <a:r>
-              <a:rPr lang="en-US" sz="1250" dirty="0">
+              <a:rPr lang="en-US" sz="1100" dirty="0">
                 <a:solidFill>
                   <a:schemeClr val="tx2"/>
                 </a:solidFill>
               </a:rPr>
-              <a:t>Street is dark: island, ration the battery until restoration, export locked to zero</a:t>
-            </a:r>
-            <a:endParaRPr lang="en-US" sz="1250" dirty="0"/>
+              <a:t>Street is dark: grid-forming inverters island the street, batteries are rationed until restoration, export locked to zero. Today's home inverters cannot form a grid; the signal is ready for the ones that will</a:t>
+            </a:r>
+            <a:endParaRPr lang="en-US" sz="1100" dirty="0"/>
           </a:p>
         </p:txBody>
       </p:sp>
@@ -8538,8 +8552,8 @@
         </p:nvSpPr>
         <p:spPr>
           <a:xfrm>
-            <a:off x="4526280" y="4069080"/>
-            <a:ext cx="3108960" cy="822960"/>
+            <a:off x="4526280" y="3995928"/>
+            <a:ext cx="3108960" cy="914400"/>
           </a:xfrm>
           <a:prstGeom prst="rect">
             <a:avLst/>
@@ -8665,8 +8679,8 @@
         </p:nvSpPr>
         <p:spPr>
           <a:xfrm>
-            <a:off x="8275320" y="4069080"/>
-            <a:ext cx="3108960" cy="822960"/>
+            <a:off x="8275320" y="3995928"/>
+            <a:ext cx="3108960" cy="914400"/>
           </a:xfrm>
           <a:prstGeom prst="rect">
             <a:avLst/>

</xml_diff>

<commit_message>
Title slide: the line after the jingle
Co-Authored-By: Claude Fable 5.1 <noreply@anthropic.com>
</commit_message>
<xml_diff>
--- a/docs/Gridzilla-pitch.pptx
+++ b/docs/Gridzilla-pitch.pptx
@@ -121,32 +121,32 @@
   <p:extLst>
     <p:ext uri="{521415D9-36F7-43E2-AB2F-B90AF26B5E84}">
       <p14:sectionLst xmlns:p14="http://schemas.microsoft.com/office/powerpoint/2010/main">
-        <p14:section name="Opening" id="{56b19f9d-f71e-4558-0f6a-660be899797c}">
+        <p14:section name="Opening" id="{38d20f2d-f05e-39e2-848e-b61544146615}">
           <p14:sldIdLst>
             <p14:sldId id="256"/>
           </p14:sldIdLst>
         </p14:section>
-        <p14:section name="Why" id="{cd7545c1-319f-4a70-66d6-ee4afa25e44f}">
+        <p14:section name="Why" id="{3bbb6860-8df7-7e3b-b0ca-1c449af9f5cc}">
           <p14:sldIdLst>
             <p14:sldId id="257"/>
           </p14:sldIdLst>
         </p14:section>
-        <p14:section name="What" id="{88d62e64-43f3-5367-a957-e0828c492540}">
+        <p14:section name="What" id="{383e153e-0b86-e80a-eef8-bf630bed1419}">
           <p14:sldIdLst>
             <p14:sldId id="258"/>
           </p14:sldIdLst>
         </p14:section>
-        <p14:section name="Demo" id="{5f3ebbdf-26d9-8daf-8f3a-83dd8c72b99d}">
+        <p14:section name="Demo" id="{9603302e-d8af-df24-be18-e1b1cc3789da}">
           <p14:sldIdLst>
             <p14:sldId id="260"/>
           </p14:sldIdLst>
         </p14:section>
-        <p14:section name="Close" id="{36061a63-a165-4fc8-a52d-40271c7bc1a3}">
+        <p14:section name="Close" id="{69efce7b-08c8-d1a1-ccfe-190799c257b0}">
           <p14:sldIdLst>
             <p14:sldId id="262"/>
           </p14:sldIdLst>
         </p14:section>
-        <p14:section name="Appendix" id="{bd5c6bea-922a-273b-da5c-94c56e104c1a}">
+        <p14:section name="Appendix" id="{193d09b3-6ef8-6149-4d93-49a4d9c3c61a}">
           <p14:sldIdLst>
             <p14:sldId id="263"/>
             <p14:sldId id="264"/>
@@ -562,7 +562,7 @@
           <a:p>
             <a:r>
               <a:rPr lang="en-US" dirty="0"/>
-              <a:t>0:00-0:30. Click the speaker icon top right the moment the slide is up: 30 seconds of trailer, say nothing, let it land. Then One sentence: a DSO signal that home batteries, cars and heat pumps follow, signed, bounded, with the owner always in control. Say what is real: a Victron plant and a Viessmann heat pump in Blatnica are on the board right now.</a:t>
+              <a:t>0:00-0:30. Click the speaker icon top right the moment the slide is up: 30 seconds of trailer, say nothing, let it land. After the hard cut, one line, deadpan: Now you probably wonder what the monster really is. Then next slide.</a:t>
             </a:r>
             <a:endParaRPr lang="en-US" dirty="0"/>
           </a:p>

</xml_diff>

<commit_message>
Diet slide in plain English: outcome first, no water-filling or L on the slide; guide updated
Co-Authored-By: Claude Fable 5.1 <noreply@anthropic.com>
</commit_message>
<xml_diff>
--- a/docs/Gridzilla-pitch.pptx
+++ b/docs/Gridzilla-pitch.pptx
@@ -121,32 +121,32 @@
   <p:extLst>
     <p:ext uri="{521415D9-36F7-43E2-AB2F-B90AF26B5E84}">
       <p14:sectionLst xmlns:p14="http://schemas.microsoft.com/office/powerpoint/2010/main">
-        <p14:section name="Opening" id="{38d20f2d-f05e-39e2-848e-b61544146615}">
+        <p14:section name="Opening" id="{034642bc-b0d8-b9d8-c36b-a3cc28a67f1a}">
           <p14:sldIdLst>
             <p14:sldId id="256"/>
           </p14:sldIdLst>
         </p14:section>
-        <p14:section name="Why" id="{3bbb6860-8df7-7e3b-b0ca-1c449af9f5cc}">
+        <p14:section name="Why" id="{7f0053f0-64a7-c0bf-142b-8844547f553a}">
           <p14:sldIdLst>
             <p14:sldId id="257"/>
           </p14:sldIdLst>
         </p14:section>
-        <p14:section name="What" id="{383e153e-0b86-e80a-eef8-bf630bed1419}">
+        <p14:section name="What" id="{460a6234-7ed3-0684-4ef4-d1c062bfcf8b}">
           <p14:sldIdLst>
             <p14:sldId id="258"/>
           </p14:sldIdLst>
         </p14:section>
-        <p14:section name="Demo" id="{9603302e-d8af-df24-be18-e1b1cc3789da}">
+        <p14:section name="Demo" id="{367714e0-e1e2-335b-e973-ed1a7adc4a39}">
           <p14:sldIdLst>
             <p14:sldId id="260"/>
           </p14:sldIdLst>
         </p14:section>
-        <p14:section name="Close" id="{69efce7b-08c8-d1a1-ccfe-190799c257b0}">
+        <p14:section name="Close" id="{c09b8a6e-a882-f0d3-7970-167db371674f}">
           <p14:sldIdLst>
             <p14:sldId id="262"/>
           </p14:sldIdLst>
         </p14:section>
-        <p14:section name="Appendix" id="{193d09b3-6ef8-6149-4d93-49a4d9c3c61a}">
+        <p14:section name="Appendix" id="{a4290ca0-544a-c573-9f59-9f4849c494cd}">
           <p14:sldIdLst>
             <p14:sldId id="263"/>
             <p14:sldId id="264"/>
@@ -1354,7 +1354,7 @@
           <a:p>
             <a:r>
               <a:rPr lang="en-US" dirty="0"/>
-              <a:t>1:45-2:30. Monster talk: Gridzilla eats peaks, but it is on a diet: it eats exactly the slice above L and not a watt more. A car plugged in at 18:00 trickles through dinner and gulps at 02:00. A battery swallows the peak and burps it back into the house. At noon it drinks the PV surplus. Nobody notices; the transformer sleeps at 70 instead of 110 percent. Then the algorithm in one breath: forecast what nobody controls, count the flexible energy, water-fill, send the ceilings. DeepSeek sits on top for what the plan cannot see: a cold snap, an outage, backflow.</a:t>
+              <a:t>1:45-2:30. Gridzilla eats peaks. Every street, every evening. At six the cars come home and the transformer would go to a hundred and ten percent. With Gridzilla it stays at seventy. The cars still charge, just not all at dinner: a car plugged in at six trickles through the evening and fills up at two in the morning, full by seven. The batteries eat the dinner spike. The sun at noon goes into the batteries instead of the feeder. Nobody at home notices. And the operator never buys that bigger transformer. Planned every two hours from the real weather forecast, for the whole city, by thirty lines of code, not by the AI. If asked how: valley filling, the textbook method.</a:t>
             </a:r>
             <a:endParaRPr lang="en-US" dirty="0"/>
           </a:p>
@@ -8599,7 +8599,7 @@
                   <a:schemeClr val="tx1"/>
                 </a:solidFill>
               </a:rPr>
-              <a:t>The monster is on a diet: water-filling flattens every street</a:t>
+              <a:t>The monster eats peaks. Every street, every evening</a:t>
             </a:r>
             <a:endParaRPr lang="en-US" sz="3200" dirty="0"/>
           </a:p>
@@ -8631,7 +8631,7 @@
       </p:pic>
       <p:sp>
         <p:nvSpPr>
-          <p:cNvPr id="4" name="stat the planner's forecast for tonight, of transformer rating: 23.7 MW becomes 13.4 MW. Measured result on the next slide"/>
+          <p:cNvPr id="4" name="stat Vienna's evening peak as a share of what the transformers can carry: 23.7 MW becomes 13.4 MW. Planned for tonight; measured on the next slide"/>
           <p:cNvSpPr/>
           <p:nvPr/>
         </p:nvSpPr>
@@ -8725,7 +8725,7 @@
                   <a:schemeClr val="tx2"/>
                 </a:solidFill>
               </a:rPr>
-              <a:t>the planner's forecast for tonight, of transformer rating: 23.7 MW becomes 13.4 MW. Measured result on the next slide</a:t>
+              <a:t>Vienna's evening peak as a share of what the transformers can carry: 23.7 MW becomes 13.4 MW. Planned for tonight; measured on the next slide</a:t>
             </a:r>
             <a:endParaRPr lang="en-US" sz="1200" dirty="0"/>
           </a:p>
@@ -8733,7 +8733,7 @@
       </p:sp>
       <p:sp>
         <p:nvSpPr>
-          <p:cNvPr id="7" name="stat of car charging moved from dinner into the night valley; every car full by 07:00"/>
+          <p:cNvPr id="7" name="stat of car charging moved from dinner time into the night. Every car full by seven"/>
           <p:cNvSpPr/>
           <p:nvPr/>
         </p:nvSpPr>
@@ -8827,7 +8827,7 @@
                   <a:schemeClr val="tx2"/>
                 </a:solidFill>
               </a:rPr>
-              <a:t>of car charging moved from dinner into the night valley; every car full by 07:00</a:t>
+              <a:t>of car charging moved from dinner time into the night. Every car full by seven</a:t>
             </a:r>
             <a:endParaRPr lang="en-US" sz="1200" dirty="0"/>
           </a:p>
@@ -8835,7 +8835,7 @@
       </p:sp>
       <p:sp>
         <p:nvSpPr>
-          <p:cNvPr id="10" name="stat the lowest level where the cars fit below it and the peak above it fits in the batteries. Two ceilings per 15 min, per house, signed, renewed every 2 h"/>
+          <p:cNvPr id="10" name="stat transformer upgrades. The batteries eat the dinner spike, the noon sun goes into the batteries, nobody at home notices"/>
           <p:cNvSpPr/>
           <p:nvPr/>
         </p:nvSpPr>
@@ -8893,7 +8893,7 @@
                 <a:ea typeface="Arial" pitchFamily="34" charset="-122"/>
                 <a:cs typeface="Arial" pitchFamily="34" charset="-120"/>
               </a:rPr>
-              <a:t>L</a:t>
+              <a:t>0</a:t>
             </a:r>
             <a:endParaRPr lang="en-US" sz="3600" dirty="0"/>
           </a:p>
@@ -8929,7 +8929,7 @@
                   <a:schemeClr val="tx2"/>
                 </a:solidFill>
               </a:rPr>
-              <a:t>the lowest level where the cars fit below it and the peak above it fits in the batteries. Two ceilings per 15 min, per house, signed, renewed every 2 h</a:t>
+              <a:t>transformer upgrades. The batteries eat the dinner spike, the noon sun goes into the batteries, nobody at home notices</a:t>
             </a:r>
             <a:endParaRPr lang="en-US" sz="1200" dirty="0"/>
           </a:p>

</xml_diff>

<commit_message>
Diet slide: tile labels fit
Co-Authored-By: Claude Fable 5.1 <noreply@anthropic.com>
</commit_message>
<xml_diff>
--- a/docs/Gridzilla-pitch.pptx
+++ b/docs/Gridzilla-pitch.pptx
@@ -121,32 +121,32 @@
   <p:extLst>
     <p:ext uri="{521415D9-36F7-43E2-AB2F-B90AF26B5E84}">
       <p14:sectionLst xmlns:p14="http://schemas.microsoft.com/office/powerpoint/2010/main">
-        <p14:section name="Opening" id="{034642bc-b0d8-b9d8-c36b-a3cc28a67f1a}">
+        <p14:section name="Opening" id="{0634f85c-f273-682d-386b-02c8bcbcf93c}">
           <p14:sldIdLst>
             <p14:sldId id="256"/>
           </p14:sldIdLst>
         </p14:section>
-        <p14:section name="Why" id="{7f0053f0-64a7-c0bf-142b-8844547f553a}">
+        <p14:section name="Why" id="{cf4da425-a9bd-a1e2-e3bb-ca1d94f7e572}">
           <p14:sldIdLst>
             <p14:sldId id="257"/>
           </p14:sldIdLst>
         </p14:section>
-        <p14:section name="What" id="{460a6234-7ed3-0684-4ef4-d1c062bfcf8b}">
+        <p14:section name="What" id="{24c9b102-67ff-d5b2-7112-9ebf7ea69a62}">
           <p14:sldIdLst>
             <p14:sldId id="258"/>
           </p14:sldIdLst>
         </p14:section>
-        <p14:section name="Demo" id="{367714e0-e1e2-335b-e973-ed1a7adc4a39}">
+        <p14:section name="Demo" id="{c2439ae7-cc02-40a7-8bf1-37e5e18f443b}">
           <p14:sldIdLst>
             <p14:sldId id="260"/>
           </p14:sldIdLst>
         </p14:section>
-        <p14:section name="Close" id="{c09b8a6e-a882-f0d3-7970-167db371674f}">
+        <p14:section name="Close" id="{c697aafd-1a08-73e9-8f15-0ea644e30130}">
           <p14:sldIdLst>
             <p14:sldId id="262"/>
           </p14:sldIdLst>
         </p14:section>
-        <p14:section name="Appendix" id="{a4290ca0-544a-c573-9f59-9f4849c494cd}">
+        <p14:section name="Appendix" id="{db3292ef-8a0d-4ad9-fe31-08eec94bc054}">
           <p14:sldIdLst>
             <p14:sldId id="263"/>
             <p14:sldId id="264"/>
@@ -8631,7 +8631,7 @@
       </p:pic>
       <p:sp>
         <p:nvSpPr>
-          <p:cNvPr id="4" name="stat Vienna's evening peak as a share of what the transformers can carry: 23.7 MW becomes 13.4 MW. Planned for tonight; measured on the next slide"/>
+          <p:cNvPr id="4" name="stat Vienna's evening peak, share of transformer capacity: 23.7 → 13.4 MW, planned for tonight"/>
           <p:cNvSpPr/>
           <p:nvPr/>
         </p:nvSpPr>
@@ -8725,7 +8725,7 @@
                   <a:schemeClr val="tx2"/>
                 </a:solidFill>
               </a:rPr>
-              <a:t>Vienna's evening peak as a share of what the transformers can carry: 23.7 MW becomes 13.4 MW. Planned for tonight; measured on the next slide</a:t>
+              <a:t>Vienna's evening peak, share of transformer capacity: 23.7 → 13.4 MW, planned for tonight</a:t>
             </a:r>
             <a:endParaRPr lang="en-US" sz="1200" dirty="0"/>
           </a:p>
@@ -8835,7 +8835,7 @@
       </p:sp>
       <p:sp>
         <p:nvSpPr>
-          <p:cNvPr id="10" name="stat transformer upgrades. The batteries eat the dinner spike, the noon sun goes into the batteries, nobody at home notices"/>
+          <p:cNvPr id="10" name="stat transformer upgrades. Batteries eat the dinner spike, the noon sun charges them, nobody at home notices"/>
           <p:cNvSpPr/>
           <p:nvPr/>
         </p:nvSpPr>
@@ -8929,7 +8929,7 @@
                   <a:schemeClr val="tx2"/>
                 </a:solidFill>
               </a:rPr>
-              <a:t>transformer upgrades. The batteries eat the dinner spike, the noon sun goes into the batteries, nobody at home notices</a:t>
+              <a:t>transformer upgrades. Batteries eat the dinner spike, the noon sun charges them, nobody at home notices</a:t>
             </a:r>
             <a:endParaRPr lang="en-US" sz="1200" dirty="0"/>
           </a:p>

</xml_diff>

<commit_message>
All presented slides in plain English: grid operator, message, maker of the box, no DSO/SoC/setpoint/heartbeat jargon
Co-Authored-By: Claude Fable 5.1 <noreply@anthropic.com>
</commit_message>
<xml_diff>
--- a/docs/Gridzilla-pitch.pptx
+++ b/docs/Gridzilla-pitch.pptx
@@ -121,32 +121,32 @@
   <p:extLst>
     <p:ext uri="{521415D9-36F7-43E2-AB2F-B90AF26B5E84}">
       <p14:sectionLst xmlns:p14="http://schemas.microsoft.com/office/powerpoint/2010/main">
-        <p14:section name="Opening" id="{0634f85c-f273-682d-386b-02c8bcbcf93c}">
+        <p14:section name="Opening" id="{ff7a16a9-a96c-4a02-1bd3-742946ad5373}">
           <p14:sldIdLst>
             <p14:sldId id="256"/>
           </p14:sldIdLst>
         </p14:section>
-        <p14:section name="Why" id="{cf4da425-a9bd-a1e2-e3bb-ca1d94f7e572}">
+        <p14:section name="Why" id="{c51585fa-bc30-e42e-0cb5-3f446e4485c5}">
           <p14:sldIdLst>
             <p14:sldId id="257"/>
           </p14:sldIdLst>
         </p14:section>
-        <p14:section name="What" id="{24c9b102-67ff-d5b2-7112-9ebf7ea69a62}">
+        <p14:section name="What" id="{3a596f7c-0fc8-a157-0983-3a323be7059d}">
           <p14:sldIdLst>
             <p14:sldId id="258"/>
           </p14:sldIdLst>
         </p14:section>
-        <p14:section name="Demo" id="{c2439ae7-cc02-40a7-8bf1-37e5e18f443b}">
+        <p14:section name="Demo" id="{5a054cfa-eb60-2e28-2af0-86a522f41e5f}">
           <p14:sldIdLst>
             <p14:sldId id="260"/>
           </p14:sldIdLst>
         </p14:section>
-        <p14:section name="Close" id="{c697aafd-1a08-73e9-8f15-0ea644e30130}">
+        <p14:section name="Close" id="{e348c19e-a9c1-f286-5591-ccfde031d52d}">
           <p14:sldIdLst>
             <p14:sldId id="262"/>
           </p14:sldIdLst>
         </p14:section>
-        <p14:section name="Appendix" id="{db3292ef-8a0d-4ad9-fe31-08eec94bc054}">
+        <p14:section name="Appendix" id="{2fad0d07-1f15-83dc-d18e-4dd0ecd0550a}">
           <p14:sldIdLst>
             <p14:sldId id="263"/>
             <p14:sldId id="264"/>
@@ -2565,7 +2565,7 @@
                   <a:schemeClr val="tx1"/>
                 </a:solidFill>
               </a:rPr>
-              <a:t>The DSO's monster. Every house keeps it on a leash.</a:t>
+              <a:t>The grid operator's monster. Every house keeps it on a leash.</a:t>
             </a:r>
             <a:endParaRPr lang="en-US" sz="5400" dirty="0"/>
           </a:p>
@@ -2603,7 +2603,7 @@
                   <a:schemeClr val="tx2"/>
                 </a:solidFill>
               </a:rPr>
-              <a:t>A signed, bounded grid signal for home batteries, cars and heat pumps,</a:t>
+              <a:t>One simple message from the grid operator to home batteries, cars and heat pumps: how much the house may take or give, and for how long.</a:t>
             </a:r>
             <a:endParaRPr lang="en-US" sz="2200" dirty="0"/>
           </a:p>
@@ -2617,7 +2617,7 @@
                   <a:schemeClr val="tx2"/>
                 </a:solidFill>
               </a:rPr>
-              <a:t>with DeepSeek running the grid and a real plant in Blatnica following it live.</a:t>
+              <a:t>An AI runs the grid, a real plant in Blatnica follows it live.</a:t>
             </a:r>
             <a:endParaRPr lang="en-US" sz="2200" dirty="0"/>
           </a:p>
@@ -7124,7 +7124,7 @@
                   <a:schemeClr val="tx1"/>
                 </a:solidFill>
               </a:rPr>
-              <a:t>Europe's largest battery fleet is in people's basements. The grid cannot use one of them</a:t>
+              <a:t>Europe's largest battery is in people's basements. The grid cannot use any of it</a:t>
             </a:r>
             <a:endParaRPr lang="en-US" sz="3200" dirty="0"/>
           </a:p>
@@ -7132,7 +7132,7 @@
       </p:sp>
       <p:sp>
         <p:nvSpPr>
-          <p:cNvPr id="3" name="stat DSO-level signals to home storage in Slovakia. The only flexibility pilot served the TSO, not the street transformer"/>
+          <p:cNvPr id="3" name="stat signals from a grid operator to home batteries in Slovakia today. The one pilot helped the national grid, not the street"/>
           <p:cNvSpPr/>
           <p:nvPr/>
         </p:nvSpPr>
@@ -7226,7 +7226,7 @@
                   <a:schemeClr val="tx2"/>
                 </a:solidFill>
               </a:rPr>
-              <a:t>DSO-level signals to home storage in Slovakia. The only flexibility pilot served the TSO, not the street transformer</a:t>
+              <a:t>signals from a grid operator to home batteries in Slovakia today. The one pilot helped the national grid, not the street</a:t>
             </a:r>
             <a:endParaRPr lang="en-US" sz="1200" dirty="0"/>
           </a:p>
@@ -7234,7 +7234,7 @@
       </p:sp>
       <p:sp>
         <p:nvSpPr>
-          <p:cNvPr id="6" name="stat The best case, Germany's §14a: a dimmer for new devices, charging only, used in under 1 % of hours"/>
+          <p:cNvPr id="6" name="stat Germany's best case: the operator may dim a new charger down to this. Charging only, used in under 1 % of hours"/>
           <p:cNvSpPr/>
           <p:nvPr/>
         </p:nvSpPr>
@@ -7328,7 +7328,7 @@
                   <a:schemeClr val="tx2"/>
                 </a:solidFill>
               </a:rPr>
-              <a:t>The best case, Germany's §14a: a dimmer for new devices, charging only, used in under 1 % of hours</a:t>
+              <a:t>Germany's best case: the operator may dim a new charger down to this. Charging only, used in under 1 % of hours</a:t>
             </a:r>
             <a:endParaRPr lang="en-US" sz="1200" dirty="0"/>
           </a:p>
@@ -7336,7 +7336,7 @@
       </p:sp>
       <p:sp>
         <p:nvSpPr>
-          <p:cNvPr id="9" name="stat Home batteries installed in Ukraine in 2025 alone. People charge by hand before the published outage queue"/>
+          <p:cNvPr id="9" name="stat of home batteries installed in Ukraine in 2025 alone. People charge them by hand before the published outage schedule"/>
           <p:cNvSpPr/>
           <p:nvPr/>
         </p:nvSpPr>
@@ -7430,7 +7430,7 @@
                   <a:schemeClr val="tx2"/>
                 </a:solidFill>
               </a:rPr>
-              <a:t>Home batteries installed in Ukraine in 2025 alone. People charge by hand before the published outage queue</a:t>
+              <a:t>of home batteries installed in Ukraine in 2025 alone. People charge them by hand before the published outage schedule</a:t>
             </a:r>
             <a:endParaRPr lang="en-US" sz="1200" dirty="0"/>
           </a:p>
@@ -7533,7 +7533,7 @@
                   <a:schemeClr val="tx1"/>
                 </a:solidFill>
               </a:rPr>
-              <a:t>Evening peaks: heat pumps and EV chargers push street transformers past rating; the DSO's only tools are curtailment or copper</a:t>
+              <a:t>Dinner time: heat pumps and car chargers push the street transformer past what it can carry; the operator can only switch people off or dig up the street for a bigger one</a:t>
             </a:r>
             <a:endParaRPr lang="en-US" sz="1500" dirty="0"/>
           </a:p>
@@ -7551,7 +7551,7 @@
                   <a:schemeClr val="tx1"/>
                 </a:solidFill>
               </a:rPr>
-              <a:t>PV noon: everyone exports at once, the feeder voltage rises, new connections get refused or capped for the whole year</a:t>
+              <a:t>Sunny noon: everyone exports at once, the voltage rises, new solar connections are refused or capped for a year</a:t>
             </a:r>
             <a:endParaRPr lang="en-US" sz="1500" dirty="0"/>
           </a:p>
@@ -7569,7 +7569,7 @@
                   <a:schemeClr val="tx1"/>
                 </a:solidFill>
               </a:rPr>
-              <a:t>Crisis: when a transformer is hit or the country is short, everyone is cut equally, including the houses that could have ridden through</a:t>
+              <a:t>Crisis: when a transformer is hit or the country is short, everyone is cut equally, including the houses that could have ridden it out</a:t>
             </a:r>
             <a:endParaRPr lang="en-US" sz="1500" dirty="0"/>
           </a:p>
@@ -7677,7 +7677,7 @@
                   <a:schemeClr val="tx1"/>
                 </a:solidFill>
               </a:rPr>
-              <a:t>One signed, bounded signal from the DSO to every house, on whatever path the vendor likes</a:t>
+              <a:t>One signed message from the grid operator to every house, on whatever path the maker of the box prefers</a:t>
             </a:r>
             <a:endParaRPr lang="en-US" sz="3200" dirty="0"/>
           </a:p>
@@ -7685,7 +7685,7 @@
       </p:sp>
       <p:sp>
         <p:nvSpPr>
-          <p:cNvPr id="3" name="chain DSO"/>
+          <p:cNvPr id="3" name="chain GRID OPERATOR"/>
           <p:cNvSpPr/>
           <p:nvPr/>
         </p:nvSpPr>
@@ -7725,11 +7725,11 @@
             <a:avLst/>
           </a:prstGeom>
           <a:solidFill>
-            <a:schemeClr val="accent2"/>
+            <a:schemeClr val="accent4"/>
           </a:solidFill>
           <a:ln w="12700">
             <a:solidFill>
-              <a:schemeClr val="accent2"/>
+              <a:schemeClr val="accent4"/>
             </a:solidFill>
             <a:prstDash val="solid"/>
           </a:ln>
@@ -7765,7 +7765,7 @@
                   <a:schemeClr val="tx1"/>
                 </a:solidFill>
               </a:rPr>
-              <a:t>DSO</a:t>
+              <a:t>GRID OPERATOR</a:t>
             </a:r>
             <a:endParaRPr lang="en-US" sz="1300" dirty="0"/>
           </a:p>
@@ -7801,7 +7801,7 @@
                   <a:schemeClr val="tx2"/>
                 </a:solidFill>
               </a:rPr>
-              <a:t>sees a transformer or feeder heading past rating</a:t>
+              <a:t>sees a street or a district heading past its limit</a:t>
             </a:r>
             <a:endParaRPr lang="en-US" sz="1150" dirty="0"/>
           </a:p>
@@ -7950,7 +7950,7 @@
                   <a:schemeClr val="tx2"/>
                 </a:solidFill>
               </a:rPr>
-              <a:t>policy guard, Ed25519 signature, one topic per grid segment</a:t>
+              <a:t>checks the rules, signs the message, addresses one street or one district</a:t>
             </a:r>
             <a:endParaRPr lang="en-US" sz="1150" dirty="0"/>
           </a:p>
@@ -7983,7 +7983,7 @@
       </p:sp>
       <p:sp>
         <p:nvSpPr>
-          <p:cNvPr id="13" name="chain BROKER"/>
+          <p:cNvPr id="13" name="chain MESSAGE BUS"/>
           <p:cNvSpPr/>
           <p:nvPr/>
         </p:nvSpPr>
@@ -8063,7 +8063,7 @@
                   <a:schemeClr val="tx1"/>
                 </a:solidFill>
               </a:rPr>
-              <a:t>BROKER</a:t>
+              <a:t>MESSAGE BUS</a:t>
             </a:r>
             <a:endParaRPr lang="en-US" sz="1300" dirty="0"/>
           </a:p>
@@ -8099,7 +8099,7 @@
                   <a:schemeClr val="tx2"/>
                 </a:solidFill>
               </a:rPr>
-              <a:t>MQTT over TLS, delivery only, no authority</a:t>
+              <a:t>delivers it, has no authority of its own</a:t>
             </a:r>
             <a:endParaRPr lang="en-US" sz="1150" dirty="0"/>
           </a:p>
@@ -8172,11 +8172,11 @@
             <a:avLst/>
           </a:prstGeom>
           <a:solidFill>
-            <a:schemeClr val="accent3"/>
+            <a:schemeClr val="accent2"/>
           </a:solidFill>
           <a:ln w="12700">
             <a:solidFill>
-              <a:schemeClr val="accent3"/>
+              <a:schemeClr val="accent2"/>
             </a:solidFill>
             <a:prstDash val="solid"/>
           </a:ln>
@@ -8248,7 +8248,7 @@
                   <a:schemeClr val="tx2"/>
                 </a:solidFill>
               </a:rPr>
-              <a:t>verifies, merges with the owner's limits, applies, acks</a:t>
+              <a:t>checks the signature, applies the owner's own limits, acts, reports back</a:t>
             </a:r>
             <a:endParaRPr lang="en-US" sz="1150" dirty="0"/>
           </a:p>
@@ -8281,7 +8281,7 @@
       </p:sp>
       <p:sp>
         <p:nvSpPr>
-          <p:cNvPr id="23" name="chain BATTERY · EV · HEAT"/>
+          <p:cNvPr id="23" name="chain BATTERY · CAR · HEAT"/>
           <p:cNvSpPr/>
           <p:nvPr/>
         </p:nvSpPr>
@@ -8321,11 +8321,11 @@
             <a:avLst/>
           </a:prstGeom>
           <a:solidFill>
-            <a:schemeClr val="accent5"/>
+            <a:schemeClr val="accent3"/>
           </a:solidFill>
           <a:ln w="12700">
             <a:solidFill>
-              <a:schemeClr val="accent5"/>
+              <a:schemeClr val="accent3"/>
             </a:solidFill>
             <a:prstDash val="solid"/>
           </a:ln>
@@ -8361,7 +8361,7 @@
                   <a:schemeClr val="tx1"/>
                 </a:solidFill>
               </a:rPr>
-              <a:t>BATTERY · EV · HEAT</a:t>
+              <a:t>BATTERY · CAR · HEAT</a:t>
             </a:r>
             <a:endParaRPr lang="en-US" sz="1300" dirty="0"/>
           </a:p>
@@ -8397,7 +8397,7 @@
                   <a:schemeClr val="tx2"/>
                 </a:solidFill>
               </a:rPr>
-              <a:t>a limit at the meter, never a setpoint</a:t>
+              <a:t>a limit on the meter, never a command to a device</a:t>
             </a:r>
             <a:endParaRPr lang="en-US" sz="1150" dirty="0"/>
           </a:p>
@@ -8437,7 +8437,7 @@
                   <a:schemeClr val="tx1"/>
                 </a:solidFill>
               </a:rPr>
-              <a:t>The signal names a limit at the grid connection point: import ceiling, export ceiling, export floor, target SoC. It never names a device or a register</a:t>
+              <a:t>The message names a limit for the whole house: take at most, give at most, give at least, be full by. It never names a device or a setting</a:t>
             </a:r>
             <a:endParaRPr lang="en-US" sz="1500" dirty="0"/>
           </a:p>
@@ -8455,7 +8455,7 @@
                   <a:schemeClr val="tx1"/>
                 </a:solidFill>
               </a:rPr>
-              <a:t>The owner's limits always win: minimum SoC, max current, opt-out. The house may answer partial or refused</a:t>
+              <a:t>The owner's own limits always win: battery reserve, charger current, opt-out. The house may answer partly, or no</a:t>
             </a:r>
             <a:endParaRPr lang="en-US" sz="1500" dirty="0"/>
           </a:p>
@@ -8473,7 +8473,7 @@
                   <a:schemeClr val="tx1"/>
                 </a:solidFill>
               </a:rPr>
-              <a:t>Four-hour maximum, enforced on the platform and again on the device; revert on window end or 120 s without heartbeat</a:t>
+              <a:t>Every message expires by itself, on the platform and again in the house. If the operator falls silent, the house is back to normal within two minutes</a:t>
             </a:r>
             <a:endParaRPr lang="en-US" sz="1500" dirty="0"/>
           </a:p>
@@ -8491,7 +8491,7 @@
                   <a:schemeClr val="tx1"/>
                 </a:solidFill>
               </a:rPr>
-              <a:t>Pay on the meter: limits are a yes or no per 15-minute interval on the DSO's own smart meter, so there is nothing to game</a:t>
+              <a:t>Paid on the meter: did the house stay under the limit in each 15-minute interval, yes or no, on the operator's own smart meter. Nothing to game</a:t>
             </a:r>
             <a:endParaRPr lang="en-US" sz="1500" dirty="0"/>
           </a:p>
@@ -9164,7 +9164,7 @@
                   <a:schemeClr val="tx1"/>
                 </a:solidFill>
               </a:rPr>
-              <a:t>Board: Vienna, 72 transformers, 272 households live, one of them real; the with/without curve</a:t>
+              <a:t>Board: Vienna, 72 street transformers, 272 households live, one of them real; with and without Gridzilla</a:t>
             </a:r>
             <a:endParaRPr lang="en-US" sz="1250" dirty="0"/>
           </a:p>
@@ -9182,7 +9182,7 @@
                   <a:schemeClr val="tx1"/>
                 </a:solidFill>
               </a:rPr>
-              <a:t>Board: the last DeepSeek decision: sense, decide, guard, signed signal</a:t>
+              <a:t>Board: the AI's last decision: what it saw, what it chose, the rule check, the signed message</a:t>
             </a:r>
             <a:endParaRPr lang="en-US" sz="1250" dirty="0"/>
           </a:p>
@@ -9200,7 +9200,7 @@
                   <a:schemeClr val="tx1"/>
                 </a:solidFill>
               </a:rPr>
-              <a:t>Board, Flattening tab: tonight's diet plan, Vienna then one street</a:t>
+              <a:t>Board, Flattening tab: tonight's plan for Vienna, then for one street</a:t>
             </a:r>
             <a:endParaRPr lang="en-US" sz="1250" dirty="0"/>
           </a:p>
@@ -9218,7 +9218,7 @@
                   <a:schemeClr val="tx1"/>
                 </a:solidFill>
               </a:rPr>
-              <a:t>Board, pin Blatnica: the real plant live, last ack verified</a:t>
+              <a:t>Board, pin Blatnica: the real plant live, last reply verified</a:t>
             </a:r>
             <a:endParaRPr lang="en-US" sz="1250" dirty="0"/>
           </a:p>
@@ -9236,7 +9236,7 @@
                   <a:schemeClr val="tx1"/>
                 </a:solidFill>
               </a:rPr>
-              <a:t>Board: pause the heartbeat, every house reverts</a:t>
+              <a:t>Board: pause the operator's heartbeat, every house goes back to normal</a:t>
             </a:r>
             <a:endParaRPr lang="en-US" sz="1250" dirty="0"/>
           </a:p>
@@ -9344,7 +9344,7 @@
                   <a:schemeClr val="tx1"/>
                 </a:solidFill>
               </a:rPr>
-              <a:t>What is real, what is modelled, and what the numbers mean</a:t>
+              <a:t>What is real, what is simulated, and what the numbers mean</a:t>
             </a:r>
             <a:endParaRPr lang="en-US" sz="3200" dirty="0"/>
           </a:p>
@@ -9475,7 +9475,7 @@
                   <a:schemeClr val="tx1"/>
                 </a:solidFill>
               </a:rPr>
-              <a:t>The control path: signed signal in, a Victron plant and a Viessmann heat pump move, verified acks come back</a:t>
+              <a:t>The whole path: a signed message goes out, a Victron plant and a Viessmann heat pump react, verified replies come back</a:t>
             </a:r>
             <a:endParaRPr lang="en-US" sz="1250" dirty="0"/>
           </a:p>
@@ -9493,7 +9493,7 @@
                   <a:schemeClr val="tx1"/>
                 </a:solidFill>
               </a:rPr>
-              <a:t>The flattening algorithm and the guard, running on the fleet every two grid hours</a:t>
+              <a:t>The planning and the rule check, running on the fleet every two hours</a:t>
             </a:r>
             <a:endParaRPr lang="en-US" sz="1250" dirty="0"/>
           </a:p>
@@ -9511,7 +9511,7 @@
                   <a:schemeClr val="tx1"/>
                 </a:solidFill>
               </a:rPr>
-              <a:t>Measured on streets with cars: 18-31 % off the evening peak, inside what published smart-charging and home-battery pilots report (3-6 kW per EV house, 1-2 kW per battery at the peak)</a:t>
+              <a:t>Measured on streets with cars: 18 to 31 % off the evening peak, in line with published smart-charging and home-battery trials (3 to 6 kW per car, 1 to 2 kW per battery at the peak)</a:t>
             </a:r>
             <a:endParaRPr lang="en-US" sz="1250" dirty="0"/>
           </a:p>
@@ -9602,7 +9602,7 @@
                 <a:ea typeface="Arial" pitchFamily="34" charset="-122"/>
                 <a:cs typeface="Arial" pitchFamily="34" charset="-120"/>
               </a:rPr>
-              <a:t>MODELLED</a:t>
+              <a:t>SIMULATED</a:t>
             </a:r>
             <a:endParaRPr lang="en-US" sz="1600" dirty="0"/>
           </a:p>
@@ -9642,7 +9642,7 @@
                   <a:schemeClr val="tx1"/>
                 </a:solidFill>
               </a:rPr>
-              <a:t>The fleet: 271 simulated households, each standing for 8 real ones: 2,184 program houses with 10-25 kWh batteries, 1,190 with an 11 kW charger needing 6-26 kWh a night</a:t>
+              <a:t>The fleet: 271 simulated households, each standing for 8 real ones: 2,184 houses with a 10 to 25 kWh battery, 1,190 of them with an 11 kW charger needing 6 to 26 kWh a night</a:t>
             </a:r>
             <a:endParaRPr lang="en-US" sz="1250" dirty="0"/>
           </a:p>
@@ -9660,7 +9660,7 @@
                   <a:schemeClr val="tx1"/>
                 </a:solidFill>
               </a:rPr>
-              <a:t>The "without" curve is the same houses with no signal: a car charges on 55 % of nights, arrivals spread over three hours, full power until full. No inflated coincidence</a:t>
+              <a:t>The "without" curve is the same houses left alone: a car charges on 55 % of nights, people come home over three hours, full power until full. Nothing inflated</a:t>
             </a:r>
             <a:endParaRPr lang="en-US" sz="1250" dirty="0"/>
           </a:p>
@@ -9678,7 +9678,7 @@
                   <a:schemeClr val="tx1"/>
                 </a:solidFill>
               </a:rPr>
-              <a:t>Program houses carry ~30 % of a street's evening load here: a 2030 picture, not a street today</a:t>
+              <a:t>These houses carry about 30 % of a street's evening load: a 2030 picture, not a street today</a:t>
             </a:r>
             <a:endParaRPr lang="en-US" sz="1250" dirty="0"/>
           </a:p>
@@ -10258,7 +10258,7 @@
                   <a:schemeClr val="tx1"/>
                 </a:solidFill>
               </a:rPr>
-              <a:t>A pilot street, a second vendor, a DSO that wants the signal</a:t>
+              <a:t>A pilot street, a second maker, a grid operator that wants the signal</a:t>
             </a:r>
             <a:endParaRPr lang="en-US" sz="5400" dirty="0"/>
           </a:p>
@@ -10296,7 +10296,7 @@
                   <a:schemeClr val="tx2"/>
                 </a:solidFill>
               </a:rPr>
-              <a:t>Enrolment bound to the meter point and operator login, two weeks. GoodWe agent on our own plant, one week.</a:t>
+              <a:t>Sign-up tied to the meter and the operator's login: two weeks. A GoodWe version on our own plant: one week.</a:t>
             </a:r>
             <a:endParaRPr lang="en-US" sz="2200" dirty="0"/>
           </a:p>
@@ -10310,7 +10310,7 @@
                   <a:schemeClr val="tx2"/>
                 </a:solidFill>
               </a:rPr>
-              <a:t>A ten-house pilot with a Slovak or Austrian DSO on one real transformer, this winter.</a:t>
+              <a:t>A ten-house pilot with a Slovak or Austrian grid operator on one real street transformer, this winter.</a:t>
             </a:r>
             <a:endParaRPr lang="en-US" sz="2200" dirty="0"/>
           </a:p>
@@ -10324,7 +10324,7 @@
                   <a:schemeClr val="tx2"/>
                 </a:solidFill>
               </a:rPr>
-              <a:t>The vision: streets that island on grid-forming inverters when the 22 kV line is gone, rationed by the same signal.</a:t>
+              <a:t>The vision: streets that keep their lights on from their own batteries when the line is gone, sharing fairly by the same signal.</a:t>
             </a:r>
             <a:endParaRPr lang="en-US" sz="2200" dirty="0"/>
           </a:p>

</xml_diff>

<commit_message>
Pitch at 4:30: tighter script, notes retimed, demo at 75 seconds
Co-Authored-By: Claude Fable 5.1 <noreply@anthropic.com>
</commit_message>
<xml_diff>
--- a/docs/Gridzilla-pitch.pptx
+++ b/docs/Gridzilla-pitch.pptx
@@ -121,32 +121,32 @@
   <p:extLst>
     <p:ext uri="{521415D9-36F7-43E2-AB2F-B90AF26B5E84}">
       <p14:sectionLst xmlns:p14="http://schemas.microsoft.com/office/powerpoint/2010/main">
-        <p14:section name="Opening" id="{ff7a16a9-a96c-4a02-1bd3-742946ad5373}">
+        <p14:section name="Opening" id="{57331f7b-bf0b-a477-304a-ac3fcc1c12d8}">
           <p14:sldIdLst>
             <p14:sldId id="256"/>
           </p14:sldIdLst>
         </p14:section>
-        <p14:section name="Why" id="{c51585fa-bc30-e42e-0cb5-3f446e4485c5}">
+        <p14:section name="Why" id="{7edc2212-c46d-cf69-f536-033ed9d1397c}">
           <p14:sldIdLst>
             <p14:sldId id="257"/>
           </p14:sldIdLst>
         </p14:section>
-        <p14:section name="What" id="{3a596f7c-0fc8-a157-0983-3a323be7059d}">
+        <p14:section name="What" id="{8384c3c5-e21c-57ab-da44-b7b9583da458}">
           <p14:sldIdLst>
             <p14:sldId id="258"/>
           </p14:sldIdLst>
         </p14:section>
-        <p14:section name="Demo" id="{5a054cfa-eb60-2e28-2af0-86a522f41e5f}">
+        <p14:section name="Demo" id="{a2cc7b3e-a988-31db-aa07-38432b121cf6}">
           <p14:sldIdLst>
             <p14:sldId id="260"/>
           </p14:sldIdLst>
         </p14:section>
-        <p14:section name="Close" id="{e348c19e-a9c1-f286-5591-ccfde031d52d}">
+        <p14:section name="Close" id="{288f01a1-f12f-01e6-feed-5ee2a7ce6b68}">
           <p14:sldIdLst>
             <p14:sldId id="262"/>
           </p14:sldIdLst>
         </p14:section>
-        <p14:section name="Appendix" id="{2fad0d07-1f15-83dc-d18e-4dd0ecd0550a}">
+        <p14:section name="Appendix" id="{8d5d9949-cdfa-4e7b-7903-06772bfbf7aa}">
           <p14:sldIdLst>
             <p14:sldId id="263"/>
             <p14:sldId id="264"/>
@@ -562,7 +562,7 @@
           <a:p>
             <a:r>
               <a:rPr lang="en-US" dirty="0"/>
-              <a:t>0:00-0:30. Click the speaker icon top right the moment the slide is up: 30 seconds of trailer, say nothing, let it land. After the hard cut, one line, deadpan: Now you probably wonder what the monster really is. Then next slide.</a:t>
+              <a:t>0:00-0:30. Click the speaker icon top right the moment the slide is up: 30 seconds of trailer, say nothing. After the hard cut, one line, deadpan: Now you probably wonder what the monster really is. Next slide.</a:t>
             </a:r>
             <a:endParaRPr lang="en-US" dirty="0"/>
           </a:p>
@@ -1178,7 +1178,7 @@
           <a:p>
             <a:r>
               <a:rPr lang="en-US" dirty="0"/>
-              <a:t>0:30-1:00. Three numbers, then the three failure modes. The point: the storage exists, the signal does not.</a:t>
+              <a:t>0:30-0:55. It is a grid signal that home batteries, cars and heat pumps follow. Europe's largest battery is in people's basements, and the grid can use none of it. Slovakia has no signal at all. Germany has a dimmer switch on one device. Ukraine had three gigawatt hours of home storage sitting idle through the blackouts. The storage exists. The signal does not.</a:t>
             </a:r>
             <a:endParaRPr lang="en-US" dirty="0"/>
           </a:p>
@@ -1266,7 +1266,7 @@
           <a:p>
             <a:r>
               <a:rPr lang="en-US" dirty="0"/>
-              <a:t>1:00-1:45. Walk the chain left to right. Stress: limits not setpoints, owner wins, device enforces time bounds itself, settlement on the meter.</a:t>
+              <a:t>0:55-1:35. One signed message. The operator says: this street, next three hours, take at most three kilowatts per house. Never discharge now, never a setting. The house decides how: battery first, car second, hot water third. The owner's limits always win. If the operator goes silent, every house is back to normal in two minutes. The meter checks it, the meter pays it. An AI proposes every fifteen minutes, thirty lines of rules decide, the platform signs.</a:t>
             </a:r>
             <a:endParaRPr lang="en-US" dirty="0"/>
           </a:p>
@@ -1354,7 +1354,7 @@
           <a:p>
             <a:r>
               <a:rPr lang="en-US" dirty="0"/>
-              <a:t>1:45-2:30. Gridzilla eats peaks. Every street, every evening. At six the cars come home and the transformer would go to a hundred and ten percent. With Gridzilla it stays at seventy. The cars still charge, just not all at dinner: a car plugged in at six trickles through the evening and fills up at two in the morning, full by seven. The batteries eat the dinner spike. The sun at noon goes into the batteries instead of the feeder. Nobody at home notices. And the operator never buys that bigger transformer. Planned every two hours from the real weather forecast, for the whole city, by thirty lines of code, not by the AI. If asked how: valley filling, the textbook method.</a:t>
+              <a:t>1:35-2:15. Gridzilla eats peaks. Every street, every evening. At six the cars come home and the transformer would go to a hundred and ten percent. With Gridzilla it stays at seventy. The cars still charge, just not at dinner: plugged in at six, trickle through the evening, full by seven in the morning. The batteries eat the dinner spike, the noon sun charges them. Nobody at home notices. The operator never buys the bigger transformer. Planned every two hours from the real weather, by thirty lines of code, not by the AI.</a:t>
             </a:r>
             <a:endParaRPr lang="en-US" dirty="0"/>
           </a:p>
@@ -1442,7 +1442,7 @@
           <a:p>
             <a:r>
               <a:rPr lang="en-US" dirty="0"/>
-              <a:t>2:30-4:00. Alt-tab: deck, Gridzilla board, VRM. Pin Blatnica before the SUPPORT step so the curve stays on our transformer. VRM is the independent witness: Victron's own portal showing the setpoint change. If the venue network dies, show the recorded video.</a:t>
+              <a:t>2:15-3:30. Alt-tab to the board, talk while clicking. VIENNA: seventy-two transformers, two hundred seventy-two households, one of them real; blue with, grey without, orange eaten. Tiles: what the AI saw, what it chose, the rule check, the signed message. Flattening tab, VIENNA then one street: tonight's plan. Pin Blatnica: the real plant live, last reply verified. Autopilot, pause heartbeat: the operator goes dark, every house goes back to normal. Resume. If behind, skip Blatnica, keep the heartbeat.</a:t>
             </a:r>
             <a:endParaRPr lang="en-US" dirty="0"/>
           </a:p>
@@ -1530,7 +1530,7 @@
           <a:p>
             <a:r>
               <a:rPr lang="en-US" dirty="0"/>
-              <a:t>4:00-4:30. Say it before the jury asks: the signal path and the algorithm are real, the fleet is simulated, and the counterfactual is honest: same cars, same batteries, realistic charging coincidence. The street numbers sit inside published pilots; the city number is that times 2,184 enrolled houses.</a:t>
+              <a:t>3:30-3:55. Real: the whole path, a Victron plant and a Viessmann heat pump reacting to a signed message, the planning on the fleet. Simulated: the fleet, two thousand houses, same cars with and without, realistic charging. Measured tonight: one street thirty-one percent off its peak, Vienna with two thousand houses five megawatts off, a street where no car charged, zero.</a:t>
             </a:r>
             <a:endParaRPr lang="en-US" dirty="0"/>
           </a:p>
@@ -1618,7 +1618,7 @@
           <a:p>
             <a:r>
               <a:rPr lang="en-US" dirty="0"/>
-              <a:t>4:30-5:00. The ask is a transformer to pilot on. Stop talking, take questions.</a:t>
+              <a:t>3:55-4:20. We need one street transformer to pilot on, this winter. Sign-up is two weeks, a second maker one week, we own the plant. After that: streets that keep their lights on from their own batteries when the line is gone. Gridzilla. It eats peaks for breakfast. Thank you.</a:t>
             </a:r>
             <a:endParaRPr lang="en-US" dirty="0"/>
           </a:p>
@@ -9124,7 +9124,7 @@
                   <a:schemeClr val="accent1"/>
                 </a:solidFill>
               </a:rPr>
-              <a:t>Ninety seconds, alt-tab</a:t>
+              <a:t>75 seconds, alt-tab</a:t>
             </a:r>
             <a:endParaRPr lang="en-US" sz="1500" dirty="0"/>
           </a:p>

</xml_diff>

<commit_message>
Idea slide wording: the operator asks, the house decides, the owner can always say no
Co-Authored-By: Claude Fable 5.1 <noreply@anthropic.com>
</commit_message>
<xml_diff>
--- a/docs/Gridzilla-pitch.pptx
+++ b/docs/Gridzilla-pitch.pptx
@@ -121,32 +121,32 @@
   <p:extLst>
     <p:ext uri="{521415D9-36F7-43E2-AB2F-B90AF26B5E84}">
       <p14:sectionLst xmlns:p14="http://schemas.microsoft.com/office/powerpoint/2010/main">
-        <p14:section name="Opening" id="{57331f7b-bf0b-a477-304a-ac3fcc1c12d8}">
+        <p14:section name="Opening" id="{95b963a0-6608-fe43-fc21-5eed26ffab82}">
           <p14:sldIdLst>
             <p14:sldId id="256"/>
           </p14:sldIdLst>
         </p14:section>
-        <p14:section name="Why" id="{7edc2212-c46d-cf69-f536-033ed9d1397c}">
+        <p14:section name="Why" id="{d442a1ad-ab6b-341c-8779-1ecb40835b75}">
           <p14:sldIdLst>
             <p14:sldId id="257"/>
           </p14:sldIdLst>
         </p14:section>
-        <p14:section name="What" id="{8384c3c5-e21c-57ab-da44-b7b9583da458}">
+        <p14:section name="What" id="{bed23466-8cb6-253c-8a3e-26813ce4ac91}">
           <p14:sldIdLst>
             <p14:sldId id="258"/>
           </p14:sldIdLst>
         </p14:section>
-        <p14:section name="Demo" id="{a2cc7b3e-a988-31db-aa07-38432b121cf6}">
+        <p14:section name="Demo" id="{74bd4345-e79c-8866-1409-0afd11fa58c6}">
           <p14:sldIdLst>
             <p14:sldId id="260"/>
           </p14:sldIdLst>
         </p14:section>
-        <p14:section name="Close" id="{288f01a1-f12f-01e6-feed-5ee2a7ce6b68}">
+        <p14:section name="Close" id="{7013f5e5-a2b9-c7f8-9b8a-25a5a4aa14e5}">
           <p14:sldIdLst>
             <p14:sldId id="262"/>
           </p14:sldIdLst>
         </p14:section>
-        <p14:section name="Appendix" id="{8d5d9949-cdfa-4e7b-7903-06772bfbf7aa}">
+        <p14:section name="Appendix" id="{aa0508e9-e2dd-01be-8e2d-1c60ef078509}">
           <p14:sldIdLst>
             <p14:sldId id="263"/>
             <p14:sldId id="264"/>
@@ -1266,7 +1266,7 @@
           <a:p>
             <a:r>
               <a:rPr lang="en-US" dirty="0"/>
-              <a:t>0:55-1:35. One signed message. The operator says: this street, next three hours, take at most three kilowatts per house. Never discharge now, never a setting. The house decides how: battery first, car second, hot water third. The owner's limits always win. If the operator goes silent, every house is back to normal in two minutes. The meter checks it, the meter pays it. An AI proposes every fifteen minutes, thirty lines of rules decide, the platform signs.</a:t>
+              <a:t>0:55-1:35. One signed message. The operator says: this street, next three hours, take at most three kilowatts per house. Never discharge now, never a setting. The house decides how: battery first, car second, hot water third. The owner can always say no. If the operator goes silent, every house is back to normal in two minutes. The smart meter sees whether the house kept the limit, and that is what gets paid. An AI proposes every fifteen minutes, thirty lines of rules decide, the platform signs.</a:t>
             </a:r>
             <a:endParaRPr lang="en-US" dirty="0"/>
           </a:p>

</xml_diff>

<commit_message>
Idea slide: sell the message, one line of trust, safety rails to Q&A
Co-Authored-By: Claude Fable 5.1 <noreply@anthropic.com>
</commit_message>
<xml_diff>
--- a/docs/Gridzilla-pitch.pptx
+++ b/docs/Gridzilla-pitch.pptx
@@ -121,32 +121,32 @@
   <p:extLst>
     <p:ext uri="{521415D9-36F7-43E2-AB2F-B90AF26B5E84}">
       <p14:sectionLst xmlns:p14="http://schemas.microsoft.com/office/powerpoint/2010/main">
-        <p14:section name="Opening" id="{95b963a0-6608-fe43-fc21-5eed26ffab82}">
+        <p14:section name="Opening" id="{baa05a93-0e22-689c-3d21-ddd8221327b1}">
           <p14:sldIdLst>
             <p14:sldId id="256"/>
           </p14:sldIdLst>
         </p14:section>
-        <p14:section name="Why" id="{d442a1ad-ab6b-341c-8779-1ecb40835b75}">
+        <p14:section name="Why" id="{b8edbb70-c993-97dc-1c32-44f62c45559d}">
           <p14:sldIdLst>
             <p14:sldId id="257"/>
           </p14:sldIdLst>
         </p14:section>
-        <p14:section name="What" id="{bed23466-8cb6-253c-8a3e-26813ce4ac91}">
+        <p14:section name="What" id="{4acfc083-2e49-36e1-69f4-43db1d2c550b}">
           <p14:sldIdLst>
             <p14:sldId id="258"/>
           </p14:sldIdLst>
         </p14:section>
-        <p14:section name="Demo" id="{74bd4345-e79c-8866-1409-0afd11fa58c6}">
+        <p14:section name="Demo" id="{5801dfe3-ba18-1485-963d-9294b1a08b92}">
           <p14:sldIdLst>
             <p14:sldId id="260"/>
           </p14:sldIdLst>
         </p14:section>
-        <p14:section name="Close" id="{7013f5e5-a2b9-c7f8-9b8a-25a5a4aa14e5}">
+        <p14:section name="Close" id="{6011225e-fa49-d8bd-4d17-65f8efc32d02}">
           <p14:sldIdLst>
             <p14:sldId id="262"/>
           </p14:sldIdLst>
         </p14:section>
-        <p14:section name="Appendix" id="{aa0508e9-e2dd-01be-8e2d-1c60ef078509}">
+        <p14:section name="Appendix" id="{06aa693b-2826-69aa-66d6-7c1be36ed280}">
           <p14:sldIdLst>
             <p14:sldId id="263"/>
             <p14:sldId id="264"/>
@@ -1266,7 +1266,7 @@
           <a:p>
             <a:r>
               <a:rPr lang="en-US" dirty="0"/>
-              <a:t>0:55-1:35. One signed message. The operator says: this street, next three hours, take at most three kilowatts per house. Never discharge now, never a setting. The house decides how: battery first, car second, hot water third. The owner can always say no. If the operator goes silent, every house is back to normal in two minutes. The smart meter sees whether the house kept the limit, and that is what gets paid. An AI proposes every fifteen minutes, thirty lines of rules decide, the platform signs.</a:t>
+              <a:t>0:55-1:35. One message does the whole job. This street, next three hours, take at most three kilowatts per house. Every house under it reads the same line: the Victron, the GoodWe, the Viessmann, the car charger. Each one sorts it out by itself: battery first, car second, hot water third. Same message at noon: give at most two, and the sun goes into the batteries instead of the feeder. Same message after an outage: be full by seven, and the street refills without a second blackout. The operator only ever sends a limit, never a command, which is why an operator can sign up for it tomorrow. An AI writes the message every fifteen minutes, thirty lines of rules check it, the platform signs it.</a:t>
             </a:r>
             <a:endParaRPr lang="en-US" dirty="0"/>
           </a:p>

</xml_diff>